<commit_message>
Trainer-Review: M22-Quiz + freigegeben, aktualisierte Decks/Handbücher/Workbooks
content: M01/M08/M22 Sec-4/5/7-Sync; M22 Frontmatter (Dauer 120, Bloom 3–5,
Status freigegeben). lib/quizzes.ts: M22-Quiz (8 Fragen) ergänzt.

Downloads aktualisiert: 8 Teilnehmer-Workbooks (M01/M03/M04/M07/M08/M10/M12/M22),
22 Präsentationen (Trainer-Notizen/Agenda/Anker-Folien) und 8 Trainerhandbücher
– alle Trainer-/Präsentations-Assets rollengeschützt unter protected-downloads/.

Co-Authored-By: Claude Opus 4 <noreply@anthropic.com>
</commit_message>
<xml_diff>
--- a/protected-downloads/praesentation/M01.pptx
+++ b/protected-downloads/praesentation/M01.pptx
@@ -8,12 +8,12 @@
     <p:sldId id="256" r:id="rId7"/>
     <p:sldId id="257" r:id="rId8"/>
     <p:sldId id="258" r:id="rId9"/>
-    <p:sldId id="259" r:id="rId10"/>
-    <p:sldId id="260" r:id="rId11"/>
-    <p:sldId id="261" r:id="rId12"/>
-    <p:sldId id="262" r:id="rId13"/>
-    <p:sldId id="263" r:id="rId14"/>
-    <p:sldId id="264" r:id="rId15"/>
+    <p:sldId id="259" r:id="rId11"/>
+    <p:sldId id="260" r:id="rId12"/>
+    <p:sldId id="261" r:id="rId13"/>
+    <p:sldId id="262" r:id="rId14"/>
+    <p:sldId id="263" r:id="rId15"/>
+    <p:sldId id="264" r:id="rId16"/>
   </p:sldIdLst>
   <p:sldSz cx="12188952" cy="6858000" type="screen4x3"/>
   <p:notesSz cx="6858000" cy="9144000"/>
@@ -113,6 +113,571 @@
     </a:lvl9pPr>
   </p:defaultTextStyle>
 </p:presentation>
+</file>
+
+<file path=ppt/notesMasters/notesMaster1.xml><?xml version="1.0" encoding="utf-8"?>
+<p:notesMaster xmlns:a="http://schemas.openxmlformats.org/drawingml/2006/main" xmlns:p="http://schemas.openxmlformats.org/presentationml/2006/main" xmlns:r="http://schemas.openxmlformats.org/officeDocument/2006/relationships">
+  <p:cSld>
+    <p:bg>
+      <p:bgRef idx="1001">
+        <a:schemeClr val="bg1"/>
+      </p:bgRef>
+    </p:bg>
+    <p:spTree>
+      <p:nvGrpSpPr>
+        <p:cNvPr id="1" name=""/>
+        <p:cNvGrpSpPr/>
+        <p:nvPr/>
+      </p:nvGrpSpPr>
+      <p:grpSpPr>
+        <a:xfrm>
+          <a:off x="0" y="0"/>
+          <a:ext cx="0" cy="0"/>
+          <a:chOff x="0" y="0"/>
+          <a:chExt cx="0" cy="0"/>
+        </a:xfrm>
+      </p:grpSpPr>
+      <p:sp>
+        <p:nvSpPr>
+          <p:cNvPr id="2" name="Header Placeholder 1"/>
+          <p:cNvSpPr>
+            <a:spLocks noGrp="1"/>
+          </p:cNvSpPr>
+          <p:nvPr>
+            <p:ph type="hdr" sz="quarter"/>
+          </p:nvPr>
+        </p:nvSpPr>
+        <p:spPr>
+          <a:xfrm>
+            <a:off x="0" y="0"/>
+            <a:ext cx="2971800" cy="457200"/>
+          </a:xfrm>
+          <a:prstGeom prst="rect">
+            <a:avLst/>
+          </a:prstGeom>
+        </p:spPr>
+        <p:txBody>
+          <a:bodyPr vert="horz" lIns="91440" tIns="45720" rIns="91440" bIns="45720" rtlCol="0"/>
+          <a:lstStyle>
+            <a:lvl1pPr algn="l">
+              <a:defRPr sz="1200"/>
+            </a:lvl1pPr>
+          </a:lstStyle>
+          <a:p>
+            <a:endParaRPr lang="en-US"/>
+          </a:p>
+        </p:txBody>
+      </p:sp>
+      <p:sp>
+        <p:nvSpPr>
+          <p:cNvPr id="3" name="Date Placeholder 2"/>
+          <p:cNvSpPr>
+            <a:spLocks noGrp="1"/>
+          </p:cNvSpPr>
+          <p:nvPr>
+            <p:ph type="dt" idx="1"/>
+          </p:nvPr>
+        </p:nvSpPr>
+        <p:spPr>
+          <a:xfrm>
+            <a:off x="3884613" y="0"/>
+            <a:ext cx="2971800" cy="457200"/>
+          </a:xfrm>
+          <a:prstGeom prst="rect">
+            <a:avLst/>
+          </a:prstGeom>
+        </p:spPr>
+        <p:txBody>
+          <a:bodyPr vert="horz" lIns="91440" tIns="45720" rIns="91440" bIns="45720" rtlCol="0"/>
+          <a:lstStyle>
+            <a:lvl1pPr algn="r">
+              <a:defRPr sz="1200"/>
+            </a:lvl1pPr>
+          </a:lstStyle>
+          <a:p>
+            <a:fld id="{0F89C1C7-3DCD-1040-A9CF-14679D8B5DDD}" type="datetimeFigureOut">
+              <a:rPr lang="en-US" smtClean="0"/>
+              <a:t>10/17/16</a:t>
+            </a:fld>
+            <a:endParaRPr lang="en-US"/>
+          </a:p>
+        </p:txBody>
+      </p:sp>
+      <p:sp>
+        <p:nvSpPr>
+          <p:cNvPr id="4" name="Slide Image Placeholder 3"/>
+          <p:cNvSpPr>
+            <a:spLocks noGrp="1" noRot="1" noChangeAspect="1"/>
+          </p:cNvSpPr>
+          <p:nvPr>
+            <p:ph type="sldImg" idx="2"/>
+          </p:nvPr>
+        </p:nvSpPr>
+        <p:spPr>
+          <a:xfrm>
+            <a:off x="1143000" y="685800"/>
+            <a:ext cx="4572000" cy="3429000"/>
+          </a:xfrm>
+          <a:prstGeom prst="rect">
+            <a:avLst/>
+          </a:prstGeom>
+          <a:noFill/>
+          <a:ln w="12700">
+            <a:solidFill>
+              <a:prstClr val="black"/>
+            </a:solidFill>
+          </a:ln>
+        </p:spPr>
+        <p:txBody>
+          <a:bodyPr vert="horz" lIns="91440" tIns="45720" rIns="91440" bIns="45720" rtlCol="0" anchor="ctr"/>
+          <a:lstStyle/>
+          <a:p>
+            <a:endParaRPr lang="en-US"/>
+          </a:p>
+        </p:txBody>
+      </p:sp>
+      <p:sp>
+        <p:nvSpPr>
+          <p:cNvPr id="5" name="Notes Placeholder 4"/>
+          <p:cNvSpPr>
+            <a:spLocks noGrp="1"/>
+          </p:cNvSpPr>
+          <p:nvPr>
+            <p:ph type="body" sz="quarter" idx="3"/>
+          </p:nvPr>
+        </p:nvSpPr>
+        <p:spPr>
+          <a:xfrm>
+            <a:off x="685800" y="4343400"/>
+            <a:ext cx="5486400" cy="4114800"/>
+          </a:xfrm>
+          <a:prstGeom prst="rect">
+            <a:avLst/>
+          </a:prstGeom>
+        </p:spPr>
+        <p:txBody>
+          <a:bodyPr vert="horz" lIns="91440" tIns="45720" rIns="91440" bIns="45720" rtlCol="0"/>
+          <a:lstStyle/>
+          <a:p>
+            <a:pPr lvl="0"/>
+            <a:r>
+              <a:rPr lang="en-US" smtClean="0"/>
+              <a:t>Click to edit Master text styles</a:t>
+            </a:r>
+          </a:p>
+          <a:p>
+            <a:pPr lvl="1"/>
+            <a:r>
+              <a:rPr lang="en-US" smtClean="0"/>
+              <a:t>Second level</a:t>
+            </a:r>
+          </a:p>
+          <a:p>
+            <a:pPr lvl="2"/>
+            <a:r>
+              <a:rPr lang="en-US" smtClean="0"/>
+              <a:t>Third level</a:t>
+            </a:r>
+          </a:p>
+          <a:p>
+            <a:pPr lvl="3"/>
+            <a:r>
+              <a:rPr lang="en-US" smtClean="0"/>
+              <a:t>Fourth level</a:t>
+            </a:r>
+          </a:p>
+          <a:p>
+            <a:pPr lvl="4"/>
+            <a:r>
+              <a:rPr lang="en-US" smtClean="0"/>
+              <a:t>Fifth level</a:t>
+            </a:r>
+            <a:endParaRPr lang="en-US"/>
+          </a:p>
+        </p:txBody>
+      </p:sp>
+      <p:sp>
+        <p:nvSpPr>
+          <p:cNvPr id="6" name="Footer Placeholder 5"/>
+          <p:cNvSpPr>
+            <a:spLocks noGrp="1"/>
+          </p:cNvSpPr>
+          <p:nvPr>
+            <p:ph type="ftr" sz="quarter" idx="4"/>
+          </p:nvPr>
+        </p:nvSpPr>
+        <p:spPr>
+          <a:xfrm>
+            <a:off x="0" y="8685213"/>
+            <a:ext cx="2971800" cy="457200"/>
+          </a:xfrm>
+          <a:prstGeom prst="rect">
+            <a:avLst/>
+          </a:prstGeom>
+        </p:spPr>
+        <p:txBody>
+          <a:bodyPr vert="horz" lIns="91440" tIns="45720" rIns="91440" bIns="45720" rtlCol="0" anchor="b"/>
+          <a:lstStyle>
+            <a:lvl1pPr algn="l">
+              <a:defRPr sz="1200"/>
+            </a:lvl1pPr>
+          </a:lstStyle>
+          <a:p>
+            <a:endParaRPr lang="en-US"/>
+          </a:p>
+        </p:txBody>
+      </p:sp>
+      <p:sp>
+        <p:nvSpPr>
+          <p:cNvPr id="7" name="Slide Number Placeholder 6"/>
+          <p:cNvSpPr>
+            <a:spLocks noGrp="1"/>
+          </p:cNvSpPr>
+          <p:nvPr>
+            <p:ph type="sldNum" sz="quarter" idx="5"/>
+          </p:nvPr>
+        </p:nvSpPr>
+        <p:spPr>
+          <a:xfrm>
+            <a:off x="3884613" y="8685213"/>
+            <a:ext cx="2971800" cy="457200"/>
+          </a:xfrm>
+          <a:prstGeom prst="rect">
+            <a:avLst/>
+          </a:prstGeom>
+        </p:spPr>
+        <p:txBody>
+          <a:bodyPr vert="horz" lIns="91440" tIns="45720" rIns="91440" bIns="45720" rtlCol="0" anchor="b"/>
+          <a:lstStyle>
+            <a:lvl1pPr algn="r">
+              <a:defRPr sz="1200"/>
+            </a:lvl1pPr>
+          </a:lstStyle>
+          <a:p>
+            <a:fld id="{BB5E49A5-4136-284D-997B-48E1D791AD67}" type="slidenum">
+              <a:rPr lang="en-US" smtClean="0"/>
+              <a:t>‹#›</a:t>
+            </a:fld>
+            <a:endParaRPr lang="en-US"/>
+          </a:p>
+        </p:txBody>
+      </p:sp>
+    </p:spTree>
+    <p:extLst>
+      <p:ext uri="{BB962C8B-B14F-4D97-AF65-F5344CB8AC3E}">
+        <p14:creationId xmlns:p14="http://schemas.microsoft.com/office/powerpoint/2010/main" val="2623252185"/>
+      </p:ext>
+    </p:extLst>
+  </p:cSld>
+  <p:clrMap bg1="lt1" tx1="dk1" bg2="lt2" tx2="dk2" accent1="accent1" accent2="accent2" accent3="accent3" accent4="accent4" accent5="accent5" accent6="accent6" hlink="hlink" folHlink="folHlink"/>
+  <p:notesStyle>
+    <a:lvl1pPr marL="0" algn="l" defTabSz="457200" rtl="0" eaLnBrk="1" latinLnBrk="0" hangingPunct="1">
+      <a:defRPr sz="1200" kern="1200">
+        <a:solidFill>
+          <a:schemeClr val="tx1"/>
+        </a:solidFill>
+        <a:latin typeface="+mn-lt"/>
+        <a:ea typeface="+mn-ea"/>
+        <a:cs typeface="+mn-cs"/>
+      </a:defRPr>
+    </a:lvl1pPr>
+    <a:lvl2pPr marL="457200" algn="l" defTabSz="457200" rtl="0" eaLnBrk="1" latinLnBrk="0" hangingPunct="1">
+      <a:defRPr sz="1200" kern="1200">
+        <a:solidFill>
+          <a:schemeClr val="tx1"/>
+        </a:solidFill>
+        <a:latin typeface="+mn-lt"/>
+        <a:ea typeface="+mn-ea"/>
+        <a:cs typeface="+mn-cs"/>
+      </a:defRPr>
+    </a:lvl2pPr>
+    <a:lvl3pPr marL="914400" algn="l" defTabSz="457200" rtl="0" eaLnBrk="1" latinLnBrk="0" hangingPunct="1">
+      <a:defRPr sz="1200" kern="1200">
+        <a:solidFill>
+          <a:schemeClr val="tx1"/>
+        </a:solidFill>
+        <a:latin typeface="+mn-lt"/>
+        <a:ea typeface="+mn-ea"/>
+        <a:cs typeface="+mn-cs"/>
+      </a:defRPr>
+    </a:lvl3pPr>
+    <a:lvl4pPr marL="1371600" algn="l" defTabSz="457200" rtl="0" eaLnBrk="1" latinLnBrk="0" hangingPunct="1">
+      <a:defRPr sz="1200" kern="1200">
+        <a:solidFill>
+          <a:schemeClr val="tx1"/>
+        </a:solidFill>
+        <a:latin typeface="+mn-lt"/>
+        <a:ea typeface="+mn-ea"/>
+        <a:cs typeface="+mn-cs"/>
+      </a:defRPr>
+    </a:lvl4pPr>
+    <a:lvl5pPr marL="1828800" algn="l" defTabSz="457200" rtl="0" eaLnBrk="1" latinLnBrk="0" hangingPunct="1">
+      <a:defRPr sz="1200" kern="1200">
+        <a:solidFill>
+          <a:schemeClr val="tx1"/>
+        </a:solidFill>
+        <a:latin typeface="+mn-lt"/>
+        <a:ea typeface="+mn-ea"/>
+        <a:cs typeface="+mn-cs"/>
+      </a:defRPr>
+    </a:lvl5pPr>
+    <a:lvl6pPr marL="2286000" algn="l" defTabSz="457200" rtl="0" eaLnBrk="1" latinLnBrk="0" hangingPunct="1">
+      <a:defRPr sz="1200" kern="1200">
+        <a:solidFill>
+          <a:schemeClr val="tx1"/>
+        </a:solidFill>
+        <a:latin typeface="+mn-lt"/>
+        <a:ea typeface="+mn-ea"/>
+        <a:cs typeface="+mn-cs"/>
+      </a:defRPr>
+    </a:lvl6pPr>
+    <a:lvl7pPr marL="2743200" algn="l" defTabSz="457200" rtl="0" eaLnBrk="1" latinLnBrk="0" hangingPunct="1">
+      <a:defRPr sz="1200" kern="1200">
+        <a:solidFill>
+          <a:schemeClr val="tx1"/>
+        </a:solidFill>
+        <a:latin typeface="+mn-lt"/>
+        <a:ea typeface="+mn-ea"/>
+        <a:cs typeface="+mn-cs"/>
+      </a:defRPr>
+    </a:lvl7pPr>
+    <a:lvl8pPr marL="3200400" algn="l" defTabSz="457200" rtl="0" eaLnBrk="1" latinLnBrk="0" hangingPunct="1">
+      <a:defRPr sz="1200" kern="1200">
+        <a:solidFill>
+          <a:schemeClr val="tx1"/>
+        </a:solidFill>
+        <a:latin typeface="+mn-lt"/>
+        <a:ea typeface="+mn-ea"/>
+        <a:cs typeface="+mn-cs"/>
+      </a:defRPr>
+    </a:lvl8pPr>
+    <a:lvl9pPr marL="3657600" algn="l" defTabSz="457200" rtl="0" eaLnBrk="1" latinLnBrk="0" hangingPunct="1">
+      <a:defRPr sz="1200" kern="1200">
+        <a:solidFill>
+          <a:schemeClr val="tx1"/>
+        </a:solidFill>
+        <a:latin typeface="+mn-lt"/>
+        <a:ea typeface="+mn-ea"/>
+        <a:cs typeface="+mn-cs"/>
+      </a:defRPr>
+    </a:lvl9pPr>
+  </p:notesStyle>
+</p:notesMaster>
+</file>
+
+<file path=ppt/notesSlides/notesSlide1.xml><?xml version="1.0" encoding="utf-8"?>
+<p:notes xmlns:a="http://schemas.openxmlformats.org/drawingml/2006/main" xmlns:p="http://schemas.openxmlformats.org/presentationml/2006/main" xmlns:r="http://schemas.openxmlformats.org/officeDocument/2006/relationships">
+  <p:cSld>
+    <p:spTree>
+      <p:nvGrpSpPr>
+        <p:cNvPr id="1" name=""/>
+        <p:cNvGrpSpPr/>
+        <p:nvPr/>
+      </p:nvGrpSpPr>
+      <p:grpSpPr>
+        <a:xfrm>
+          <a:off x="0" y="0"/>
+          <a:ext cx="0" cy="0"/>
+          <a:chOff x="0" y="0"/>
+          <a:chExt cx="0" cy="0"/>
+        </a:xfrm>
+      </p:grpSpPr>
+      <p:sp>
+        <p:nvSpPr>
+          <p:cNvPr id="2" name="Slide Image Placeholder 1"/>
+          <p:cNvSpPr>
+            <a:spLocks noGrp="1"/>
+          </p:cNvSpPr>
+          <p:nvPr>
+            <p:ph type="sldImg" idx="2"/>
+          </p:nvPr>
+        </p:nvSpPr>
+        <p:spPr/>
+      </p:sp>
+      <p:sp>
+        <p:nvSpPr>
+          <p:cNvPr id="3" name="Notes Placeholder 2"/>
+          <p:cNvSpPr>
+            <a:spLocks noGrp="1"/>
+          </p:cNvSpPr>
+          <p:nvPr>
+            <p:ph type="body" idx="3" sz="quarter"/>
+          </p:nvPr>
+        </p:nvSpPr>
+        <p:spPr/>
+        <p:txBody>
+          <a:bodyPr/>
+          <a:lstStyle/>
+          <a:p>
+            <a:r>
+              <a:t>Siehe Trainerhandbuch (Sektion 3) für Moderationshinweise, Timing und erwartete Teilnehmerreaktionen.</a:t>
+            </a:r>
+          </a:p>
+        </p:txBody>
+      </p:sp>
+      <p:sp>
+        <p:nvSpPr>
+          <p:cNvPr id="4" name="Slide Number Placeholder 3"/>
+          <p:cNvSpPr>
+            <a:spLocks noGrp="1"/>
+          </p:cNvSpPr>
+          <p:nvPr>
+            <p:ph type="sldNum" idx="5" sz="quarter"/>
+          </p:nvPr>
+        </p:nvSpPr>
+        <p:spPr/>
+      </p:sp>
+    </p:spTree>
+  </p:cSld>
+  <p:clrMapOvr>
+    <a:masterClrMapping/>
+  </p:clrMapOvr>
+</p:notes>
+</file>
+
+<file path=ppt/notesSlides/notesSlide2.xml><?xml version="1.0" encoding="utf-8"?>
+<p:notes xmlns:a="http://schemas.openxmlformats.org/drawingml/2006/main" xmlns:p="http://schemas.openxmlformats.org/presentationml/2006/main" xmlns:r="http://schemas.openxmlformats.org/officeDocument/2006/relationships">
+  <p:cSld>
+    <p:spTree>
+      <p:nvGrpSpPr>
+        <p:cNvPr id="1" name=""/>
+        <p:cNvGrpSpPr/>
+        <p:nvPr/>
+      </p:nvGrpSpPr>
+      <p:grpSpPr>
+        <a:xfrm>
+          <a:off x="0" y="0"/>
+          <a:ext cx="0" cy="0"/>
+          <a:chOff x="0" y="0"/>
+          <a:chExt cx="0" cy="0"/>
+        </a:xfrm>
+      </p:grpSpPr>
+      <p:sp>
+        <p:nvSpPr>
+          <p:cNvPr id="2" name="Slide Image Placeholder 1"/>
+          <p:cNvSpPr>
+            <a:spLocks noGrp="1"/>
+          </p:cNvSpPr>
+          <p:nvPr>
+            <p:ph type="sldImg" idx="2"/>
+          </p:nvPr>
+        </p:nvSpPr>
+        <p:spPr/>
+      </p:sp>
+      <p:sp>
+        <p:nvSpPr>
+          <p:cNvPr id="3" name="Notes Placeholder 2"/>
+          <p:cNvSpPr>
+            <a:spLocks noGrp="1"/>
+          </p:cNvSpPr>
+          <p:nvPr>
+            <p:ph type="body" idx="3" sz="quarter"/>
+          </p:nvPr>
+        </p:nvSpPr>
+        <p:spPr/>
+        <p:txBody>
+          <a:bodyPr/>
+          <a:lstStyle/>
+          <a:p>
+            <a:r>
+              <a:t>AB-2 Musterlösung (Trainer-Version)</a:t>
+            </a:r>
+          </a:p>
+          <a:p>
+            <a:r>
+              <a:t>Trainer-Hinweis Anlagendeckung II: Langfristiges FK = Bankverbindlichkeiten (1.580) abzgl. kurzfristigem Anteil (340) = 1.240 TEUR + Gesellschafterdarlehen 680 TEUR. Ohne Rangrücktrittsvertrag beim Gesellschafterdarlehen: (802 + 1.240) / 2.400 = 84,3 % → Gelb. Wichtiger Nachfragepunkt im Kundengespräch!</a:t>
+            </a:r>
+          </a:p>
+        </p:txBody>
+      </p:sp>
+      <p:sp>
+        <p:nvSpPr>
+          <p:cNvPr id="4" name="Slide Number Placeholder 3"/>
+          <p:cNvSpPr>
+            <a:spLocks noGrp="1"/>
+          </p:cNvSpPr>
+          <p:nvPr>
+            <p:ph type="sldNum" idx="5" sz="quarter"/>
+          </p:nvPr>
+        </p:nvSpPr>
+        <p:spPr/>
+      </p:sp>
+    </p:spTree>
+  </p:cSld>
+  <p:clrMapOvr>
+    <a:masterClrMapping/>
+  </p:clrMapOvr>
+</p:notes>
+</file>
+
+<file path=ppt/notesSlides/notesSlide3.xml><?xml version="1.0" encoding="utf-8"?>
+<p:notes xmlns:a="http://schemas.openxmlformats.org/drawingml/2006/main" xmlns:p="http://schemas.openxmlformats.org/presentationml/2006/main" xmlns:r="http://schemas.openxmlformats.org/officeDocument/2006/relationships">
+  <p:cSld>
+    <p:spTree>
+      <p:nvGrpSpPr>
+        <p:cNvPr id="1" name=""/>
+        <p:cNvGrpSpPr/>
+        <p:nvPr/>
+      </p:nvGrpSpPr>
+      <p:grpSpPr>
+        <a:xfrm>
+          <a:off x="0" y="0"/>
+          <a:ext cx="0" cy="0"/>
+          <a:chOff x="0" y="0"/>
+          <a:chExt cx="0" cy="0"/>
+        </a:xfrm>
+      </p:grpSpPr>
+      <p:sp>
+        <p:nvSpPr>
+          <p:cNvPr id="2" name="Slide Image Placeholder 1"/>
+          <p:cNvSpPr>
+            <a:spLocks noGrp="1"/>
+          </p:cNvSpPr>
+          <p:nvPr>
+            <p:ph type="sldImg" idx="2"/>
+          </p:nvPr>
+        </p:nvSpPr>
+        <p:spPr/>
+      </p:sp>
+      <p:sp>
+        <p:nvSpPr>
+          <p:cNvPr id="3" name="Notes Placeholder 2"/>
+          <p:cNvSpPr>
+            <a:spLocks noGrp="1"/>
+          </p:cNvSpPr>
+          <p:nvPr>
+            <p:ph type="body" idx="3" sz="quarter"/>
+          </p:nvPr>
+        </p:nvSpPr>
+        <p:spPr/>
+        <p:txBody>
+          <a:bodyPr/>
+          <a:lstStyle/>
+          <a:p>
+            <a:r>
+              <a:t>Siehe Trainerhandbuch (Sektion 3) für Moderationshinweise, Timing und erwartete Teilnehmerreaktionen.</a:t>
+            </a:r>
+          </a:p>
+        </p:txBody>
+      </p:sp>
+      <p:sp>
+        <p:nvSpPr>
+          <p:cNvPr id="4" name="Slide Number Placeholder 3"/>
+          <p:cNvSpPr>
+            <a:spLocks noGrp="1"/>
+          </p:cNvSpPr>
+          <p:nvPr>
+            <p:ph type="sldNum" idx="5" sz="quarter"/>
+          </p:nvPr>
+        </p:nvSpPr>
+        <p:spPr/>
+      </p:sp>
+    </p:spTree>
+  </p:cSld>
+  <p:clrMapOvr>
+    <a:masterClrMapping/>
+  </p:clrMapOvr>
+</p:notes>
 </file>
 
 <file path=ppt/slideLayouts/slideLayout1.xml><?xml version="1.0" encoding="utf-8"?>
@@ -5459,7 +6024,7 @@
                 </a:solidFill>
                 <a:latin typeface="JetBrains Mono"/>
               </a:rPr>
-              <a:t>M01  ·  INHALT</a:t>
+              <a:t>M01  ·  ARBEITSBLATT</a:t>
             </a:r>
           </a:p>
         </p:txBody>
@@ -5593,8 +6158,8 @@
         </p:nvSpPr>
         <p:spPr>
           <a:xfrm>
-            <a:off x="685800" y="1417320"/>
-            <a:ext cx="10817352" cy="5029200"/>
+            <a:off x="685800" y="1554480"/>
+            <a:ext cx="10817352" cy="3840480"/>
           </a:xfrm>
           <a:prstGeom prst="rect">
             <a:avLst/>
@@ -5616,13 +6181,13 @@
               </a:spcAft>
             </a:pPr>
             <a:r>
-              <a:rPr sz="1200">
+              <a:rPr sz="1400">
                 <a:solidFill>
                   <a:srgbClr val="3D5466"/>
                 </a:solidFill>
                 <a:latin typeface="Arial"/>
               </a:rPr>
-              <a:t>Unternehmensportrait (anonymisiert, branchentypisch)</a:t>
+              <a:t>▸  Unternehmensportrait (anonymisiert, branchentypisch)</a:t>
             </a:r>
           </a:p>
           <a:p>
@@ -5635,13 +6200,13 @@
               </a:spcAft>
             </a:pPr>
             <a:r>
-              <a:rPr sz="1200">
+              <a:rPr sz="1400">
                 <a:solidFill>
                   <a:srgbClr val="3D5466"/>
                 </a:solidFill>
                 <a:latin typeface="Arial"/>
               </a:rPr>
-              <a:t>Situation: Der Kunde beantragt ein neues Investitionsdarlehen über 650.000 EUR für eine neue CNC-Fräsmaschine. Sie bereiten die Kreditvorlage vor und lesen den Jahresabschluss 2023.</a:t>
+              <a:t>▸  Situation: Der Kunde beantragt ein neues Investitionsdarlehen über 650.000 EUR für eine neue CNC-Fräsmaschine. Sie bereiten die Kreditvorlage vor und lesen den Jahresabschluss 2023.</a:t>
             </a:r>
           </a:p>
           <a:p>
@@ -5654,32 +6219,13 @@
               </a:spcAft>
             </a:pPr>
             <a:r>
-              <a:rPr sz="1200">
+              <a:rPr sz="1400">
                 <a:solidFill>
                   <a:srgbClr val="3D5466"/>
                 </a:solidFill>
                 <a:latin typeface="Arial"/>
               </a:rPr>
-              <a:t>Die folgende Handlungsempfehlung verknüpft typische Bilanzsignale mit der passenden Reaktion im Kreditgespräch – nutzen Sie sie als Orientierung bei der Auswertung des Praxisfalls.</a:t>
-            </a:r>
-          </a:p>
-          <a:p>
-            <a:pPr>
-              <a:spcBef>
-                <a:spcPts val="1000"/>
-              </a:spcBef>
-              <a:spcAft>
-                <a:spcPts val="200"/>
-              </a:spcAft>
-            </a:pPr>
-            <a:r>
-              <a:rPr sz="800" b="1">
-                <a:solidFill>
-                  <a:srgbClr val="78808C"/>
-                </a:solidFill>
-                <a:latin typeface="JetBrains Mono"/>
-              </a:rPr>
-              <a:t>MUSTERBILANZ BAUER GMBH (31.12.2023)</a:t>
+              <a:t>▸  Die folgende Handlungsempfehlung verknüpft typische Bilanzsignale mit der passenden Reaktion im Kreditgespräch – nutzen Sie sie als Orientierung bei der Auswertung des Praxisfalls.</a:t>
             </a:r>
           </a:p>
           <a:p>
@@ -5692,13 +6238,13 @@
               </a:spcAft>
             </a:pPr>
             <a:r>
-              <a:rPr sz="1200">
+              <a:rPr sz="1400">
                 <a:solidFill>
                   <a:srgbClr val="3D5466"/>
                 </a:solidFill>
                 <a:latin typeface="Arial"/>
               </a:rPr>
-              <a:t>BILANZ – Aktivseite</a:t>
+              <a:t>▸  Musterbilanz Bauer GmbH (31.12.2023)</a:t>
             </a:r>
           </a:p>
           <a:p>
@@ -5711,134 +6257,98 @@
               </a:spcAft>
             </a:pPr>
             <a:r>
-              <a:rPr sz="1200">
+              <a:rPr sz="1400">
                 <a:solidFill>
                   <a:srgbClr val="3D5466"/>
                 </a:solidFill>
                 <a:latin typeface="Arial"/>
               </a:rPr>
-              <a:t>BILANZ – Passivseite</a:t>
-            </a:r>
-          </a:p>
-          <a:p>
-            <a:pPr>
-              <a:spcBef>
-                <a:spcPts val="400"/>
-              </a:spcBef>
-              <a:spcAft>
-                <a:spcPts val="200"/>
-              </a:spcAft>
-            </a:pPr>
-            <a:r>
-              <a:rPr sz="1200">
-                <a:solidFill>
-                  <a:srgbClr val="3D5466"/>
+              <a:t>▸  BILANZ – Aktivseite</a:t>
+            </a:r>
+          </a:p>
+        </p:txBody>
+      </p:sp>
+      <p:sp>
+        <p:nvSpPr>
+          <p:cNvPr id="9" name="Rectangle 8"/>
+          <p:cNvSpPr/>
+          <p:nvPr/>
+        </p:nvSpPr>
+        <p:spPr>
+          <a:xfrm>
+            <a:off x="685800" y="5486400"/>
+            <a:ext cx="10817352" cy="640080"/>
+          </a:xfrm>
+          <a:prstGeom prst="rect">
+            <a:avLst/>
+          </a:prstGeom>
+          <a:solidFill>
+            <a:srgbClr val="1F2C56"/>
+          </a:solidFill>
+          <a:ln>
+            <a:noFill/>
+          </a:ln>
+        </p:spPr>
+        <p:style>
+          <a:lnRef idx="1">
+            <a:schemeClr val="accent1"/>
+          </a:lnRef>
+          <a:fillRef idx="3">
+            <a:schemeClr val="accent1"/>
+          </a:fillRef>
+          <a:effectRef idx="2">
+            <a:schemeClr val="accent1"/>
+          </a:effectRef>
+          <a:fontRef idx="minor">
+            <a:schemeClr val="lt1"/>
+          </a:fontRef>
+        </p:style>
+        <p:txBody>
+          <a:bodyPr rtlCol="0" anchor="ctr"/>
+          <a:lstStyle/>
+          <a:p>
+            <a:pPr algn="ctr"/>
+          </a:p>
+        </p:txBody>
+      </p:sp>
+      <p:sp>
+        <p:nvSpPr>
+          <p:cNvPr id="10" name="TextBox 9"/>
+          <p:cNvSpPr txBox="1"/>
+          <p:nvPr/>
+        </p:nvSpPr>
+        <p:spPr>
+          <a:xfrm>
+            <a:off x="868680" y="5596128"/>
+            <a:ext cx="10451592" cy="457200"/>
+          </a:xfrm>
+          <a:prstGeom prst="rect">
+            <a:avLst/>
+          </a:prstGeom>
+          <a:noFill/>
+        </p:spPr>
+        <p:txBody>
+          <a:bodyPr wrap="square">
+            <a:spAutoFit/>
+          </a:bodyPr>
+          <a:lstStyle/>
+          <a:p>
+            <a:pPr algn="l"/>
+            <a:r>
+              <a:rPr sz="1300" b="1" i="0">
+                <a:solidFill>
+                  <a:srgbClr val="FFFFFF"/>
                 </a:solidFill>
                 <a:latin typeface="Arial"/>
               </a:rPr>
-              <a:t>GEWINN- UND VERLUSTRECHNUNG (Gesamtkostenverfahren, § 275 Abs. 2 HGB)</a:t>
-            </a:r>
-          </a:p>
-          <a:p>
-            <a:pPr>
-              <a:spcBef>
-                <a:spcPts val="1000"/>
-              </a:spcBef>
-              <a:spcAft>
-                <a:spcPts val="200"/>
-              </a:spcAft>
-            </a:pPr>
-            <a:r>
-              <a:rPr sz="800" b="1">
-                <a:solidFill>
-                  <a:srgbClr val="78808C"/>
-                </a:solidFill>
-                <a:latin typeface="JetBrains Mono"/>
-              </a:rPr>
-              <a:t>KENNZAHLEN SELBST BERECHNEN – ARBEITSBLATT</a:t>
-            </a:r>
-          </a:p>
-          <a:p>
-            <a:pPr>
-              <a:spcBef>
-                <a:spcPts val="400"/>
-              </a:spcBef>
-              <a:spcAft>
-                <a:spcPts val="200"/>
-              </a:spcAft>
-            </a:pPr>
-            <a:r>
-              <a:rPr sz="1200">
-                <a:solidFill>
-                  <a:srgbClr val="3D5466"/>
-                </a:solidFill>
-                <a:latin typeface="Arial"/>
-              </a:rPr>
-              <a:t>Anleitung: Berechnen Sie alle sechs Kennzahlen anhand der Musterbilanz (2023). Tragen Sie Ihre Ergebnisse ein und vergleichen Sie danach mit Ihrem Partner.</a:t>
-            </a:r>
-          </a:p>
-          <a:p>
-            <a:pPr>
-              <a:spcBef>
-                <a:spcPts val="400"/>
-              </a:spcBef>
-              <a:spcAft>
-                <a:spcPts val="200"/>
-              </a:spcAft>
-            </a:pPr>
-            <a:r>
-              <a:rPr sz="1200">
-                <a:solidFill>
-                  <a:srgbClr val="3D5466"/>
-                </a:solidFill>
-                <a:latin typeface="Arial"/>
-              </a:rPr>
-              <a:t>Kennzahl 1: Eigenkapitalquote</a:t>
-            </a:r>
-          </a:p>
-          <a:p>
-            <a:pPr>
-              <a:spcBef>
-                <a:spcPts val="400"/>
-              </a:spcBef>
-              <a:spcAft>
-                <a:spcPts val="200"/>
-              </a:spcAft>
-            </a:pPr>
-            <a:r>
-              <a:rPr sz="1200">
-                <a:solidFill>
-                  <a:srgbClr val="3D5466"/>
-                </a:solidFill>
-                <a:latin typeface="Arial"/>
-              </a:rPr>
-              <a:t>Formel: EK / Bilanzsumme × 100</a:t>
-            </a:r>
-          </a:p>
-          <a:p>
-            <a:pPr>
-              <a:spcBef>
-                <a:spcPts val="400"/>
-              </a:spcBef>
-              <a:spcAft>
-                <a:spcPts val="200"/>
-              </a:spcAft>
-            </a:pPr>
-            <a:r>
-              <a:rPr sz="1200">
-                <a:solidFill>
-                  <a:srgbClr val="3D5466"/>
-                </a:solidFill>
-                <a:latin typeface="Arial"/>
-              </a:rPr>
-              <a:t>Ihre Rechnung: _______ / _______ × 100 = _______ %</a:t>
-            </a:r>
-          </a:p>
-        </p:txBody>
-      </p:sp>
-      <p:sp>
-        <p:nvSpPr>
-          <p:cNvPr id="9" name="Rectangle 8"/>
+              <a:t>→  Bearbeitung im Teilnehmer-Workbook (Arbeitsblatt mit Ausfüllfeldern)</a:t>
+            </a:r>
+          </a:p>
+        </p:txBody>
+      </p:sp>
+      <p:sp>
+        <p:nvSpPr>
+          <p:cNvPr id="11" name="Rectangle 10"/>
           <p:cNvSpPr/>
           <p:nvPr/>
         </p:nvSpPr>
@@ -5881,7 +6391,7 @@
       </p:sp>
       <p:sp>
         <p:nvSpPr>
-          <p:cNvPr id="10" name="TextBox 9"/>
+          <p:cNvPr id="12" name="TextBox 11"/>
           <p:cNvSpPr txBox="1"/>
           <p:nvPr/>
         </p:nvSpPr>
@@ -7404,4 +7914,324 @@
   </a:objectDefaults>
   <a:extraClrSchemeLst/>
 </a:theme>
+</file>
+
+<file path=ppt/theme/theme2.xml><?xml version="1.0" encoding="utf-8"?>
+<a:theme xmlns:a="http://schemas.openxmlformats.org/drawingml/2006/main" name="Office Theme">
+  <a:themeElements>
+    <a:clrScheme name="Office">
+      <a:dk1>
+        <a:sysClr val="windowText" lastClr="000000"/>
+      </a:dk1>
+      <a:lt1>
+        <a:sysClr val="window" lastClr="FFFFFF"/>
+      </a:lt1>
+      <a:dk2>
+        <a:srgbClr val="1F497D"/>
+      </a:dk2>
+      <a:lt2>
+        <a:srgbClr val="EEECE1"/>
+      </a:lt2>
+      <a:accent1>
+        <a:srgbClr val="4F81BD"/>
+      </a:accent1>
+      <a:accent2>
+        <a:srgbClr val="C0504D"/>
+      </a:accent2>
+      <a:accent3>
+        <a:srgbClr val="9BBB59"/>
+      </a:accent3>
+      <a:accent4>
+        <a:srgbClr val="8064A2"/>
+      </a:accent4>
+      <a:accent5>
+        <a:srgbClr val="4BACC6"/>
+      </a:accent5>
+      <a:accent6>
+        <a:srgbClr val="F79646"/>
+      </a:accent6>
+      <a:hlink>
+        <a:srgbClr val="0000FF"/>
+      </a:hlink>
+      <a:folHlink>
+        <a:srgbClr val="800080"/>
+      </a:folHlink>
+    </a:clrScheme>
+    <a:fontScheme name="Office">
+      <a:majorFont>
+        <a:latin typeface="Calibri"/>
+        <a:ea typeface=""/>
+        <a:cs typeface=""/>
+        <a:font script="Jpan" typeface="ＭＳ Ｐゴシック"/>
+        <a:font script="Hang" typeface="맑은 고딕"/>
+        <a:font script="Hans" typeface="宋体"/>
+        <a:font script="Hant" typeface="新細明體"/>
+        <a:font script="Arab" typeface="Times New Roman"/>
+        <a:font script="Hebr" typeface="Times New Roman"/>
+        <a:font script="Thai" typeface="Angsana New"/>
+        <a:font script="Ethi" typeface="Nyala"/>
+        <a:font script="Beng" typeface="Vrinda"/>
+        <a:font script="Gujr" typeface="Shruti"/>
+        <a:font script="Khmr" typeface="MoolBoran"/>
+        <a:font script="Knda" typeface="Tunga"/>
+        <a:font script="Guru" typeface="Raavi"/>
+        <a:font script="Cans" typeface="Euphemia"/>
+        <a:font script="Cher" typeface="Plantagenet Cherokee"/>
+        <a:font script="Yiii" typeface="Microsoft Yi Baiti"/>
+        <a:font script="Tibt" typeface="Microsoft Himalaya"/>
+        <a:font script="Thaa" typeface="MV Boli"/>
+        <a:font script="Deva" typeface="Mangal"/>
+        <a:font script="Telu" typeface="Gautami"/>
+        <a:font script="Taml" typeface="Latha"/>
+        <a:font script="Syrc" typeface="Estrangelo Edessa"/>
+        <a:font script="Orya" typeface="Kalinga"/>
+        <a:font script="Mlym" typeface="Kartika"/>
+        <a:font script="Laoo" typeface="DokChampa"/>
+        <a:font script="Sinh" typeface="Iskoola Pota"/>
+        <a:font script="Mong" typeface="Mongolian Baiti"/>
+        <a:font script="Viet" typeface="Times New Roman"/>
+        <a:font script="Uigh" typeface="Microsoft Uighur"/>
+        <a:font script="Geor" typeface="Sylfaen"/>
+      </a:majorFont>
+      <a:minorFont>
+        <a:latin typeface="Calibri"/>
+        <a:ea typeface=""/>
+        <a:cs typeface=""/>
+        <a:font script="Jpan" typeface="ＭＳ Ｐゴシック"/>
+        <a:font script="Hang" typeface="맑은 고딕"/>
+        <a:font script="Hans" typeface="宋体"/>
+        <a:font script="Hant" typeface="新細明體"/>
+        <a:font script="Arab" typeface="Arial"/>
+        <a:font script="Hebr" typeface="Arial"/>
+        <a:font script="Thai" typeface="Cordia New"/>
+        <a:font script="Ethi" typeface="Nyala"/>
+        <a:font script="Beng" typeface="Vrinda"/>
+        <a:font script="Gujr" typeface="Shruti"/>
+        <a:font script="Khmr" typeface="DaunPenh"/>
+        <a:font script="Knda" typeface="Tunga"/>
+        <a:font script="Guru" typeface="Raavi"/>
+        <a:font script="Cans" typeface="Euphemia"/>
+        <a:font script="Cher" typeface="Plantagenet Cherokee"/>
+        <a:font script="Yiii" typeface="Microsoft Yi Baiti"/>
+        <a:font script="Tibt" typeface="Microsoft Himalaya"/>
+        <a:font script="Thaa" typeface="MV Boli"/>
+        <a:font script="Deva" typeface="Mangal"/>
+        <a:font script="Telu" typeface="Gautami"/>
+        <a:font script="Taml" typeface="Latha"/>
+        <a:font script="Syrc" typeface="Estrangelo Edessa"/>
+        <a:font script="Orya" typeface="Kalinga"/>
+        <a:font script="Mlym" typeface="Kartika"/>
+        <a:font script="Laoo" typeface="DokChampa"/>
+        <a:font script="Sinh" typeface="Iskoola Pota"/>
+        <a:font script="Mong" typeface="Mongolian Baiti"/>
+        <a:font script="Viet" typeface="Arial"/>
+        <a:font script="Uigh" typeface="Microsoft Uighur"/>
+        <a:font script="Geor" typeface="Sylfaen"/>
+      </a:minorFont>
+    </a:fontScheme>
+    <a:fmtScheme name="Office">
+      <a:fillStyleLst>
+        <a:solidFill>
+          <a:schemeClr val="phClr"/>
+        </a:solidFill>
+        <a:gradFill rotWithShape="1">
+          <a:gsLst>
+            <a:gs pos="0">
+              <a:schemeClr val="phClr">
+                <a:tint val="50000"/>
+                <a:satMod val="300000"/>
+              </a:schemeClr>
+            </a:gs>
+            <a:gs pos="35000">
+              <a:schemeClr val="phClr">
+                <a:tint val="37000"/>
+                <a:satMod val="300000"/>
+              </a:schemeClr>
+            </a:gs>
+            <a:gs pos="100000">
+              <a:schemeClr val="phClr">
+                <a:tint val="15000"/>
+                <a:satMod val="350000"/>
+              </a:schemeClr>
+            </a:gs>
+          </a:gsLst>
+          <a:lin ang="16200000" scaled="1"/>
+        </a:gradFill>
+        <a:gradFill rotWithShape="1">
+          <a:gsLst>
+            <a:gs pos="0">
+              <a:schemeClr val="phClr">
+                <a:tint val="100000"/>
+                <a:shade val="100000"/>
+                <a:satMod val="130000"/>
+              </a:schemeClr>
+            </a:gs>
+            <a:gs pos="100000">
+              <a:schemeClr val="phClr">
+                <a:tint val="50000"/>
+                <a:shade val="100000"/>
+                <a:satMod val="350000"/>
+              </a:schemeClr>
+            </a:gs>
+          </a:gsLst>
+          <a:lin ang="16200000" scaled="0"/>
+        </a:gradFill>
+      </a:fillStyleLst>
+      <a:lnStyleLst>
+        <a:ln w="9525" cap="flat" cmpd="sng" algn="ctr">
+          <a:solidFill>
+            <a:schemeClr val="phClr">
+              <a:shade val="95000"/>
+              <a:satMod val="105000"/>
+            </a:schemeClr>
+          </a:solidFill>
+          <a:prstDash val="solid"/>
+        </a:ln>
+        <a:ln w="25400" cap="flat" cmpd="sng" algn="ctr">
+          <a:solidFill>
+            <a:schemeClr val="phClr"/>
+          </a:solidFill>
+          <a:prstDash val="solid"/>
+        </a:ln>
+        <a:ln w="38100" cap="flat" cmpd="sng" algn="ctr">
+          <a:solidFill>
+            <a:schemeClr val="phClr"/>
+          </a:solidFill>
+          <a:prstDash val="solid"/>
+        </a:ln>
+      </a:lnStyleLst>
+      <a:effectStyleLst>
+        <a:effectStyle>
+          <a:effectLst>
+            <a:outerShdw blurRad="40000" dist="20000" dir="5400000" rotWithShape="0">
+              <a:srgbClr val="000000">
+                <a:alpha val="38000"/>
+              </a:srgbClr>
+            </a:outerShdw>
+          </a:effectLst>
+        </a:effectStyle>
+        <a:effectStyle>
+          <a:effectLst>
+            <a:outerShdw blurRad="40000" dist="23000" dir="5400000" rotWithShape="0">
+              <a:srgbClr val="000000">
+                <a:alpha val="35000"/>
+              </a:srgbClr>
+            </a:outerShdw>
+          </a:effectLst>
+        </a:effectStyle>
+        <a:effectStyle>
+          <a:effectLst>
+            <a:outerShdw blurRad="40000" dist="23000" dir="5400000" rotWithShape="0">
+              <a:srgbClr val="000000">
+                <a:alpha val="35000"/>
+              </a:srgbClr>
+            </a:outerShdw>
+          </a:effectLst>
+          <a:scene3d>
+            <a:camera prst="orthographicFront">
+              <a:rot lat="0" lon="0" rev="0"/>
+            </a:camera>
+            <a:lightRig rig="threePt" dir="t">
+              <a:rot lat="0" lon="0" rev="1200000"/>
+            </a:lightRig>
+          </a:scene3d>
+          <a:sp3d>
+            <a:bevelT w="63500" h="25400"/>
+          </a:sp3d>
+        </a:effectStyle>
+      </a:effectStyleLst>
+      <a:bgFillStyleLst>
+        <a:solidFill>
+          <a:schemeClr val="phClr"/>
+        </a:solidFill>
+        <a:gradFill rotWithShape="1">
+          <a:gsLst>
+            <a:gs pos="0">
+              <a:schemeClr val="phClr">
+                <a:tint val="40000"/>
+                <a:satMod val="350000"/>
+              </a:schemeClr>
+            </a:gs>
+            <a:gs pos="40000">
+              <a:schemeClr val="phClr">
+                <a:tint val="45000"/>
+                <a:shade val="99000"/>
+                <a:satMod val="350000"/>
+              </a:schemeClr>
+            </a:gs>
+            <a:gs pos="100000">
+              <a:schemeClr val="phClr">
+                <a:shade val="20000"/>
+                <a:satMod val="255000"/>
+              </a:schemeClr>
+            </a:gs>
+          </a:gsLst>
+          <a:path path="circle">
+            <a:fillToRect l="50000" t="-80000" r="50000" b="180000"/>
+          </a:path>
+        </a:gradFill>
+        <a:gradFill rotWithShape="1">
+          <a:gsLst>
+            <a:gs pos="0">
+              <a:schemeClr val="phClr">
+                <a:tint val="80000"/>
+                <a:satMod val="300000"/>
+              </a:schemeClr>
+            </a:gs>
+            <a:gs pos="100000">
+              <a:schemeClr val="phClr">
+                <a:shade val="30000"/>
+                <a:satMod val="200000"/>
+              </a:schemeClr>
+            </a:gs>
+          </a:gsLst>
+          <a:path path="circle">
+            <a:fillToRect l="50000" t="50000" r="50000" b="50000"/>
+          </a:path>
+        </a:gradFill>
+      </a:bgFillStyleLst>
+    </a:fmtScheme>
+  </a:themeElements>
+  <a:objectDefaults>
+    <a:spDef>
+      <a:spPr/>
+      <a:bodyPr/>
+      <a:lstStyle/>
+      <a:style>
+        <a:lnRef idx="1">
+          <a:schemeClr val="accent1"/>
+        </a:lnRef>
+        <a:fillRef idx="3">
+          <a:schemeClr val="accent1"/>
+        </a:fillRef>
+        <a:effectRef idx="2">
+          <a:schemeClr val="accent1"/>
+        </a:effectRef>
+        <a:fontRef idx="minor">
+          <a:schemeClr val="lt1"/>
+        </a:fontRef>
+      </a:style>
+    </a:spDef>
+    <a:lnDef>
+      <a:spPr/>
+      <a:bodyPr/>
+      <a:lstStyle/>
+      <a:style>
+        <a:lnRef idx="2">
+          <a:schemeClr val="accent1"/>
+        </a:lnRef>
+        <a:fillRef idx="0">
+          <a:schemeClr val="accent1"/>
+        </a:fillRef>
+        <a:effectRef idx="1">
+          <a:schemeClr val="accent1"/>
+        </a:effectRef>
+        <a:fontRef idx="minor">
+          <a:schemeClr val="tx1"/>
+        </a:fontRef>
+      </a:style>
+    </a:lnDef>
+  </a:objectDefaults>
+  <a:extraClrSchemeLst/>
+</a:theme>
 </file>
</xml_diff>

<commit_message>
Modulseite: Überblick → Ablauf → Praxisfall → Workbook → Nach dem Workshop → Vertiefung
- lib/modules.ts: kurzbeschreibung, hero_grafik, praxisfall_vignette,
  workbook_inhalt, ablauf als Module-Felder
- page.tsx: neue Teilnehmer-Logik; Sec 2 + Quellen einklappbar ans Ende;
  Hero-Grafik im Überblick; Workbook-Box mit Inhaltsliste + Download
- content/modules: alle 22 mit auto-gepflegtem sync-Frontmatter-Block
- Artefakte (Workbooks, Trainerhandbücher, Decks) regeneriert

Co-Authored-By: Claude Fable 5 <noreply@anthropic.com>
</commit_message>
<xml_diff>
--- a/protected-downloads/praesentation/M01.pptx
+++ b/protected-downloads/praesentation/M01.pptx
@@ -8,12 +8,13 @@
     <p:sldId id="256" r:id="rId7"/>
     <p:sldId id="257" r:id="rId8"/>
     <p:sldId id="258" r:id="rId9"/>
-    <p:sldId id="259" r:id="rId11"/>
+    <p:sldId id="259" r:id="rId10"/>
     <p:sldId id="260" r:id="rId12"/>
     <p:sldId id="261" r:id="rId13"/>
     <p:sldId id="262" r:id="rId14"/>
     <p:sldId id="263" r:id="rId15"/>
     <p:sldId id="264" r:id="rId16"/>
+    <p:sldId id="265" r:id="rId17"/>
   </p:sldIdLst>
   <p:sldSz cx="12188952" cy="6858000" type="screen4x3"/>
   <p:notesSz cx="6858000" cy="9144000"/>
@@ -4226,6 +4227,462 @@
 </p:sld>
 </file>
 
+<file path=ppt/slides/slide10.xml><?xml version="1.0" encoding="utf-8"?>
+<p:sld xmlns:a="http://schemas.openxmlformats.org/drawingml/2006/main" xmlns:p="http://schemas.openxmlformats.org/presentationml/2006/main" xmlns:r="http://schemas.openxmlformats.org/officeDocument/2006/relationships">
+  <p:cSld>
+    <p:spTree>
+      <p:nvGrpSpPr>
+        <p:cNvPr id="1" name=""/>
+        <p:cNvGrpSpPr/>
+        <p:nvPr/>
+      </p:nvGrpSpPr>
+      <p:grpSpPr/>
+      <p:sp>
+        <p:nvSpPr>
+          <p:cNvPr id="2" name="Rectangle 1"/>
+          <p:cNvSpPr/>
+          <p:nvPr/>
+        </p:nvSpPr>
+        <p:spPr>
+          <a:xfrm>
+            <a:off x="0" y="0"/>
+            <a:ext cx="12188952" cy="6858000"/>
+          </a:xfrm>
+          <a:prstGeom prst="rect">
+            <a:avLst/>
+          </a:prstGeom>
+          <a:solidFill>
+            <a:srgbClr val="EDEDF3"/>
+          </a:solidFill>
+          <a:ln>
+            <a:noFill/>
+          </a:ln>
+        </p:spPr>
+        <p:style>
+          <a:lnRef idx="1">
+            <a:schemeClr val="accent1"/>
+          </a:lnRef>
+          <a:fillRef idx="3">
+            <a:schemeClr val="accent1"/>
+          </a:fillRef>
+          <a:effectRef idx="2">
+            <a:schemeClr val="accent1"/>
+          </a:effectRef>
+          <a:fontRef idx="minor">
+            <a:schemeClr val="lt1"/>
+          </a:fontRef>
+        </p:style>
+        <p:txBody>
+          <a:bodyPr rtlCol="0" anchor="ctr"/>
+          <a:lstStyle/>
+          <a:p>
+            <a:pPr algn="ctr"/>
+          </a:p>
+        </p:txBody>
+      </p:sp>
+      <p:sp>
+        <p:nvSpPr>
+          <p:cNvPr id="3" name="Rectangle 2"/>
+          <p:cNvSpPr/>
+          <p:nvPr/>
+        </p:nvSpPr>
+        <p:spPr>
+          <a:xfrm>
+            <a:off x="0" y="0"/>
+            <a:ext cx="12188952" cy="50292"/>
+          </a:xfrm>
+          <a:prstGeom prst="rect">
+            <a:avLst/>
+          </a:prstGeom>
+          <a:solidFill>
+            <a:srgbClr val="1F2C56"/>
+          </a:solidFill>
+          <a:ln>
+            <a:noFill/>
+          </a:ln>
+        </p:spPr>
+        <p:style>
+          <a:lnRef idx="1">
+            <a:schemeClr val="accent1"/>
+          </a:lnRef>
+          <a:fillRef idx="3">
+            <a:schemeClr val="accent1"/>
+          </a:fillRef>
+          <a:effectRef idx="2">
+            <a:schemeClr val="accent1"/>
+          </a:effectRef>
+          <a:fontRef idx="minor">
+            <a:schemeClr val="lt1"/>
+          </a:fontRef>
+        </p:style>
+        <p:txBody>
+          <a:bodyPr rtlCol="0" anchor="ctr"/>
+          <a:lstStyle/>
+          <a:p>
+            <a:pPr algn="ctr"/>
+          </a:p>
+        </p:txBody>
+      </p:sp>
+      <p:sp>
+        <p:nvSpPr>
+          <p:cNvPr id="4" name="TextBox 3"/>
+          <p:cNvSpPr txBox="1"/>
+          <p:nvPr/>
+        </p:nvSpPr>
+        <p:spPr>
+          <a:xfrm>
+            <a:off x="685800" y="109728"/>
+            <a:ext cx="10817352" cy="228600"/>
+          </a:xfrm>
+          <a:prstGeom prst="rect">
+            <a:avLst/>
+          </a:prstGeom>
+          <a:noFill/>
+        </p:spPr>
+        <p:txBody>
+          <a:bodyPr wrap="none">
+            <a:spAutoFit/>
+          </a:bodyPr>
+          <a:lstStyle/>
+          <a:p>
+            <a:pPr algn="l"/>
+            <a:r>
+              <a:rPr sz="750">
+                <a:solidFill>
+                  <a:srgbClr val="78808C"/>
+                </a:solidFill>
+                <a:latin typeface="JetBrains Mono"/>
+              </a:rPr>
+              <a:t>M01  ·  INHALT</a:t>
+            </a:r>
+          </a:p>
+        </p:txBody>
+      </p:sp>
+      <p:sp>
+        <p:nvSpPr>
+          <p:cNvPr id="5" name="Rectangle 4"/>
+          <p:cNvSpPr/>
+          <p:nvPr/>
+        </p:nvSpPr>
+        <p:spPr>
+          <a:xfrm>
+            <a:off x="0" y="1234440"/>
+            <a:ext cx="12188952" cy="12700"/>
+          </a:xfrm>
+          <a:prstGeom prst="rect">
+            <a:avLst/>
+          </a:prstGeom>
+          <a:solidFill>
+            <a:srgbClr val="D8DFE4"/>
+          </a:solidFill>
+          <a:ln>
+            <a:noFill/>
+          </a:ln>
+        </p:spPr>
+        <p:style>
+          <a:lnRef idx="1">
+            <a:schemeClr val="accent1"/>
+          </a:lnRef>
+          <a:fillRef idx="3">
+            <a:schemeClr val="accent1"/>
+          </a:fillRef>
+          <a:effectRef idx="2">
+            <a:schemeClr val="accent1"/>
+          </a:effectRef>
+          <a:fontRef idx="minor">
+            <a:schemeClr val="lt1"/>
+          </a:fontRef>
+        </p:style>
+        <p:txBody>
+          <a:bodyPr rtlCol="0" anchor="ctr"/>
+          <a:lstStyle/>
+          <a:p>
+            <a:pPr algn="ctr"/>
+          </a:p>
+        </p:txBody>
+      </p:sp>
+      <p:sp>
+        <p:nvSpPr>
+          <p:cNvPr id="6" name="Rectangle 5"/>
+          <p:cNvSpPr/>
+          <p:nvPr/>
+        </p:nvSpPr>
+        <p:spPr>
+          <a:xfrm>
+            <a:off x="685800" y="502920"/>
+            <a:ext cx="36576" cy="658368"/>
+          </a:xfrm>
+          <a:prstGeom prst="rect">
+            <a:avLst/>
+          </a:prstGeom>
+          <a:solidFill>
+            <a:srgbClr val="D9C089"/>
+          </a:solidFill>
+          <a:ln>
+            <a:noFill/>
+          </a:ln>
+        </p:spPr>
+        <p:style>
+          <a:lnRef idx="1">
+            <a:schemeClr val="accent1"/>
+          </a:lnRef>
+          <a:fillRef idx="3">
+            <a:schemeClr val="accent1"/>
+          </a:fillRef>
+          <a:effectRef idx="2">
+            <a:schemeClr val="accent1"/>
+          </a:effectRef>
+          <a:fontRef idx="minor">
+            <a:schemeClr val="lt1"/>
+          </a:fontRef>
+        </p:style>
+        <p:txBody>
+          <a:bodyPr rtlCol="0" anchor="ctr"/>
+          <a:lstStyle/>
+          <a:p>
+            <a:pPr algn="ctr"/>
+          </a:p>
+        </p:txBody>
+      </p:sp>
+      <p:sp>
+        <p:nvSpPr>
+          <p:cNvPr id="7" name="TextBox 6"/>
+          <p:cNvSpPr txBox="1"/>
+          <p:nvPr/>
+        </p:nvSpPr>
+        <p:spPr>
+          <a:xfrm>
+            <a:off x="813816" y="502920"/>
+            <a:ext cx="10634472" cy="685800"/>
+          </a:xfrm>
+          <a:prstGeom prst="rect">
+            <a:avLst/>
+          </a:prstGeom>
+          <a:noFill/>
+        </p:spPr>
+        <p:txBody>
+          <a:bodyPr wrap="square">
+            <a:spAutoFit/>
+          </a:bodyPr>
+          <a:lstStyle/>
+          <a:p>
+            <a:pPr algn="l"/>
+            <a:r>
+              <a:rPr sz="2400" b="1" i="0">
+                <a:solidFill>
+                  <a:srgbClr val="1F2C56"/>
+                </a:solidFill>
+                <a:latin typeface="Source Serif 4"/>
+              </a:rPr>
+              <a:t>Reflexionsfragen</a:t>
+            </a:r>
+          </a:p>
+        </p:txBody>
+      </p:sp>
+      <p:sp>
+        <p:nvSpPr>
+          <p:cNvPr id="8" name="TextBox 7"/>
+          <p:cNvSpPr txBox="1"/>
+          <p:nvPr/>
+        </p:nvSpPr>
+        <p:spPr>
+          <a:xfrm>
+            <a:off x="685800" y="1417320"/>
+            <a:ext cx="10817352" cy="5029200"/>
+          </a:xfrm>
+          <a:prstGeom prst="rect">
+            <a:avLst/>
+          </a:prstGeom>
+          <a:noFill/>
+        </p:spPr>
+        <p:txBody>
+          <a:bodyPr wrap="square">
+            <a:spAutoFit/>
+          </a:bodyPr>
+          <a:lstStyle/>
+          <a:p>
+            <a:pPr>
+              <a:spcBef>
+                <a:spcPts val="400"/>
+              </a:spcBef>
+              <a:spcAft>
+                <a:spcPts val="200"/>
+              </a:spcAft>
+            </a:pPr>
+            <a:r>
+              <a:rPr sz="1200">
+                <a:solidFill>
+                  <a:srgbClr val="3D5466"/>
+                </a:solidFill>
+                <a:latin typeface="Arial"/>
+              </a:rPr>
+              <a:t>Beantworten Sie diese Fragen am Ende des Moduls schriftlich (5 Minuten):</a:t>
+            </a:r>
+          </a:p>
+          <a:p>
+            <a:pPr>
+              <a:spcBef>
+                <a:spcPts val="400"/>
+              </a:spcBef>
+              <a:spcAft>
+                <a:spcPts val="200"/>
+              </a:spcAft>
+            </a:pPr>
+            <a:r>
+              <a:rPr sz="1300">
+                <a:solidFill>
+                  <a:srgbClr val="3D5466"/>
+                </a:solidFill>
+                <a:latin typeface="Arial"/>
+              </a:rPr>
+              <a:t>▸  Welche der sechs Kennzahlen war Ihnen vor diesem Modul noch unklar?</a:t>
+            </a:r>
+          </a:p>
+          <a:p>
+            <a:pPr>
+              <a:spcBef>
+                <a:spcPts val="400"/>
+              </a:spcBef>
+              <a:spcAft>
+                <a:spcPts val="200"/>
+              </a:spcAft>
+            </a:pPr>
+            <a:r>
+              <a:rPr sz="1300">
+                <a:solidFill>
+                  <a:srgbClr val="3D5466"/>
+                </a:solidFill>
+                <a:latin typeface="Arial"/>
+              </a:rPr>
+              <a:t>▸  Was ist der kritischste Befund in der Bauer GmbH-Analyse? Wie würden Sie ihn im Kundengespräch ansprechen?</a:t>
+            </a:r>
+          </a:p>
+          <a:p>
+            <a:pPr>
+              <a:spcBef>
+                <a:spcPts val="400"/>
+              </a:spcBef>
+              <a:spcAft>
+                <a:spcPts val="200"/>
+              </a:spcAft>
+            </a:pPr>
+            <a:r>
+              <a:rPr sz="1300">
+                <a:solidFill>
+                  <a:srgbClr val="3D5466"/>
+                </a:solidFill>
+                <a:latin typeface="Arial"/>
+              </a:rPr>
+              <a:t>▸  Welcher Kunde in Ihrem Portfolio kommt Ihnen beim Blick auf die Bauer-Bilanz spontan in den Sinn?</a:t>
+            </a:r>
+          </a:p>
+          <a:p>
+            <a:pPr>
+              <a:spcBef>
+                <a:spcPts val="400"/>
+              </a:spcBef>
+              <a:spcAft>
+                <a:spcPts val="200"/>
+              </a:spcAft>
+            </a:pPr>
+            <a:r>
+              <a:rPr sz="1300">
+                <a:solidFill>
+                  <a:srgbClr val="3D5466"/>
+                </a:solidFill>
+                <a:latin typeface="Arial"/>
+              </a:rPr>
+              <a:t>▸  Was werden Sie konkret in den nächsten 30 Tagen anders machen, wenn ein Jahresabschluss auf Ihrem Tisch liegt?</a:t>
+            </a:r>
+          </a:p>
+        </p:txBody>
+      </p:sp>
+      <p:sp>
+        <p:nvSpPr>
+          <p:cNvPr id="9" name="Rectangle 8"/>
+          <p:cNvSpPr/>
+          <p:nvPr/>
+        </p:nvSpPr>
+        <p:spPr>
+          <a:xfrm>
+            <a:off x="0" y="6510528"/>
+            <a:ext cx="12188952" cy="347472"/>
+          </a:xfrm>
+          <a:prstGeom prst="rect">
+            <a:avLst/>
+          </a:prstGeom>
+          <a:solidFill>
+            <a:srgbClr val="0A1937"/>
+          </a:solidFill>
+          <a:ln>
+            <a:noFill/>
+          </a:ln>
+        </p:spPr>
+        <p:style>
+          <a:lnRef idx="1">
+            <a:schemeClr val="accent1"/>
+          </a:lnRef>
+          <a:fillRef idx="3">
+            <a:schemeClr val="accent1"/>
+          </a:fillRef>
+          <a:effectRef idx="2">
+            <a:schemeClr val="accent1"/>
+          </a:effectRef>
+          <a:fontRef idx="minor">
+            <a:schemeClr val="lt1"/>
+          </a:fontRef>
+        </p:style>
+        <p:txBody>
+          <a:bodyPr rtlCol="0" anchor="ctr"/>
+          <a:lstStyle/>
+          <a:p>
+            <a:pPr algn="ctr"/>
+          </a:p>
+        </p:txBody>
+      </p:sp>
+      <p:sp>
+        <p:nvSpPr>
+          <p:cNvPr id="10" name="TextBox 9"/>
+          <p:cNvSpPr txBox="1"/>
+          <p:nvPr/>
+        </p:nvSpPr>
+        <p:spPr>
+          <a:xfrm>
+            <a:off x="685800" y="6583680"/>
+            <a:ext cx="6490411" cy="256032"/>
+          </a:xfrm>
+          <a:prstGeom prst="rect">
+            <a:avLst/>
+          </a:prstGeom>
+          <a:noFill/>
+        </p:spPr>
+        <p:txBody>
+          <a:bodyPr wrap="none">
+            <a:spAutoFit/>
+          </a:bodyPr>
+          <a:lstStyle/>
+          <a:p>
+            <a:pPr algn="l"/>
+            <a:r>
+              <a:rPr sz="700">
+                <a:solidFill>
+                  <a:srgbClr val="A0B4D2"/>
+                </a:solidFill>
+                <a:latin typeface="JetBrains Mono"/>
+              </a:rPr>
+              <a:t>Benedikt Zoller Coaching  ·  FKB Campus  ·  M01</a:t>
+            </a:r>
+          </a:p>
+        </p:txBody>
+      </p:sp>
+    </p:spTree>
+  </p:cSld>
+  <p:clrMapOvr>
+    <a:masterClrMapping/>
+  </p:clrMapOvr>
+</p:sld>
+</file>
+
 <file path=ppt/slides/slide2.xml><?xml version="1.0" encoding="utf-8"?>
 <p:sld xmlns:a="http://schemas.openxmlformats.org/drawingml/2006/main" xmlns:p="http://schemas.openxmlformats.org/presentationml/2006/main" xmlns:r="http://schemas.openxmlformats.org/officeDocument/2006/relationships">
   <p:cSld>
@@ -4352,7 +4809,7 @@
                 </a:solidFill>
                 <a:latin typeface="JetBrains Mono"/>
               </a:rPr>
-              <a:t>LERNZIELE  ·  M01</a:t>
+              <a:t>ÜBERBLICK  ·  M01</a:t>
             </a:r>
           </a:p>
         </p:txBody>
@@ -4430,7 +4887,7 @@
                 </a:solidFill>
                 <a:latin typeface="Source Serif 4"/>
               </a:rPr>
-              <a:t>Was Sie heute mitnehmen</a:t>
+              <a:t>Worum geht es heute</a:t>
             </a:r>
           </a:p>
         </p:txBody>
@@ -4443,8 +4900,8 @@
         </p:nvSpPr>
         <p:spPr>
           <a:xfrm>
-            <a:off x="685800" y="1371600"/>
-            <a:ext cx="10817352" cy="5120640"/>
+            <a:off x="685800" y="1737360"/>
+            <a:ext cx="9720072" cy="4206240"/>
           </a:xfrm>
           <a:prstGeom prst="rect">
             <a:avLst/>
@@ -4458,78 +4915,50 @@
           <a:lstStyle/>
           <a:p>
             <a:pPr>
-              <a:spcBef>
-                <a:spcPts val="800"/>
-              </a:spcBef>
               <a:spcAft>
-                <a:spcPts val="200"/>
+                <a:spcPts val="1200"/>
               </a:spcAft>
             </a:pPr>
             <a:r>
-              <a:rPr sz="1400">
+              <a:rPr sz="1700">
                 <a:solidFill>
                   <a:srgbClr val="3D5466"/>
                 </a:solidFill>
                 <a:latin typeface="Arial"/>
               </a:rPr>
-              <a:t>▸  Bestandteile eines HGB-Jahresabschlusses (Bilanz, GuV, Anhang) benennen</a:t>
+              <a:t>Viele Kundengespräche bleiben an der Oberfläche, weil die Bilanz ungelesen in der Akte liegt.</a:t>
             </a:r>
           </a:p>
           <a:p>
             <a:pPr>
-              <a:spcBef>
-                <a:spcPts val="800"/>
-              </a:spcBef>
               <a:spcAft>
-                <a:spcPts val="200"/>
+                <a:spcPts val="1200"/>
               </a:spcAft>
             </a:pPr>
             <a:r>
-              <a:rPr sz="1400">
+              <a:rPr sz="1700">
                 <a:solidFill>
                   <a:srgbClr val="3D5466"/>
                 </a:solidFill>
                 <a:latin typeface="Arial"/>
               </a:rPr>
-              <a:t>▸  Den Zusammenhang zwischen Bilanzstruktur und wirtschaftlicher Lage eines Unternehmens erklären</a:t>
+              <a:t>In diesem Modul lernen Sie, HGB-Jahresabschlüsse sicher zu lesen und die zentralen Kennzahlen selbst zu berechnen – am durchgängigen Praxisfall eines süddeutschen Maschinenbauers.</a:t>
             </a:r>
           </a:p>
           <a:p>
             <a:pPr>
-              <a:spcBef>
-                <a:spcPts val="800"/>
-              </a:spcBef>
               <a:spcAft>
-                <a:spcPts val="200"/>
+                <a:spcPts val="1200"/>
               </a:spcAft>
             </a:pPr>
             <a:r>
-              <a:rPr sz="1400">
+              <a:rPr sz="1700">
                 <a:solidFill>
                   <a:srgbClr val="3D5466"/>
                 </a:solidFill>
                 <a:latin typeface="Arial"/>
               </a:rPr>
-              <a:t>▸  Zentrale Bilanzkennzahlen (EK-Quote, Verschuldungsgrad, EBIT-Marge, KDCG, Liquidität II) anhand eines Praxisfalls berechnen und einordnen</a:t>
-            </a:r>
-          </a:p>
-          <a:p>
-            <a:pPr>
-              <a:spcBef>
-                <a:spcPts val="800"/>
-              </a:spcBef>
-              <a:spcAft>
-                <a:spcPts val="200"/>
-              </a:spcAft>
-            </a:pPr>
-            <a:r>
-              <a:rPr sz="1400">
-                <a:solidFill>
-                  <a:srgbClr val="3D5466"/>
-                </a:solidFill>
-                <a:latin typeface="Arial"/>
-              </a:rPr>
-              <a:t>▸  Häufige Bilanzierungswahlrechte nach HGB identifizieren und deren Auswirkung auf Kennzahlen benennen</a:t>
+              <a:t>Danach erkennen Sie Warnsignale auf einen Blick und leiten daraus konkrete Fragen für das nächste Kundengespräch ab.</a:t>
             </a:r>
           </a:p>
         </p:txBody>
@@ -4746,7 +5175,7 @@
                 </a:solidFill>
                 <a:latin typeface="JetBrains Mono"/>
               </a:rPr>
-              <a:t>M01  ·  INHALT</a:t>
+              <a:t>LERNZIELE  ·  M01</a:t>
             </a:r>
           </a:p>
         </p:txBody>
@@ -4796,57 +5225,14 @@
       </p:sp>
       <p:sp>
         <p:nvSpPr>
-          <p:cNvPr id="6" name="Rectangle 5"/>
-          <p:cNvSpPr/>
+          <p:cNvPr id="6" name="TextBox 5"/>
+          <p:cNvSpPr txBox="1"/>
           <p:nvPr/>
         </p:nvSpPr>
         <p:spPr>
           <a:xfrm>
             <a:off x="685800" y="502920"/>
-            <a:ext cx="36576" cy="658368"/>
-          </a:xfrm>
-          <a:prstGeom prst="rect">
-            <a:avLst/>
-          </a:prstGeom>
-          <a:solidFill>
-            <a:srgbClr val="D9C089"/>
-          </a:solidFill>
-          <a:ln>
-            <a:noFill/>
-          </a:ln>
-        </p:spPr>
-        <p:style>
-          <a:lnRef idx="1">
-            <a:schemeClr val="accent1"/>
-          </a:lnRef>
-          <a:fillRef idx="3">
-            <a:schemeClr val="accent1"/>
-          </a:fillRef>
-          <a:effectRef idx="2">
-            <a:schemeClr val="accent1"/>
-          </a:effectRef>
-          <a:fontRef idx="minor">
-            <a:schemeClr val="lt1"/>
-          </a:fontRef>
-        </p:style>
-        <p:txBody>
-          <a:bodyPr rtlCol="0" anchor="ctr"/>
-          <a:lstStyle/>
-          <a:p>
-            <a:pPr algn="ctr"/>
-          </a:p>
-        </p:txBody>
-      </p:sp>
-      <p:sp>
-        <p:nvSpPr>
-          <p:cNvPr id="7" name="TextBox 6"/>
-          <p:cNvSpPr txBox="1"/>
-          <p:nvPr/>
-        </p:nvSpPr>
-        <p:spPr>
-          <a:xfrm>
-            <a:off x="813816" y="502920"/>
-            <a:ext cx="10634472" cy="685800"/>
+            <a:ext cx="10817352" cy="658368"/>
           </a:xfrm>
           <a:prstGeom prst="rect">
             <a:avLst/>
@@ -4861,27 +5247,27 @@
           <a:p>
             <a:pPr algn="l"/>
             <a:r>
-              <a:rPr sz="2400" b="1" i="0">
+              <a:rPr sz="2600" b="1" i="0">
                 <a:solidFill>
                   <a:srgbClr val="1F2C56"/>
                 </a:solidFill>
                 <a:latin typeface="Source Serif 4"/>
               </a:rPr>
-              <a:t>Theorie-Input: Aufbau des HGB-Jahresabschlusses</a:t>
-            </a:r>
-          </a:p>
-        </p:txBody>
-      </p:sp>
-      <p:sp>
-        <p:nvSpPr>
-          <p:cNvPr id="8" name="TextBox 7"/>
+              <a:t>Was Sie heute mitnehmen</a:t>
+            </a:r>
+          </a:p>
+        </p:txBody>
+      </p:sp>
+      <p:sp>
+        <p:nvSpPr>
+          <p:cNvPr id="7" name="TextBox 6"/>
           <p:cNvSpPr txBox="1"/>
           <p:nvPr/>
         </p:nvSpPr>
         <p:spPr>
           <a:xfrm>
-            <a:off x="685800" y="1417320"/>
-            <a:ext cx="10817352" cy="5029200"/>
+            <a:off x="685800" y="1371600"/>
+            <a:ext cx="10817352" cy="5120640"/>
           </a:xfrm>
           <a:prstGeom prst="rect">
             <a:avLst/>
@@ -4896,217 +5282,84 @@
           <a:p>
             <a:pPr>
               <a:spcBef>
-                <a:spcPts val="1000"/>
+                <a:spcPts val="800"/>
               </a:spcBef>
               <a:spcAft>
                 <a:spcPts val="200"/>
               </a:spcAft>
             </a:pPr>
             <a:r>
-              <a:rPr sz="800" b="1">
-                <a:solidFill>
-                  <a:srgbClr val="78808C"/>
-                </a:solidFill>
-                <a:latin typeface="JetBrains Mono"/>
+              <a:rPr sz="1400">
+                <a:solidFill>
+                  <a:srgbClr val="3D5466"/>
+                </a:solidFill>
+                <a:latin typeface="Arial"/>
               </a:rPr>
-              <a:t>WAS IST EIN JAHRESABSCHLUSS?</a:t>
+              <a:t>▸  Bestandteile eines HGB-Jahresabschlusses (Bilanz, GuV, Anhang) benennen</a:t>
             </a:r>
           </a:p>
           <a:p>
             <a:pPr>
               <a:spcBef>
-                <a:spcPts val="400"/>
+                <a:spcPts val="800"/>
               </a:spcBef>
               <a:spcAft>
                 <a:spcPts val="200"/>
               </a:spcAft>
             </a:pPr>
             <a:r>
-              <a:rPr sz="1200">
+              <a:rPr sz="1400">
                 <a:solidFill>
                   <a:srgbClr val="3D5466"/>
                 </a:solidFill>
                 <a:latin typeface="Arial"/>
               </a:rPr>
-              <a:t>Der Jahresabschluss ist die jährliche Zusammenfassung der wirtschaftlichen Lage eines Unternehmens. Für Kapitalgesellschaften (GmbH, AG) schreibt das HGB in §§ 264 ff. folgende Bestandteile vor:</a:t>
+              <a:t>▸  Den Zusammenhang zwischen Bilanzstruktur und wirtschaftlicher Lage eines Unternehmens erklären</a:t>
             </a:r>
           </a:p>
           <a:p>
             <a:pPr>
               <a:spcBef>
-                <a:spcPts val="400"/>
+                <a:spcPts val="800"/>
               </a:spcBef>
               <a:spcAft>
                 <a:spcPts val="200"/>
               </a:spcAft>
             </a:pPr>
             <a:r>
-              <a:rPr sz="1200">
+              <a:rPr sz="1400">
                 <a:solidFill>
                   <a:srgbClr val="3D5466"/>
                 </a:solidFill>
                 <a:latin typeface="Arial"/>
               </a:rPr>
-              <a:t>Bilanz (§ 266 HGB): Stichtagsbezogene Gegenüberstellung von Vermögen (Aktiva) und Kapital (Passiva). Die Bilanz zeigt, was ein Unternehmen besitzt und wie es finanziert ist.</a:t>
+              <a:t>▸  Zentrale Bilanzkennzahlen (EK-Quote, Verschuldungsgrad, EBIT-Marge, KDCG, Liquidität II) anhand eines Praxisfalls berechnen und einordnen</a:t>
             </a:r>
           </a:p>
           <a:p>
             <a:pPr>
               <a:spcBef>
-                <a:spcPts val="400"/>
+                <a:spcPts val="800"/>
               </a:spcBef>
               <a:spcAft>
                 <a:spcPts val="200"/>
               </a:spcAft>
             </a:pPr>
             <a:r>
-              <a:rPr sz="1200">
+              <a:rPr sz="1400">
                 <a:solidFill>
                   <a:srgbClr val="3D5466"/>
                 </a:solidFill>
                 <a:latin typeface="Arial"/>
               </a:rPr>
-              <a:t>Gewinn- und Verlustrechnung (§ 275 HGB): Zeitraumbezogene Darstellung von Erträgen und Aufwendungen eines Geschäftsjahres. Sie zeigt, wie ein Unternehmen Geld verdient (oder verliert).</a:t>
-            </a:r>
-          </a:p>
-          <a:p>
-            <a:pPr>
-              <a:spcBef>
-                <a:spcPts val="400"/>
-              </a:spcBef>
-              <a:spcAft>
-                <a:spcPts val="200"/>
-              </a:spcAft>
-            </a:pPr>
-            <a:r>
-              <a:rPr sz="1200">
-                <a:solidFill>
-                  <a:srgbClr val="3D5466"/>
-                </a:solidFill>
-                <a:latin typeface="Arial"/>
-              </a:rPr>
-              <a:t>Anhang (§ 284 HGB): Erläuterungen und Ergänzungen zu Bilanz und GuV (z.B. Bilanzierungsmethoden, Haftungsverhältnisse). Für den Kreditgeber oft wertvoller als die nackten Zahlen.</a:t>
-            </a:r>
-          </a:p>
-          <a:p>
-            <a:pPr>
-              <a:spcBef>
-                <a:spcPts val="400"/>
-              </a:spcBef>
-              <a:spcAft>
-                <a:spcPts val="200"/>
-              </a:spcAft>
-            </a:pPr>
-            <a:r>
-              <a:rPr sz="1200">
-                <a:solidFill>
-                  <a:srgbClr val="3D5466"/>
-                </a:solidFill>
-                <a:latin typeface="Arial"/>
-              </a:rPr>
-              <a:t>Lagebericht (§ 289 HGB): Lageeinschätzung des Managements, Risikobericht, Ausblick. Nur für mittelgroße und große Unternehmen verpflichtend.</a:t>
-            </a:r>
-          </a:p>
-          <a:p>
-            <a:pPr>
-              <a:spcBef>
-                <a:spcPts val="1000"/>
-              </a:spcBef>
-              <a:spcAft>
-                <a:spcPts val="200"/>
-              </a:spcAft>
-            </a:pPr>
-            <a:r>
-              <a:rPr sz="800" b="1">
-                <a:solidFill>
-                  <a:srgbClr val="78808C"/>
-                </a:solidFill>
-                <a:latin typeface="JetBrains Mono"/>
-              </a:rPr>
-              <a:t>OFFENLEGUNGSPFLICHTEN UND GRÖSSENKLASSEN (§ 267 HGB)</a:t>
-            </a:r>
-          </a:p>
-          <a:p>
-            <a:pPr>
-              <a:spcBef>
-                <a:spcPts val="1000"/>
-              </a:spcBef>
-              <a:spcAft>
-                <a:spcPts val="200"/>
-              </a:spcAft>
-            </a:pPr>
-            <a:r>
-              <a:rPr sz="800" b="1">
-                <a:solidFill>
-                  <a:srgbClr val="78808C"/>
-                </a:solidFill>
-                <a:latin typeface="JetBrains Mono"/>
-              </a:rPr>
-              <a:t>BILANZSTRUKTUR: MITTELHERKUNFT UND -VERWENDUNG</a:t>
-            </a:r>
-          </a:p>
-          <a:p>
-            <a:pPr>
-              <a:spcBef>
-                <a:spcPts val="1000"/>
-              </a:spcBef>
-              <a:spcAft>
-                <a:spcPts val="200"/>
-              </a:spcAft>
-            </a:pPr>
-            <a:r>
-              <a:rPr sz="800" b="1">
-                <a:solidFill>
-                  <a:srgbClr val="78808C"/>
-                </a:solidFill>
-                <a:latin typeface="JetBrains Mono"/>
-              </a:rPr>
-              <a:t>BILANZIERUNGSWAHLRECHTE UND IHRE WIRKUNG</a:t>
-            </a:r>
-          </a:p>
-          <a:p>
-            <a:pPr>
-              <a:spcBef>
-                <a:spcPts val="1000"/>
-              </a:spcBef>
-              <a:spcAft>
-                <a:spcPts val="200"/>
-              </a:spcAft>
-            </a:pPr>
-            <a:r>
-              <a:rPr sz="800" b="1">
-                <a:solidFill>
-                  <a:srgbClr val="78808C"/>
-                </a:solidFill>
-                <a:latin typeface="JetBrains Mono"/>
-              </a:rPr>
-              <a:t>BILANZKENNZAHLEN IM ÜBERBLICK</a:t>
-            </a:r>
-          </a:p>
-          <a:p>
-            <a:pPr>
-              <a:spcBef>
-                <a:spcPts val="400"/>
-              </a:spcBef>
-              <a:spcAft>
-                <a:spcPts val="200"/>
-              </a:spcAft>
-            </a:pPr>
-            <a:r>
-              <a:rPr sz="1200">
-                <a:solidFill>
-                  <a:srgbClr val="3D5466"/>
-                </a:solidFill>
-                <a:latin typeface="Arial"/>
-              </a:rPr>
-              <a:t>Die sechs zentralen Kennzahlen mit Formel, Benchmark und Bewertungsampel:</a:t>
-            </a:r>
-          </a:p>
-        </p:txBody>
-      </p:sp>
-      <p:sp>
-        <p:nvSpPr>
-          <p:cNvPr id="9" name="Rectangle 8"/>
+              <a:t>▸  Häufige Bilanzierungswahlrechte nach HGB identifizieren und deren Auswirkung auf Kennzahlen benennen</a:t>
+            </a:r>
+          </a:p>
+        </p:txBody>
+      </p:sp>
+      <p:sp>
+        <p:nvSpPr>
+          <p:cNvPr id="8" name="Rectangle 7"/>
           <p:cNvSpPr/>
           <p:nvPr/>
         </p:nvSpPr>
@@ -5149,7 +5402,7 @@
       </p:sp>
       <p:sp>
         <p:nvSpPr>
-          <p:cNvPr id="10" name="TextBox 9"/>
+          <p:cNvPr id="9" name="TextBox 8"/>
           <p:cNvSpPr txBox="1"/>
           <p:nvPr/>
         </p:nvSpPr>
@@ -5215,7 +5468,7 @@
             <a:avLst/>
           </a:prstGeom>
           <a:solidFill>
-            <a:srgbClr val="FFFFFF"/>
+            <a:srgbClr val="EDEDF3"/>
           </a:solidFill>
           <a:ln>
             <a:noFill/>
@@ -5316,43 +5569,51 @@
                 </a:solidFill>
                 <a:latin typeface="JetBrains Mono"/>
               </a:rPr>
-              <a:t>M01  ·  SCHAUBILD</a:t>
-            </a:r>
-          </a:p>
-        </p:txBody>
-      </p:sp>
-      <p:sp>
-        <p:nvSpPr>
-          <p:cNvPr id="5" name="TextBox 4"/>
-          <p:cNvSpPr txBox="1"/>
-          <p:nvPr/>
-        </p:nvSpPr>
-        <p:spPr>
-          <a:xfrm>
-            <a:off x="685800" y="502920"/>
-            <a:ext cx="10817352" cy="594360"/>
-          </a:xfrm>
-          <a:prstGeom prst="rect">
-            <a:avLst/>
-          </a:prstGeom>
-          <a:noFill/>
-        </p:spPr>
-        <p:txBody>
-          <a:bodyPr wrap="square">
-            <a:spAutoFit/>
-          </a:bodyPr>
-          <a:lstStyle/>
-          <a:p>
-            <a:pPr algn="l"/>
-            <a:r>
-              <a:rPr sz="2000" b="1" i="0">
-                <a:solidFill>
-                  <a:srgbClr val="1F2C56"/>
-                </a:solidFill>
-                <a:latin typeface="Source Serif 4"/>
-              </a:rPr>
-              <a:t>Bilanzstruktur T-Konto</a:t>
-            </a:r>
+              <a:t>M01  ·  INHALT</a:t>
+            </a:r>
+          </a:p>
+        </p:txBody>
+      </p:sp>
+      <p:sp>
+        <p:nvSpPr>
+          <p:cNvPr id="5" name="Rectangle 4"/>
+          <p:cNvSpPr/>
+          <p:nvPr/>
+        </p:nvSpPr>
+        <p:spPr>
+          <a:xfrm>
+            <a:off x="0" y="1234440"/>
+            <a:ext cx="12188952" cy="12700"/>
+          </a:xfrm>
+          <a:prstGeom prst="rect">
+            <a:avLst/>
+          </a:prstGeom>
+          <a:solidFill>
+            <a:srgbClr val="D8DFE4"/>
+          </a:solidFill>
+          <a:ln>
+            <a:noFill/>
+          </a:ln>
+        </p:spPr>
+        <p:style>
+          <a:lnRef idx="1">
+            <a:schemeClr val="accent1"/>
+          </a:lnRef>
+          <a:fillRef idx="3">
+            <a:schemeClr val="accent1"/>
+          </a:fillRef>
+          <a:effectRef idx="2">
+            <a:schemeClr val="accent1"/>
+          </a:effectRef>
+          <a:fontRef idx="minor">
+            <a:schemeClr val="lt1"/>
+          </a:fontRef>
+        </p:style>
+        <p:txBody>
+          <a:bodyPr rtlCol="0" anchor="ctr"/>
+          <a:lstStyle/>
+          <a:p>
+            <a:pPr algn="ctr"/>
           </a:p>
         </p:txBody>
       </p:sp>
@@ -5364,8 +5625,8 @@
         </p:nvSpPr>
         <p:spPr>
           <a:xfrm>
-            <a:off x="685800" y="1143000"/>
-            <a:ext cx="10817352" cy="25400"/>
+            <a:off x="685800" y="502920"/>
+            <a:ext cx="36576" cy="658368"/>
           </a:xfrm>
           <a:prstGeom prst="rect">
             <a:avLst/>
@@ -5399,33 +5660,276 @@
           </a:p>
         </p:txBody>
       </p:sp>
-      <p:pic>
-        <p:nvPicPr>
-          <p:cNvPr id="7" name="Picture 6" descr="image.png"/>
-          <p:cNvPicPr>
-            <a:picLocks noChangeAspect="1"/>
-          </p:cNvPicPr>
-          <p:nvPr/>
-        </p:nvPicPr>
-        <p:blipFill>
-          <a:blip r:embed="rId2"/>
-          <a:stretch>
-            <a:fillRect/>
-          </a:stretch>
-        </p:blipFill>
-        <p:spPr>
-          <a:xfrm>
-            <a:off x="1931981" y="1325880"/>
-            <a:ext cx="8324990" cy="4937760"/>
-          </a:xfrm>
-          <a:prstGeom prst="rect">
-            <a:avLst/>
-          </a:prstGeom>
-        </p:spPr>
-      </p:pic>
-      <p:sp>
-        <p:nvSpPr>
-          <p:cNvPr id="8" name="Rectangle 7"/>
+      <p:sp>
+        <p:nvSpPr>
+          <p:cNvPr id="7" name="TextBox 6"/>
+          <p:cNvSpPr txBox="1"/>
+          <p:nvPr/>
+        </p:nvSpPr>
+        <p:spPr>
+          <a:xfrm>
+            <a:off x="813816" y="502920"/>
+            <a:ext cx="10634472" cy="685800"/>
+          </a:xfrm>
+          <a:prstGeom prst="rect">
+            <a:avLst/>
+          </a:prstGeom>
+          <a:noFill/>
+        </p:spPr>
+        <p:txBody>
+          <a:bodyPr wrap="square">
+            <a:spAutoFit/>
+          </a:bodyPr>
+          <a:lstStyle/>
+          <a:p>
+            <a:pPr algn="l"/>
+            <a:r>
+              <a:rPr sz="2400" b="1" i="0">
+                <a:solidFill>
+                  <a:srgbClr val="1F2C56"/>
+                </a:solidFill>
+                <a:latin typeface="Source Serif 4"/>
+              </a:rPr>
+              <a:t>Theorie-Input: Aufbau des HGB-Jahresabschlusses</a:t>
+            </a:r>
+          </a:p>
+        </p:txBody>
+      </p:sp>
+      <p:sp>
+        <p:nvSpPr>
+          <p:cNvPr id="8" name="TextBox 7"/>
+          <p:cNvSpPr txBox="1"/>
+          <p:nvPr/>
+        </p:nvSpPr>
+        <p:spPr>
+          <a:xfrm>
+            <a:off x="685800" y="1417320"/>
+            <a:ext cx="10817352" cy="5029200"/>
+          </a:xfrm>
+          <a:prstGeom prst="rect">
+            <a:avLst/>
+          </a:prstGeom>
+          <a:noFill/>
+        </p:spPr>
+        <p:txBody>
+          <a:bodyPr wrap="square">
+            <a:spAutoFit/>
+          </a:bodyPr>
+          <a:lstStyle/>
+          <a:p>
+            <a:pPr>
+              <a:spcBef>
+                <a:spcPts val="1000"/>
+              </a:spcBef>
+              <a:spcAft>
+                <a:spcPts val="200"/>
+              </a:spcAft>
+            </a:pPr>
+            <a:r>
+              <a:rPr sz="800" b="1">
+                <a:solidFill>
+                  <a:srgbClr val="78808C"/>
+                </a:solidFill>
+                <a:latin typeface="JetBrains Mono"/>
+              </a:rPr>
+              <a:t>WAS IST EIN JAHRESABSCHLUSS?</a:t>
+            </a:r>
+          </a:p>
+          <a:p>
+            <a:pPr>
+              <a:spcBef>
+                <a:spcPts val="400"/>
+              </a:spcBef>
+              <a:spcAft>
+                <a:spcPts val="200"/>
+              </a:spcAft>
+            </a:pPr>
+            <a:r>
+              <a:rPr sz="1200">
+                <a:solidFill>
+                  <a:srgbClr val="3D5466"/>
+                </a:solidFill>
+                <a:latin typeface="Arial"/>
+              </a:rPr>
+              <a:t>Der Jahresabschluss ist die jährliche Zusammenfassung der wirtschaftlichen Lage eines Unternehmens. Für Kapitalgesellschaften (GmbH, AG) schreibt das HGB in §§ 264 ff. folgende Bestandteile vor:</a:t>
+            </a:r>
+          </a:p>
+          <a:p>
+            <a:pPr>
+              <a:spcBef>
+                <a:spcPts val="400"/>
+              </a:spcBef>
+              <a:spcAft>
+                <a:spcPts val="200"/>
+              </a:spcAft>
+            </a:pPr>
+            <a:r>
+              <a:rPr sz="1200">
+                <a:solidFill>
+                  <a:srgbClr val="3D5466"/>
+                </a:solidFill>
+                <a:latin typeface="Arial"/>
+              </a:rPr>
+              <a:t>Bilanz (§ 266 HGB): Stichtagsbezogene Gegenüberstellung von Vermögen (Aktiva) und Kapital (Passiva). Die Bilanz zeigt, was ein Unternehmen besitzt und wie es finanziert ist.</a:t>
+            </a:r>
+          </a:p>
+          <a:p>
+            <a:pPr>
+              <a:spcBef>
+                <a:spcPts val="400"/>
+              </a:spcBef>
+              <a:spcAft>
+                <a:spcPts val="200"/>
+              </a:spcAft>
+            </a:pPr>
+            <a:r>
+              <a:rPr sz="1200">
+                <a:solidFill>
+                  <a:srgbClr val="3D5466"/>
+                </a:solidFill>
+                <a:latin typeface="Arial"/>
+              </a:rPr>
+              <a:t>Gewinn- und Verlustrechnung (§ 275 HGB): Zeitraumbezogene Darstellung von Erträgen und Aufwendungen eines Geschäftsjahres. Sie zeigt, wie ein Unternehmen Geld verdient (oder verliert).</a:t>
+            </a:r>
+          </a:p>
+          <a:p>
+            <a:pPr>
+              <a:spcBef>
+                <a:spcPts val="400"/>
+              </a:spcBef>
+              <a:spcAft>
+                <a:spcPts val="200"/>
+              </a:spcAft>
+            </a:pPr>
+            <a:r>
+              <a:rPr sz="1200">
+                <a:solidFill>
+                  <a:srgbClr val="3D5466"/>
+                </a:solidFill>
+                <a:latin typeface="Arial"/>
+              </a:rPr>
+              <a:t>Anhang (§ 284 HGB): Erläuterungen und Ergänzungen zu Bilanz und GuV (z.B. Bilanzierungsmethoden, Haftungsverhältnisse). Für den Kreditgeber oft wertvoller als die nackten Zahlen.</a:t>
+            </a:r>
+          </a:p>
+          <a:p>
+            <a:pPr>
+              <a:spcBef>
+                <a:spcPts val="400"/>
+              </a:spcBef>
+              <a:spcAft>
+                <a:spcPts val="200"/>
+              </a:spcAft>
+            </a:pPr>
+            <a:r>
+              <a:rPr sz="1200">
+                <a:solidFill>
+                  <a:srgbClr val="3D5466"/>
+                </a:solidFill>
+                <a:latin typeface="Arial"/>
+              </a:rPr>
+              <a:t>Lagebericht (§ 289 HGB): Lageeinschätzung des Managements, Risikobericht, Ausblick. Nur für mittelgroße und große Unternehmen verpflichtend.</a:t>
+            </a:r>
+          </a:p>
+          <a:p>
+            <a:pPr>
+              <a:spcBef>
+                <a:spcPts val="1000"/>
+              </a:spcBef>
+              <a:spcAft>
+                <a:spcPts val="200"/>
+              </a:spcAft>
+            </a:pPr>
+            <a:r>
+              <a:rPr sz="800" b="1">
+                <a:solidFill>
+                  <a:srgbClr val="78808C"/>
+                </a:solidFill>
+                <a:latin typeface="JetBrains Mono"/>
+              </a:rPr>
+              <a:t>OFFENLEGUNGSPFLICHTEN UND GRÖSSENKLASSEN (§ 267 HGB)</a:t>
+            </a:r>
+          </a:p>
+          <a:p>
+            <a:pPr>
+              <a:spcBef>
+                <a:spcPts val="1000"/>
+              </a:spcBef>
+              <a:spcAft>
+                <a:spcPts val="200"/>
+              </a:spcAft>
+            </a:pPr>
+            <a:r>
+              <a:rPr sz="800" b="1">
+                <a:solidFill>
+                  <a:srgbClr val="78808C"/>
+                </a:solidFill>
+                <a:latin typeface="JetBrains Mono"/>
+              </a:rPr>
+              <a:t>BILANZSTRUKTUR: MITTELHERKUNFT UND -VERWENDUNG</a:t>
+            </a:r>
+          </a:p>
+          <a:p>
+            <a:pPr>
+              <a:spcBef>
+                <a:spcPts val="1000"/>
+              </a:spcBef>
+              <a:spcAft>
+                <a:spcPts val="200"/>
+              </a:spcAft>
+            </a:pPr>
+            <a:r>
+              <a:rPr sz="800" b="1">
+                <a:solidFill>
+                  <a:srgbClr val="78808C"/>
+                </a:solidFill>
+                <a:latin typeface="JetBrains Mono"/>
+              </a:rPr>
+              <a:t>BILANZIERUNGSWAHLRECHTE UND IHRE WIRKUNG</a:t>
+            </a:r>
+          </a:p>
+          <a:p>
+            <a:pPr>
+              <a:spcBef>
+                <a:spcPts val="1000"/>
+              </a:spcBef>
+              <a:spcAft>
+                <a:spcPts val="200"/>
+              </a:spcAft>
+            </a:pPr>
+            <a:r>
+              <a:rPr sz="800" b="1">
+                <a:solidFill>
+                  <a:srgbClr val="78808C"/>
+                </a:solidFill>
+                <a:latin typeface="JetBrains Mono"/>
+              </a:rPr>
+              <a:t>BILANZKENNZAHLEN IM ÜBERBLICK</a:t>
+            </a:r>
+          </a:p>
+          <a:p>
+            <a:pPr>
+              <a:spcBef>
+                <a:spcPts val="400"/>
+              </a:spcBef>
+              <a:spcAft>
+                <a:spcPts val="200"/>
+              </a:spcAft>
+            </a:pPr>
+            <a:r>
+              <a:rPr sz="1200">
+                <a:solidFill>
+                  <a:srgbClr val="3D5466"/>
+                </a:solidFill>
+                <a:latin typeface="Arial"/>
+              </a:rPr>
+              <a:t>Die sechs zentralen Kennzahlen mit Formel, Benchmark und Bewertungsampel:</a:t>
+            </a:r>
+          </a:p>
+        </p:txBody>
+      </p:sp>
+      <p:sp>
+        <p:nvSpPr>
+          <p:cNvPr id="9" name="Rectangle 8"/>
           <p:cNvSpPr/>
           <p:nvPr/>
         </p:nvSpPr>
@@ -5468,7 +5972,7 @@
       </p:sp>
       <p:sp>
         <p:nvSpPr>
-          <p:cNvPr id="9" name="TextBox 8"/>
+          <p:cNvPr id="10" name="TextBox 9"/>
           <p:cNvSpPr txBox="1"/>
           <p:nvPr/>
         </p:nvSpPr>
@@ -5497,41 +6001,6 @@
                 <a:latin typeface="JetBrains Mono"/>
               </a:rPr>
               <a:t>Benedikt Zoller Coaching  ·  FKB Campus  ·  M01</a:t>
-            </a:r>
-          </a:p>
-        </p:txBody>
-      </p:sp>
-      <p:sp>
-        <p:nvSpPr>
-          <p:cNvPr id="10" name="TextBox 9"/>
-          <p:cNvSpPr txBox="1"/>
-          <p:nvPr/>
-        </p:nvSpPr>
-        <p:spPr>
-          <a:xfrm>
-            <a:off x="7176211" y="6583680"/>
-            <a:ext cx="4326940" cy="256032"/>
-          </a:xfrm>
-          <a:prstGeom prst="rect">
-            <a:avLst/>
-          </a:prstGeom>
-          <a:noFill/>
-        </p:spPr>
-        <p:txBody>
-          <a:bodyPr wrap="none">
-            <a:spAutoFit/>
-          </a:bodyPr>
-          <a:lstStyle/>
-          <a:p>
-            <a:pPr algn="r"/>
-            <a:r>
-              <a:rPr sz="700">
-                <a:solidFill>
-                  <a:srgbClr val="A0B4D2"/>
-                </a:solidFill>
-                <a:latin typeface="JetBrains Mono"/>
-              </a:rPr>
-              <a:t>Schaubild</a:t>
             </a:r>
           </a:p>
         </p:txBody>
@@ -5705,7 +6174,7 @@
                 </a:solidFill>
                 <a:latin typeface="Source Serif 4"/>
               </a:rPr>
-              <a:t>Bilanzkennzahlen-Karte mit Bewertungsampel</a:t>
+              <a:t>Bilanzstruktur T-Konto</a:t>
             </a:r>
           </a:p>
         </p:txBody>
@@ -5769,8 +6238,8 @@
         </p:blipFill>
         <p:spPr>
           <a:xfrm>
-            <a:off x="2163921" y="1325880"/>
-            <a:ext cx="7861110" cy="4937760"/>
+            <a:off x="1931981" y="1325880"/>
+            <a:ext cx="8324990" cy="4937760"/>
           </a:xfrm>
           <a:prstGeom prst="rect">
             <a:avLst/>
@@ -5923,7 +6392,7 @@
             <a:avLst/>
           </a:prstGeom>
           <a:solidFill>
-            <a:srgbClr val="EDEDF3"/>
+            <a:srgbClr val="FFFFFF"/>
           </a:solidFill>
           <a:ln>
             <a:noFill/>
@@ -6024,51 +6493,43 @@
                 </a:solidFill>
                 <a:latin typeface="JetBrains Mono"/>
               </a:rPr>
-              <a:t>M01  ·  ARBEITSBLATT</a:t>
-            </a:r>
-          </a:p>
-        </p:txBody>
-      </p:sp>
-      <p:sp>
-        <p:nvSpPr>
-          <p:cNvPr id="5" name="Rectangle 4"/>
-          <p:cNvSpPr/>
-          <p:nvPr/>
-        </p:nvSpPr>
-        <p:spPr>
-          <a:xfrm>
-            <a:off x="0" y="1234440"/>
-            <a:ext cx="12188952" cy="12700"/>
-          </a:xfrm>
-          <a:prstGeom prst="rect">
-            <a:avLst/>
-          </a:prstGeom>
-          <a:solidFill>
-            <a:srgbClr val="D8DFE4"/>
-          </a:solidFill>
-          <a:ln>
-            <a:noFill/>
-          </a:ln>
-        </p:spPr>
-        <p:style>
-          <a:lnRef idx="1">
-            <a:schemeClr val="accent1"/>
-          </a:lnRef>
-          <a:fillRef idx="3">
-            <a:schemeClr val="accent1"/>
-          </a:fillRef>
-          <a:effectRef idx="2">
-            <a:schemeClr val="accent1"/>
-          </a:effectRef>
-          <a:fontRef idx="minor">
-            <a:schemeClr val="lt1"/>
-          </a:fontRef>
-        </p:style>
-        <p:txBody>
-          <a:bodyPr rtlCol="0" anchor="ctr"/>
-          <a:lstStyle/>
-          <a:p>
-            <a:pPr algn="ctr"/>
+              <a:t>M01  ·  SCHAUBILD</a:t>
+            </a:r>
+          </a:p>
+        </p:txBody>
+      </p:sp>
+      <p:sp>
+        <p:nvSpPr>
+          <p:cNvPr id="5" name="TextBox 4"/>
+          <p:cNvSpPr txBox="1"/>
+          <p:nvPr/>
+        </p:nvSpPr>
+        <p:spPr>
+          <a:xfrm>
+            <a:off x="685800" y="502920"/>
+            <a:ext cx="10817352" cy="594360"/>
+          </a:xfrm>
+          <a:prstGeom prst="rect">
+            <a:avLst/>
+          </a:prstGeom>
+          <a:noFill/>
+        </p:spPr>
+        <p:txBody>
+          <a:bodyPr wrap="square">
+            <a:spAutoFit/>
+          </a:bodyPr>
+          <a:lstStyle/>
+          <a:p>
+            <a:pPr algn="l"/>
+            <a:r>
+              <a:rPr sz="2000" b="1" i="0">
+                <a:solidFill>
+                  <a:srgbClr val="1F2C56"/>
+                </a:solidFill>
+                <a:latin typeface="Source Serif 4"/>
+              </a:rPr>
+              <a:t>Bilanzkennzahlen-Karte mit Bewertungsampel</a:t>
+            </a:r>
           </a:p>
         </p:txBody>
       </p:sp>
@@ -6080,8 +6541,8 @@
         </p:nvSpPr>
         <p:spPr>
           <a:xfrm>
-            <a:off x="685800" y="502920"/>
-            <a:ext cx="36576" cy="658368"/>
+            <a:off x="685800" y="1143000"/>
+            <a:ext cx="10817352" cy="25400"/>
           </a:xfrm>
           <a:prstGeom prst="rect">
             <a:avLst/>
@@ -6115,240 +6576,33 @@
           </a:p>
         </p:txBody>
       </p:sp>
-      <p:sp>
-        <p:nvSpPr>
-          <p:cNvPr id="7" name="TextBox 6"/>
-          <p:cNvSpPr txBox="1"/>
-          <p:nvPr/>
-        </p:nvSpPr>
-        <p:spPr>
-          <a:xfrm>
-            <a:off x="813816" y="502920"/>
-            <a:ext cx="10634472" cy="685800"/>
-          </a:xfrm>
-          <a:prstGeom prst="rect">
-            <a:avLst/>
-          </a:prstGeom>
-          <a:noFill/>
-        </p:spPr>
-        <p:txBody>
-          <a:bodyPr wrap="square">
-            <a:spAutoFit/>
-          </a:bodyPr>
-          <a:lstStyle/>
-          <a:p>
-            <a:pPr algn="l"/>
-            <a:r>
-              <a:rPr sz="2400" b="1" i="0">
-                <a:solidFill>
-                  <a:srgbClr val="1F2C56"/>
-                </a:solidFill>
-                <a:latin typeface="Source Serif 4"/>
-              </a:rPr>
-              <a:t>Praxisfall: Musterbilanz „Bauer GmbH"</a:t>
-            </a:r>
-          </a:p>
-        </p:txBody>
-      </p:sp>
-      <p:sp>
-        <p:nvSpPr>
-          <p:cNvPr id="8" name="TextBox 7"/>
-          <p:cNvSpPr txBox="1"/>
-          <p:nvPr/>
-        </p:nvSpPr>
-        <p:spPr>
-          <a:xfrm>
-            <a:off x="685800" y="1554480"/>
-            <a:ext cx="10817352" cy="3840480"/>
-          </a:xfrm>
-          <a:prstGeom prst="rect">
-            <a:avLst/>
-          </a:prstGeom>
-          <a:noFill/>
-        </p:spPr>
-        <p:txBody>
-          <a:bodyPr wrap="square">
-            <a:spAutoFit/>
-          </a:bodyPr>
-          <a:lstStyle/>
-          <a:p>
-            <a:pPr>
-              <a:spcBef>
-                <a:spcPts val="400"/>
-              </a:spcBef>
-              <a:spcAft>
-                <a:spcPts val="200"/>
-              </a:spcAft>
-            </a:pPr>
-            <a:r>
-              <a:rPr sz="1400">
-                <a:solidFill>
-                  <a:srgbClr val="3D5466"/>
-                </a:solidFill>
-                <a:latin typeface="Arial"/>
-              </a:rPr>
-              <a:t>▸  Unternehmensportrait (anonymisiert, branchentypisch)</a:t>
-            </a:r>
-          </a:p>
-          <a:p>
-            <a:pPr>
-              <a:spcBef>
-                <a:spcPts val="400"/>
-              </a:spcBef>
-              <a:spcAft>
-                <a:spcPts val="200"/>
-              </a:spcAft>
-            </a:pPr>
-            <a:r>
-              <a:rPr sz="1400">
-                <a:solidFill>
-                  <a:srgbClr val="3D5466"/>
-                </a:solidFill>
-                <a:latin typeface="Arial"/>
-              </a:rPr>
-              <a:t>▸  Situation: Der Kunde beantragt ein neues Investitionsdarlehen über 650.000 EUR für eine neue CNC-Fräsmaschine. Sie bereiten die Kreditvorlage vor und lesen den Jahresabschluss 2023.</a:t>
-            </a:r>
-          </a:p>
-          <a:p>
-            <a:pPr>
-              <a:spcBef>
-                <a:spcPts val="400"/>
-              </a:spcBef>
-              <a:spcAft>
-                <a:spcPts val="200"/>
-              </a:spcAft>
-            </a:pPr>
-            <a:r>
-              <a:rPr sz="1400">
-                <a:solidFill>
-                  <a:srgbClr val="3D5466"/>
-                </a:solidFill>
-                <a:latin typeface="Arial"/>
-              </a:rPr>
-              <a:t>▸  Die folgende Handlungsempfehlung verknüpft typische Bilanzsignale mit der passenden Reaktion im Kreditgespräch – nutzen Sie sie als Orientierung bei der Auswertung des Praxisfalls.</a:t>
-            </a:r>
-          </a:p>
-          <a:p>
-            <a:pPr>
-              <a:spcBef>
-                <a:spcPts val="400"/>
-              </a:spcBef>
-              <a:spcAft>
-                <a:spcPts val="200"/>
-              </a:spcAft>
-            </a:pPr>
-            <a:r>
-              <a:rPr sz="1400">
-                <a:solidFill>
-                  <a:srgbClr val="3D5466"/>
-                </a:solidFill>
-                <a:latin typeface="Arial"/>
-              </a:rPr>
-              <a:t>▸  Musterbilanz Bauer GmbH (31.12.2023)</a:t>
-            </a:r>
-          </a:p>
-          <a:p>
-            <a:pPr>
-              <a:spcBef>
-                <a:spcPts val="400"/>
-              </a:spcBef>
-              <a:spcAft>
-                <a:spcPts val="200"/>
-              </a:spcAft>
-            </a:pPr>
-            <a:r>
-              <a:rPr sz="1400">
-                <a:solidFill>
-                  <a:srgbClr val="3D5466"/>
-                </a:solidFill>
-                <a:latin typeface="Arial"/>
-              </a:rPr>
-              <a:t>▸  BILANZ – Aktivseite</a:t>
-            </a:r>
-          </a:p>
-        </p:txBody>
-      </p:sp>
-      <p:sp>
-        <p:nvSpPr>
-          <p:cNvPr id="9" name="Rectangle 8"/>
-          <p:cNvSpPr/>
-          <p:nvPr/>
-        </p:nvSpPr>
-        <p:spPr>
-          <a:xfrm>
-            <a:off x="685800" y="5486400"/>
-            <a:ext cx="10817352" cy="640080"/>
-          </a:xfrm>
-          <a:prstGeom prst="rect">
-            <a:avLst/>
-          </a:prstGeom>
-          <a:solidFill>
-            <a:srgbClr val="1F2C56"/>
-          </a:solidFill>
-          <a:ln>
-            <a:noFill/>
-          </a:ln>
-        </p:spPr>
-        <p:style>
-          <a:lnRef idx="1">
-            <a:schemeClr val="accent1"/>
-          </a:lnRef>
-          <a:fillRef idx="3">
-            <a:schemeClr val="accent1"/>
-          </a:fillRef>
-          <a:effectRef idx="2">
-            <a:schemeClr val="accent1"/>
-          </a:effectRef>
-          <a:fontRef idx="minor">
-            <a:schemeClr val="lt1"/>
-          </a:fontRef>
-        </p:style>
-        <p:txBody>
-          <a:bodyPr rtlCol="0" anchor="ctr"/>
-          <a:lstStyle/>
-          <a:p>
-            <a:pPr algn="ctr"/>
-          </a:p>
-        </p:txBody>
-      </p:sp>
-      <p:sp>
-        <p:nvSpPr>
-          <p:cNvPr id="10" name="TextBox 9"/>
-          <p:cNvSpPr txBox="1"/>
-          <p:nvPr/>
-        </p:nvSpPr>
-        <p:spPr>
-          <a:xfrm>
-            <a:off x="868680" y="5596128"/>
-            <a:ext cx="10451592" cy="457200"/>
-          </a:xfrm>
-          <a:prstGeom prst="rect">
-            <a:avLst/>
-          </a:prstGeom>
-          <a:noFill/>
-        </p:spPr>
-        <p:txBody>
-          <a:bodyPr wrap="square">
-            <a:spAutoFit/>
-          </a:bodyPr>
-          <a:lstStyle/>
-          <a:p>
-            <a:pPr algn="l"/>
-            <a:r>
-              <a:rPr sz="1300" b="1" i="0">
-                <a:solidFill>
-                  <a:srgbClr val="FFFFFF"/>
-                </a:solidFill>
-                <a:latin typeface="Arial"/>
-              </a:rPr>
-              <a:t>→  Bearbeitung im Teilnehmer-Workbook (Arbeitsblatt mit Ausfüllfeldern)</a:t>
-            </a:r>
-          </a:p>
-        </p:txBody>
-      </p:sp>
-      <p:sp>
-        <p:nvSpPr>
-          <p:cNvPr id="11" name="Rectangle 10"/>
+      <p:pic>
+        <p:nvPicPr>
+          <p:cNvPr id="7" name="Picture 6" descr="image.png"/>
+          <p:cNvPicPr>
+            <a:picLocks noChangeAspect="1"/>
+          </p:cNvPicPr>
+          <p:nvPr/>
+        </p:nvPicPr>
+        <p:blipFill>
+          <a:blip r:embed="rId2"/>
+          <a:stretch>
+            <a:fillRect/>
+          </a:stretch>
+        </p:blipFill>
+        <p:spPr>
+          <a:xfrm>
+            <a:off x="2163921" y="1325880"/>
+            <a:ext cx="7861110" cy="4937760"/>
+          </a:xfrm>
+          <a:prstGeom prst="rect">
+            <a:avLst/>
+          </a:prstGeom>
+        </p:spPr>
+      </p:pic>
+      <p:sp>
+        <p:nvSpPr>
+          <p:cNvPr id="8" name="Rectangle 7"/>
           <p:cNvSpPr/>
           <p:nvPr/>
         </p:nvSpPr>
@@ -6391,7 +6645,7 @@
       </p:sp>
       <p:sp>
         <p:nvSpPr>
-          <p:cNvPr id="12" name="TextBox 11"/>
+          <p:cNvPr id="9" name="TextBox 8"/>
           <p:cNvSpPr txBox="1"/>
           <p:nvPr/>
         </p:nvSpPr>
@@ -6420,6 +6674,41 @@
                 <a:latin typeface="JetBrains Mono"/>
               </a:rPr>
               <a:t>Benedikt Zoller Coaching  ·  FKB Campus  ·  M01</a:t>
+            </a:r>
+          </a:p>
+        </p:txBody>
+      </p:sp>
+      <p:sp>
+        <p:nvSpPr>
+          <p:cNvPr id="10" name="TextBox 9"/>
+          <p:cNvSpPr txBox="1"/>
+          <p:nvPr/>
+        </p:nvSpPr>
+        <p:spPr>
+          <a:xfrm>
+            <a:off x="7176211" y="6583680"/>
+            <a:ext cx="4326940" cy="256032"/>
+          </a:xfrm>
+          <a:prstGeom prst="rect">
+            <a:avLst/>
+          </a:prstGeom>
+          <a:noFill/>
+        </p:spPr>
+        <p:txBody>
+          <a:bodyPr wrap="none">
+            <a:spAutoFit/>
+          </a:bodyPr>
+          <a:lstStyle/>
+          <a:p>
+            <a:pPr algn="r"/>
+            <a:r>
+              <a:rPr sz="700">
+                <a:solidFill>
+                  <a:srgbClr val="A0B4D2"/>
+                </a:solidFill>
+                <a:latin typeface="JetBrains Mono"/>
+              </a:rPr>
+              <a:t>Schaubild</a:t>
             </a:r>
           </a:p>
         </p:txBody>
@@ -6457,7 +6746,7 @@
             <a:avLst/>
           </a:prstGeom>
           <a:solidFill>
-            <a:srgbClr val="FFFFFF"/>
+            <a:srgbClr val="EDEDF3"/>
           </a:solidFill>
           <a:ln>
             <a:noFill/>
@@ -6558,43 +6847,51 @@
                 </a:solidFill>
                 <a:latin typeface="JetBrains Mono"/>
               </a:rPr>
-              <a:t>M01  ·  SCHAUBILD</a:t>
-            </a:r>
-          </a:p>
-        </p:txBody>
-      </p:sp>
-      <p:sp>
-        <p:nvSpPr>
-          <p:cNvPr id="5" name="TextBox 4"/>
-          <p:cNvSpPr txBox="1"/>
-          <p:nvPr/>
-        </p:nvSpPr>
-        <p:spPr>
-          <a:xfrm>
-            <a:off x="685800" y="502920"/>
-            <a:ext cx="10817352" cy="594360"/>
-          </a:xfrm>
-          <a:prstGeom prst="rect">
-            <a:avLst/>
-          </a:prstGeom>
-          <a:noFill/>
-        </p:spPr>
-        <p:txBody>
-          <a:bodyPr wrap="square">
-            <a:spAutoFit/>
-          </a:bodyPr>
-          <a:lstStyle/>
-          <a:p>
-            <a:pPr algn="l"/>
-            <a:r>
-              <a:rPr sz="2000" b="1" i="0">
-                <a:solidFill>
-                  <a:srgbClr val="1F2C56"/>
-                </a:solidFill>
-                <a:latin typeface="Source Serif 4"/>
-              </a:rPr>
-              <a:t>Analyseprozess in vier Schritten</a:t>
-            </a:r>
+              <a:t>M01  ·  ARBEITSBLATT</a:t>
+            </a:r>
+          </a:p>
+        </p:txBody>
+      </p:sp>
+      <p:sp>
+        <p:nvSpPr>
+          <p:cNvPr id="5" name="Rectangle 4"/>
+          <p:cNvSpPr/>
+          <p:nvPr/>
+        </p:nvSpPr>
+        <p:spPr>
+          <a:xfrm>
+            <a:off x="0" y="1234440"/>
+            <a:ext cx="12188952" cy="12700"/>
+          </a:xfrm>
+          <a:prstGeom prst="rect">
+            <a:avLst/>
+          </a:prstGeom>
+          <a:solidFill>
+            <a:srgbClr val="D8DFE4"/>
+          </a:solidFill>
+          <a:ln>
+            <a:noFill/>
+          </a:ln>
+        </p:spPr>
+        <p:style>
+          <a:lnRef idx="1">
+            <a:schemeClr val="accent1"/>
+          </a:lnRef>
+          <a:fillRef idx="3">
+            <a:schemeClr val="accent1"/>
+          </a:fillRef>
+          <a:effectRef idx="2">
+            <a:schemeClr val="accent1"/>
+          </a:effectRef>
+          <a:fontRef idx="minor">
+            <a:schemeClr val="lt1"/>
+          </a:fontRef>
+        </p:style>
+        <p:txBody>
+          <a:bodyPr rtlCol="0" anchor="ctr"/>
+          <a:lstStyle/>
+          <a:p>
+            <a:pPr algn="ctr"/>
           </a:p>
         </p:txBody>
       </p:sp>
@@ -6606,8 +6903,8 @@
         </p:nvSpPr>
         <p:spPr>
           <a:xfrm>
-            <a:off x="685800" y="1143000"/>
-            <a:ext cx="10817352" cy="25400"/>
+            <a:off x="685800" y="502920"/>
+            <a:ext cx="36576" cy="658368"/>
           </a:xfrm>
           <a:prstGeom prst="rect">
             <a:avLst/>
@@ -6641,33 +6938,240 @@
           </a:p>
         </p:txBody>
       </p:sp>
-      <p:pic>
-        <p:nvPicPr>
-          <p:cNvPr id="7" name="Picture 6" descr="image.png"/>
-          <p:cNvPicPr>
-            <a:picLocks noChangeAspect="1"/>
-          </p:cNvPicPr>
-          <p:nvPr/>
-        </p:nvPicPr>
-        <p:blipFill>
-          <a:blip r:embed="rId2"/>
-          <a:stretch>
-            <a:fillRect/>
-          </a:stretch>
-        </p:blipFill>
-        <p:spPr>
-          <a:xfrm>
-            <a:off x="1670951" y="1325880"/>
-            <a:ext cx="8847050" cy="4937760"/>
-          </a:xfrm>
-          <a:prstGeom prst="rect">
-            <a:avLst/>
-          </a:prstGeom>
-        </p:spPr>
-      </p:pic>
-      <p:sp>
-        <p:nvSpPr>
-          <p:cNvPr id="8" name="Rectangle 7"/>
+      <p:sp>
+        <p:nvSpPr>
+          <p:cNvPr id="7" name="TextBox 6"/>
+          <p:cNvSpPr txBox="1"/>
+          <p:nvPr/>
+        </p:nvSpPr>
+        <p:spPr>
+          <a:xfrm>
+            <a:off x="813816" y="502920"/>
+            <a:ext cx="10634472" cy="685800"/>
+          </a:xfrm>
+          <a:prstGeom prst="rect">
+            <a:avLst/>
+          </a:prstGeom>
+          <a:noFill/>
+        </p:spPr>
+        <p:txBody>
+          <a:bodyPr wrap="square">
+            <a:spAutoFit/>
+          </a:bodyPr>
+          <a:lstStyle/>
+          <a:p>
+            <a:pPr algn="l"/>
+            <a:r>
+              <a:rPr sz="2400" b="1" i="0">
+                <a:solidFill>
+                  <a:srgbClr val="1F2C56"/>
+                </a:solidFill>
+                <a:latin typeface="Source Serif 4"/>
+              </a:rPr>
+              <a:t>Praxisfall: Musterbilanz „Bauer GmbH"</a:t>
+            </a:r>
+          </a:p>
+        </p:txBody>
+      </p:sp>
+      <p:sp>
+        <p:nvSpPr>
+          <p:cNvPr id="8" name="TextBox 7"/>
+          <p:cNvSpPr txBox="1"/>
+          <p:nvPr/>
+        </p:nvSpPr>
+        <p:spPr>
+          <a:xfrm>
+            <a:off x="685800" y="1554480"/>
+            <a:ext cx="10817352" cy="3840480"/>
+          </a:xfrm>
+          <a:prstGeom prst="rect">
+            <a:avLst/>
+          </a:prstGeom>
+          <a:noFill/>
+        </p:spPr>
+        <p:txBody>
+          <a:bodyPr wrap="square">
+            <a:spAutoFit/>
+          </a:bodyPr>
+          <a:lstStyle/>
+          <a:p>
+            <a:pPr>
+              <a:spcBef>
+                <a:spcPts val="400"/>
+              </a:spcBef>
+              <a:spcAft>
+                <a:spcPts val="200"/>
+              </a:spcAft>
+            </a:pPr>
+            <a:r>
+              <a:rPr sz="1400">
+                <a:solidFill>
+                  <a:srgbClr val="3D5466"/>
+                </a:solidFill>
+                <a:latin typeface="Arial"/>
+              </a:rPr>
+              <a:t>▸  Unternehmensportrait (anonymisiert, branchentypisch)</a:t>
+            </a:r>
+          </a:p>
+          <a:p>
+            <a:pPr>
+              <a:spcBef>
+                <a:spcPts val="400"/>
+              </a:spcBef>
+              <a:spcAft>
+                <a:spcPts val="200"/>
+              </a:spcAft>
+            </a:pPr>
+            <a:r>
+              <a:rPr sz="1400">
+                <a:solidFill>
+                  <a:srgbClr val="3D5466"/>
+                </a:solidFill>
+                <a:latin typeface="Arial"/>
+              </a:rPr>
+              <a:t>▸  Situation: Der Kunde beantragt ein neues Investitionsdarlehen über 650.000 EUR für eine neue CNC-Fräsmaschine. Sie bereiten die Kreditvorlage vor und lesen den Jahresabschluss 2023.</a:t>
+            </a:r>
+          </a:p>
+          <a:p>
+            <a:pPr>
+              <a:spcBef>
+                <a:spcPts val="400"/>
+              </a:spcBef>
+              <a:spcAft>
+                <a:spcPts val="200"/>
+              </a:spcAft>
+            </a:pPr>
+            <a:r>
+              <a:rPr sz="1400">
+                <a:solidFill>
+                  <a:srgbClr val="3D5466"/>
+                </a:solidFill>
+                <a:latin typeface="Arial"/>
+              </a:rPr>
+              <a:t>▸  Die folgende Handlungsempfehlung verknüpft typische Bilanzsignale mit der passenden Reaktion im Kreditgespräch – nutzen Sie sie als Orientierung bei der Auswertung des Praxisfalls.</a:t>
+            </a:r>
+          </a:p>
+          <a:p>
+            <a:pPr>
+              <a:spcBef>
+                <a:spcPts val="400"/>
+              </a:spcBef>
+              <a:spcAft>
+                <a:spcPts val="200"/>
+              </a:spcAft>
+            </a:pPr>
+            <a:r>
+              <a:rPr sz="1400">
+                <a:solidFill>
+                  <a:srgbClr val="3D5466"/>
+                </a:solidFill>
+                <a:latin typeface="Arial"/>
+              </a:rPr>
+              <a:t>▸  Musterbilanz Bauer GmbH (31.12.2023)</a:t>
+            </a:r>
+          </a:p>
+          <a:p>
+            <a:pPr>
+              <a:spcBef>
+                <a:spcPts val="400"/>
+              </a:spcBef>
+              <a:spcAft>
+                <a:spcPts val="200"/>
+              </a:spcAft>
+            </a:pPr>
+            <a:r>
+              <a:rPr sz="1400">
+                <a:solidFill>
+                  <a:srgbClr val="3D5466"/>
+                </a:solidFill>
+                <a:latin typeface="Arial"/>
+              </a:rPr>
+              <a:t>▸  BILANZ – Aktivseite</a:t>
+            </a:r>
+          </a:p>
+        </p:txBody>
+      </p:sp>
+      <p:sp>
+        <p:nvSpPr>
+          <p:cNvPr id="9" name="Rectangle 8"/>
+          <p:cNvSpPr/>
+          <p:nvPr/>
+        </p:nvSpPr>
+        <p:spPr>
+          <a:xfrm>
+            <a:off x="685800" y="5486400"/>
+            <a:ext cx="10817352" cy="640080"/>
+          </a:xfrm>
+          <a:prstGeom prst="rect">
+            <a:avLst/>
+          </a:prstGeom>
+          <a:solidFill>
+            <a:srgbClr val="1F2C56"/>
+          </a:solidFill>
+          <a:ln>
+            <a:noFill/>
+          </a:ln>
+        </p:spPr>
+        <p:style>
+          <a:lnRef idx="1">
+            <a:schemeClr val="accent1"/>
+          </a:lnRef>
+          <a:fillRef idx="3">
+            <a:schemeClr val="accent1"/>
+          </a:fillRef>
+          <a:effectRef idx="2">
+            <a:schemeClr val="accent1"/>
+          </a:effectRef>
+          <a:fontRef idx="minor">
+            <a:schemeClr val="lt1"/>
+          </a:fontRef>
+        </p:style>
+        <p:txBody>
+          <a:bodyPr rtlCol="0" anchor="ctr"/>
+          <a:lstStyle/>
+          <a:p>
+            <a:pPr algn="ctr"/>
+          </a:p>
+        </p:txBody>
+      </p:sp>
+      <p:sp>
+        <p:nvSpPr>
+          <p:cNvPr id="10" name="TextBox 9"/>
+          <p:cNvSpPr txBox="1"/>
+          <p:nvPr/>
+        </p:nvSpPr>
+        <p:spPr>
+          <a:xfrm>
+            <a:off x="868680" y="5596128"/>
+            <a:ext cx="10451592" cy="457200"/>
+          </a:xfrm>
+          <a:prstGeom prst="rect">
+            <a:avLst/>
+          </a:prstGeom>
+          <a:noFill/>
+        </p:spPr>
+        <p:txBody>
+          <a:bodyPr wrap="square">
+            <a:spAutoFit/>
+          </a:bodyPr>
+          <a:lstStyle/>
+          <a:p>
+            <a:pPr algn="l"/>
+            <a:r>
+              <a:rPr sz="1300" b="1" i="0">
+                <a:solidFill>
+                  <a:srgbClr val="FFFFFF"/>
+                </a:solidFill>
+                <a:latin typeface="Arial"/>
+              </a:rPr>
+              <a:t>→  Bearbeitung im Teilnehmer-Workbook (Arbeitsblatt mit Ausfüllfeldern)</a:t>
+            </a:r>
+          </a:p>
+        </p:txBody>
+      </p:sp>
+      <p:sp>
+        <p:nvSpPr>
+          <p:cNvPr id="11" name="Rectangle 10"/>
           <p:cNvSpPr/>
           <p:nvPr/>
         </p:nvSpPr>
@@ -6710,7 +7214,7 @@
       </p:sp>
       <p:sp>
         <p:nvSpPr>
-          <p:cNvPr id="9" name="TextBox 8"/>
+          <p:cNvPr id="12" name="TextBox 11"/>
           <p:cNvSpPr txBox="1"/>
           <p:nvPr/>
         </p:nvSpPr>
@@ -6739,41 +7243,6 @@
                 <a:latin typeface="JetBrains Mono"/>
               </a:rPr>
               <a:t>Benedikt Zoller Coaching  ·  FKB Campus  ·  M01</a:t>
-            </a:r>
-          </a:p>
-        </p:txBody>
-      </p:sp>
-      <p:sp>
-        <p:nvSpPr>
-          <p:cNvPr id="10" name="TextBox 9"/>
-          <p:cNvSpPr txBox="1"/>
-          <p:nvPr/>
-        </p:nvSpPr>
-        <p:spPr>
-          <a:xfrm>
-            <a:off x="7176211" y="6583680"/>
-            <a:ext cx="4326940" cy="256032"/>
-          </a:xfrm>
-          <a:prstGeom prst="rect">
-            <a:avLst/>
-          </a:prstGeom>
-          <a:noFill/>
-        </p:spPr>
-        <p:txBody>
-          <a:bodyPr wrap="none">
-            <a:spAutoFit/>
-          </a:bodyPr>
-          <a:lstStyle/>
-          <a:p>
-            <a:pPr algn="r"/>
-            <a:r>
-              <a:rPr sz="700">
-                <a:solidFill>
-                  <a:srgbClr val="A0B4D2"/>
-                </a:solidFill>
-                <a:latin typeface="JetBrains Mono"/>
-              </a:rPr>
-              <a:t>Schaubild</a:t>
             </a:r>
           </a:p>
         </p:txBody>
@@ -6947,7 +7416,7 @@
                 </a:solidFill>
                 <a:latin typeface="Source Serif 4"/>
               </a:rPr>
-              <a:t>Handlungsempfehlung</a:t>
+              <a:t>Analyseprozess in vier Schritten</a:t>
             </a:r>
           </a:p>
         </p:txBody>
@@ -7011,8 +7480,8 @@
         </p:blipFill>
         <p:spPr>
           <a:xfrm>
-            <a:off x="2303489" y="1325880"/>
-            <a:ext cx="7581973" cy="4937760"/>
+            <a:off x="1670951" y="1325880"/>
+            <a:ext cx="8847050" cy="4937760"/>
           </a:xfrm>
           <a:prstGeom prst="rect">
             <a:avLst/>
@@ -7165,7 +7634,7 @@
             <a:avLst/>
           </a:prstGeom>
           <a:solidFill>
-            <a:srgbClr val="EDEDF3"/>
+            <a:srgbClr val="FFFFFF"/>
           </a:solidFill>
           <a:ln>
             <a:noFill/>
@@ -7266,51 +7735,43 @@
                 </a:solidFill>
                 <a:latin typeface="JetBrains Mono"/>
               </a:rPr>
-              <a:t>M01  ·  INHALT</a:t>
-            </a:r>
-          </a:p>
-        </p:txBody>
-      </p:sp>
-      <p:sp>
-        <p:nvSpPr>
-          <p:cNvPr id="5" name="Rectangle 4"/>
-          <p:cNvSpPr/>
-          <p:nvPr/>
-        </p:nvSpPr>
-        <p:spPr>
-          <a:xfrm>
-            <a:off x="0" y="1234440"/>
-            <a:ext cx="12188952" cy="12700"/>
-          </a:xfrm>
-          <a:prstGeom prst="rect">
-            <a:avLst/>
-          </a:prstGeom>
-          <a:solidFill>
-            <a:srgbClr val="D8DFE4"/>
-          </a:solidFill>
-          <a:ln>
-            <a:noFill/>
-          </a:ln>
-        </p:spPr>
-        <p:style>
-          <a:lnRef idx="1">
-            <a:schemeClr val="accent1"/>
-          </a:lnRef>
-          <a:fillRef idx="3">
-            <a:schemeClr val="accent1"/>
-          </a:fillRef>
-          <a:effectRef idx="2">
-            <a:schemeClr val="accent1"/>
-          </a:effectRef>
-          <a:fontRef idx="minor">
-            <a:schemeClr val="lt1"/>
-          </a:fontRef>
-        </p:style>
-        <p:txBody>
-          <a:bodyPr rtlCol="0" anchor="ctr"/>
-          <a:lstStyle/>
-          <a:p>
-            <a:pPr algn="ctr"/>
+              <a:t>M01  ·  SCHAUBILD</a:t>
+            </a:r>
+          </a:p>
+        </p:txBody>
+      </p:sp>
+      <p:sp>
+        <p:nvSpPr>
+          <p:cNvPr id="5" name="TextBox 4"/>
+          <p:cNvSpPr txBox="1"/>
+          <p:nvPr/>
+        </p:nvSpPr>
+        <p:spPr>
+          <a:xfrm>
+            <a:off x="685800" y="502920"/>
+            <a:ext cx="10817352" cy="594360"/>
+          </a:xfrm>
+          <a:prstGeom prst="rect">
+            <a:avLst/>
+          </a:prstGeom>
+          <a:noFill/>
+        </p:spPr>
+        <p:txBody>
+          <a:bodyPr wrap="square">
+            <a:spAutoFit/>
+          </a:bodyPr>
+          <a:lstStyle/>
+          <a:p>
+            <a:pPr algn="l"/>
+            <a:r>
+              <a:rPr sz="2000" b="1" i="0">
+                <a:solidFill>
+                  <a:srgbClr val="1F2C56"/>
+                </a:solidFill>
+                <a:latin typeface="Source Serif 4"/>
+              </a:rPr>
+              <a:t>Handlungsempfehlung</a:t>
+            </a:r>
           </a:p>
         </p:txBody>
       </p:sp>
@@ -7322,8 +7783,8 @@
         </p:nvSpPr>
         <p:spPr>
           <a:xfrm>
-            <a:off x="685800" y="502920"/>
-            <a:ext cx="36576" cy="658368"/>
+            <a:off x="685800" y="1143000"/>
+            <a:ext cx="10817352" cy="25400"/>
           </a:xfrm>
           <a:prstGeom prst="rect">
             <a:avLst/>
@@ -7357,162 +7818,33 @@
           </a:p>
         </p:txBody>
       </p:sp>
-      <p:sp>
-        <p:nvSpPr>
-          <p:cNvPr id="7" name="TextBox 6"/>
-          <p:cNvSpPr txBox="1"/>
-          <p:nvPr/>
-        </p:nvSpPr>
-        <p:spPr>
-          <a:xfrm>
-            <a:off x="813816" y="502920"/>
-            <a:ext cx="10634472" cy="685800"/>
-          </a:xfrm>
-          <a:prstGeom prst="rect">
-            <a:avLst/>
-          </a:prstGeom>
-          <a:noFill/>
-        </p:spPr>
-        <p:txBody>
-          <a:bodyPr wrap="square">
-            <a:spAutoFit/>
-          </a:bodyPr>
-          <a:lstStyle/>
-          <a:p>
-            <a:pPr algn="l"/>
-            <a:r>
-              <a:rPr sz="2400" b="1" i="0">
-                <a:solidFill>
-                  <a:srgbClr val="1F2C56"/>
-                </a:solidFill>
-                <a:latin typeface="Source Serif 4"/>
-              </a:rPr>
-              <a:t>Reflexionsfragen</a:t>
-            </a:r>
-          </a:p>
-        </p:txBody>
-      </p:sp>
-      <p:sp>
-        <p:nvSpPr>
-          <p:cNvPr id="8" name="TextBox 7"/>
-          <p:cNvSpPr txBox="1"/>
-          <p:nvPr/>
-        </p:nvSpPr>
-        <p:spPr>
-          <a:xfrm>
-            <a:off x="685800" y="1417320"/>
-            <a:ext cx="10817352" cy="5029200"/>
-          </a:xfrm>
-          <a:prstGeom prst="rect">
-            <a:avLst/>
-          </a:prstGeom>
-          <a:noFill/>
-        </p:spPr>
-        <p:txBody>
-          <a:bodyPr wrap="square">
-            <a:spAutoFit/>
-          </a:bodyPr>
-          <a:lstStyle/>
-          <a:p>
-            <a:pPr>
-              <a:spcBef>
-                <a:spcPts val="400"/>
-              </a:spcBef>
-              <a:spcAft>
-                <a:spcPts val="200"/>
-              </a:spcAft>
-            </a:pPr>
-            <a:r>
-              <a:rPr sz="1200">
-                <a:solidFill>
-                  <a:srgbClr val="3D5466"/>
-                </a:solidFill>
-                <a:latin typeface="Arial"/>
-              </a:rPr>
-              <a:t>Beantworten Sie diese Fragen am Ende des Moduls schriftlich (5 Minuten):</a:t>
-            </a:r>
-          </a:p>
-          <a:p>
-            <a:pPr>
-              <a:spcBef>
-                <a:spcPts val="400"/>
-              </a:spcBef>
-              <a:spcAft>
-                <a:spcPts val="200"/>
-              </a:spcAft>
-            </a:pPr>
-            <a:r>
-              <a:rPr sz="1300">
-                <a:solidFill>
-                  <a:srgbClr val="3D5466"/>
-                </a:solidFill>
-                <a:latin typeface="Arial"/>
-              </a:rPr>
-              <a:t>▸  Welche der sechs Kennzahlen war Ihnen vor diesem Modul noch unklar?</a:t>
-            </a:r>
-          </a:p>
-          <a:p>
-            <a:pPr>
-              <a:spcBef>
-                <a:spcPts val="400"/>
-              </a:spcBef>
-              <a:spcAft>
-                <a:spcPts val="200"/>
-              </a:spcAft>
-            </a:pPr>
-            <a:r>
-              <a:rPr sz="1300">
-                <a:solidFill>
-                  <a:srgbClr val="3D5466"/>
-                </a:solidFill>
-                <a:latin typeface="Arial"/>
-              </a:rPr>
-              <a:t>▸  Was ist der kritischste Befund in der Bauer GmbH-Analyse? Wie würden Sie ihn im Kundengespräch ansprechen?</a:t>
-            </a:r>
-          </a:p>
-          <a:p>
-            <a:pPr>
-              <a:spcBef>
-                <a:spcPts val="400"/>
-              </a:spcBef>
-              <a:spcAft>
-                <a:spcPts val="200"/>
-              </a:spcAft>
-            </a:pPr>
-            <a:r>
-              <a:rPr sz="1300">
-                <a:solidFill>
-                  <a:srgbClr val="3D5466"/>
-                </a:solidFill>
-                <a:latin typeface="Arial"/>
-              </a:rPr>
-              <a:t>▸  Welcher Kunde in Ihrem Portfolio kommt Ihnen beim Blick auf die Bauer-Bilanz spontan in den Sinn?</a:t>
-            </a:r>
-          </a:p>
-          <a:p>
-            <a:pPr>
-              <a:spcBef>
-                <a:spcPts val="400"/>
-              </a:spcBef>
-              <a:spcAft>
-                <a:spcPts val="200"/>
-              </a:spcAft>
-            </a:pPr>
-            <a:r>
-              <a:rPr sz="1300">
-                <a:solidFill>
-                  <a:srgbClr val="3D5466"/>
-                </a:solidFill>
-                <a:latin typeface="Arial"/>
-              </a:rPr>
-              <a:t>▸  Was werden Sie konkret in den nächsten 30 Tagen anders machen, wenn ein Jahresabschluss auf Ihrem Tisch liegt?</a:t>
-            </a:r>
-          </a:p>
-        </p:txBody>
-      </p:sp>
-      <p:sp>
-        <p:nvSpPr>
-          <p:cNvPr id="9" name="Rectangle 8"/>
+      <p:pic>
+        <p:nvPicPr>
+          <p:cNvPr id="7" name="Picture 6" descr="image.png"/>
+          <p:cNvPicPr>
+            <a:picLocks noChangeAspect="1"/>
+          </p:cNvPicPr>
+          <p:nvPr/>
+        </p:nvPicPr>
+        <p:blipFill>
+          <a:blip r:embed="rId2"/>
+          <a:stretch>
+            <a:fillRect/>
+          </a:stretch>
+        </p:blipFill>
+        <p:spPr>
+          <a:xfrm>
+            <a:off x="2303489" y="1325880"/>
+            <a:ext cx="7581973" cy="4937760"/>
+          </a:xfrm>
+          <a:prstGeom prst="rect">
+            <a:avLst/>
+          </a:prstGeom>
+        </p:spPr>
+      </p:pic>
+      <p:sp>
+        <p:nvSpPr>
+          <p:cNvPr id="8" name="Rectangle 7"/>
           <p:cNvSpPr/>
           <p:nvPr/>
         </p:nvSpPr>
@@ -7555,7 +7887,7 @@
       </p:sp>
       <p:sp>
         <p:nvSpPr>
-          <p:cNvPr id="10" name="TextBox 9"/>
+          <p:cNvPr id="9" name="TextBox 8"/>
           <p:cNvSpPr txBox="1"/>
           <p:nvPr/>
         </p:nvSpPr>
@@ -7584,6 +7916,41 @@
                 <a:latin typeface="JetBrains Mono"/>
               </a:rPr>
               <a:t>Benedikt Zoller Coaching  ·  FKB Campus  ·  M01</a:t>
+            </a:r>
+          </a:p>
+        </p:txBody>
+      </p:sp>
+      <p:sp>
+        <p:nvSpPr>
+          <p:cNvPr id="10" name="TextBox 9"/>
+          <p:cNvSpPr txBox="1"/>
+          <p:nvPr/>
+        </p:nvSpPr>
+        <p:spPr>
+          <a:xfrm>
+            <a:off x="7176211" y="6583680"/>
+            <a:ext cx="4326940" cy="256032"/>
+          </a:xfrm>
+          <a:prstGeom prst="rect">
+            <a:avLst/>
+          </a:prstGeom>
+          <a:noFill/>
+        </p:spPr>
+        <p:txBody>
+          <a:bodyPr wrap="none">
+            <a:spAutoFit/>
+          </a:bodyPr>
+          <a:lstStyle/>
+          <a:p>
+            <a:pPr algn="r"/>
+            <a:r>
+              <a:rPr sz="700">
+                <a:solidFill>
+                  <a:srgbClr val="A0B4D2"/>
+                </a:solidFill>
+                <a:latin typeface="JetBrains Mono"/>
+              </a:rPr>
+              <a:t>Schaubild</a:t>
             </a:r>
           </a:p>
         </p:txBody>

</xml_diff>

<commit_message>
Trainer-Decks aus kuratierten Folienskripten regeneriert (Agenda + Tabellen-Folien)
Co-Authored-By: Claude Fable 5 <noreply@anthropic.com>
</commit_message>
<xml_diff>
--- a/protected-downloads/praesentation/M01.pptx
+++ b/protected-downloads/praesentation/M01.pptx
@@ -15,6 +15,9 @@
     <p:sldId id="263" r:id="rId15"/>
     <p:sldId id="264" r:id="rId16"/>
     <p:sldId id="265" r:id="rId17"/>
+    <p:sldId id="266" r:id="rId18"/>
+    <p:sldId id="267" r:id="rId19"/>
+    <p:sldId id="268" r:id="rId20"/>
   </p:sldIdLst>
   <p:sldSz cx="12188952" cy="6858000" type="screen4x3"/>
   <p:notesSz cx="6858000" cy="9144000"/>
@@ -511,7 +514,7 @@
           <a:lstStyle/>
           <a:p>
             <a:r>
-              <a:t>Siehe Trainerhandbuch (Sektion 3) für Moderationshinweise, Timing und erwartete Teilnehmerreaktionen.</a:t>
+              <a:t>Agenda aus dem Ablaufplan (Sektion 3.1). Timing und Pausen siehe Trainerhandbuch.</a:t>
             </a:r>
           </a:p>
         </p:txBody>
@@ -581,12 +584,7 @@
           <a:lstStyle/>
           <a:p>
             <a:r>
-              <a:t>AB-2 Musterlösung (Trainer-Version)</a:t>
-            </a:r>
-          </a:p>
-          <a:p>
-            <a:r>
-              <a:t>Trainer-Hinweis Anlagendeckung II: Langfristiges FK = Bankverbindlichkeiten (1.580) abzgl. kurzfristigem Anteil (340) = 1.240 TEUR + Gesellschafterdarlehen 680 TEUR. Ohne Rangrücktrittsvertrag beim Gesellschafterdarlehen: (802 + 1.240) / 2.400 = 84,3 % → Gelb. Wichtiger Nachfragepunkt im Kundengespräch!</a:t>
+              <a:t>Siehe Trainerhandbuch (Sektion 3) für Moderationshinweise, Timing und erwartete Teilnehmerreaktionen.</a:t>
             </a:r>
           </a:p>
         </p:txBody>
@@ -612,6 +610,81 @@
 </file>
 
 <file path=ppt/notesSlides/notesSlide3.xml><?xml version="1.0" encoding="utf-8"?>
+<p:notes xmlns:a="http://schemas.openxmlformats.org/drawingml/2006/main" xmlns:p="http://schemas.openxmlformats.org/presentationml/2006/main" xmlns:r="http://schemas.openxmlformats.org/officeDocument/2006/relationships">
+  <p:cSld>
+    <p:spTree>
+      <p:nvGrpSpPr>
+        <p:cNvPr id="1" name=""/>
+        <p:cNvGrpSpPr/>
+        <p:nvPr/>
+      </p:nvGrpSpPr>
+      <p:grpSpPr>
+        <a:xfrm>
+          <a:off x="0" y="0"/>
+          <a:ext cx="0" cy="0"/>
+          <a:chOff x="0" y="0"/>
+          <a:chExt cx="0" cy="0"/>
+        </a:xfrm>
+      </p:grpSpPr>
+      <p:sp>
+        <p:nvSpPr>
+          <p:cNvPr id="2" name="Slide Image Placeholder 1"/>
+          <p:cNvSpPr>
+            <a:spLocks noGrp="1"/>
+          </p:cNvSpPr>
+          <p:nvPr>
+            <p:ph type="sldImg" idx="2"/>
+          </p:nvPr>
+        </p:nvSpPr>
+        <p:spPr/>
+      </p:sp>
+      <p:sp>
+        <p:nvSpPr>
+          <p:cNvPr id="3" name="Notes Placeholder 2"/>
+          <p:cNvSpPr>
+            <a:spLocks noGrp="1"/>
+          </p:cNvSpPr>
+          <p:nvPr>
+            <p:ph type="body" idx="3" sz="quarter"/>
+          </p:nvPr>
+        </p:nvSpPr>
+        <p:spPr/>
+        <p:txBody>
+          <a:bodyPr/>
+          <a:lstStyle/>
+          <a:p>
+            <a:r>
+              <a:t>AB-2 Musterlösung (Trainer-Version)</a:t>
+            </a:r>
+          </a:p>
+          <a:p>
+            <a:r>
+              <a:t>Trainer-Hinweis Anlagendeckung II: Langfristiges FK = Bankverbindlichkeiten (1.580) abzgl. kurzfristigem Anteil (340) = 1.240 TEUR + Gesellschafterdarlehen 680 TEUR. Ohne Rangrücktrittsvertrag beim Gesellschafterdarlehen: (802 + 1.240) / 2.400 = 84,3 % → Gelb. Wichtiger Nachfragepunkt im Kundengespräch!</a:t>
+            </a:r>
+          </a:p>
+        </p:txBody>
+      </p:sp>
+      <p:sp>
+        <p:nvSpPr>
+          <p:cNvPr id="4" name="Slide Number Placeholder 3"/>
+          <p:cNvSpPr>
+            <a:spLocks noGrp="1"/>
+          </p:cNvSpPr>
+          <p:nvPr>
+            <p:ph type="sldNum" idx="5" sz="quarter"/>
+          </p:nvPr>
+        </p:nvSpPr>
+        <p:spPr/>
+      </p:sp>
+    </p:spTree>
+  </p:cSld>
+  <p:clrMapOvr>
+    <a:masterClrMapping/>
+  </p:clrMapOvr>
+</p:notes>
+</file>
+
+<file path=ppt/notesSlides/notesSlide4.xml><?xml version="1.0" encoding="utf-8"?>
 <p:notes xmlns:a="http://schemas.openxmlformats.org/drawingml/2006/main" xmlns:p="http://schemas.openxmlformats.org/presentationml/2006/main" xmlns:r="http://schemas.openxmlformats.org/officeDocument/2006/relationships">
   <p:cSld>
     <p:spTree>
@@ -4353,7 +4426,7 @@
                 </a:solidFill>
                 <a:latin typeface="JetBrains Mono"/>
               </a:rPr>
-              <a:t>M01  ·  INHALT</a:t>
+              <a:t>M01  ·  ARBEITSBLATT</a:t>
             </a:r>
           </a:p>
         </p:txBody>
@@ -4474,7 +4547,7 @@
                 </a:solidFill>
                 <a:latin typeface="Source Serif 4"/>
               </a:rPr>
-              <a:t>Reflexionsfragen</a:t>
+              <a:t>Praxisfall: Musterbilanz „Bauer GmbH"</a:t>
             </a:r>
           </a:p>
         </p:txBody>
@@ -4487,8 +4560,8 @@
         </p:nvSpPr>
         <p:spPr>
           <a:xfrm>
-            <a:off x="685800" y="1417320"/>
-            <a:ext cx="10817352" cy="5029200"/>
+            <a:off x="685800" y="1554480"/>
+            <a:ext cx="10817352" cy="3840480"/>
           </a:xfrm>
           <a:prstGeom prst="rect">
             <a:avLst/>
@@ -4510,13 +4583,1255 @@
               </a:spcAft>
             </a:pPr>
             <a:r>
-              <a:rPr sz="1200">
+              <a:rPr sz="1400">
                 <a:solidFill>
                   <a:srgbClr val="3D5466"/>
                 </a:solidFill>
                 <a:latin typeface="Arial"/>
               </a:rPr>
-              <a:t>Beantworten Sie diese Fragen am Ende des Moduls schriftlich (5 Minuten):</a:t>
+              <a:t>▸  Unternehmensportrait (anonymisiert, branchentypisch)</a:t>
+            </a:r>
+          </a:p>
+          <a:p>
+            <a:pPr>
+              <a:spcBef>
+                <a:spcPts val="400"/>
+              </a:spcBef>
+              <a:spcAft>
+                <a:spcPts val="200"/>
+              </a:spcAft>
+            </a:pPr>
+            <a:r>
+              <a:rPr sz="1400">
+                <a:solidFill>
+                  <a:srgbClr val="3D5466"/>
+                </a:solidFill>
+                <a:latin typeface="Arial"/>
+              </a:rPr>
+              <a:t>▸  Situation: Der Kunde beantragt ein neues Investitionsdarlehen über 650.000 EUR für eine neue CNC-Fräsmaschine. Sie bereiten die Kreditvorlage vor und lesen den Jahresabschluss 2023.</a:t>
+            </a:r>
+          </a:p>
+          <a:p>
+            <a:pPr>
+              <a:spcBef>
+                <a:spcPts val="400"/>
+              </a:spcBef>
+              <a:spcAft>
+                <a:spcPts val="200"/>
+              </a:spcAft>
+            </a:pPr>
+            <a:r>
+              <a:rPr sz="1400">
+                <a:solidFill>
+                  <a:srgbClr val="3D5466"/>
+                </a:solidFill>
+                <a:latin typeface="Arial"/>
+              </a:rPr>
+              <a:t>▸  Die folgende Handlungsempfehlung verknüpft typische Bilanzsignale mit der passenden Reaktion im Kreditgespräch – nutzen Sie sie als Orientierung bei der Auswertung des Praxisfalls.</a:t>
+            </a:r>
+          </a:p>
+          <a:p>
+            <a:pPr>
+              <a:spcBef>
+                <a:spcPts val="400"/>
+              </a:spcBef>
+              <a:spcAft>
+                <a:spcPts val="200"/>
+              </a:spcAft>
+            </a:pPr>
+            <a:r>
+              <a:rPr sz="1400">
+                <a:solidFill>
+                  <a:srgbClr val="3D5466"/>
+                </a:solidFill>
+                <a:latin typeface="Arial"/>
+              </a:rPr>
+              <a:t>▸  Musterbilanz Bauer GmbH (31.12.2023)</a:t>
+            </a:r>
+          </a:p>
+          <a:p>
+            <a:pPr>
+              <a:spcBef>
+                <a:spcPts val="400"/>
+              </a:spcBef>
+              <a:spcAft>
+                <a:spcPts val="200"/>
+              </a:spcAft>
+            </a:pPr>
+            <a:r>
+              <a:rPr sz="1400">
+                <a:solidFill>
+                  <a:srgbClr val="3D5466"/>
+                </a:solidFill>
+                <a:latin typeface="Arial"/>
+              </a:rPr>
+              <a:t>▸  BILANZ – Aktivseite</a:t>
+            </a:r>
+          </a:p>
+        </p:txBody>
+      </p:sp>
+      <p:sp>
+        <p:nvSpPr>
+          <p:cNvPr id="9" name="Rectangle 8"/>
+          <p:cNvSpPr/>
+          <p:nvPr/>
+        </p:nvSpPr>
+        <p:spPr>
+          <a:xfrm>
+            <a:off x="685800" y="5486400"/>
+            <a:ext cx="10817352" cy="640080"/>
+          </a:xfrm>
+          <a:prstGeom prst="rect">
+            <a:avLst/>
+          </a:prstGeom>
+          <a:solidFill>
+            <a:srgbClr val="1F2C56"/>
+          </a:solidFill>
+          <a:ln>
+            <a:noFill/>
+          </a:ln>
+        </p:spPr>
+        <p:style>
+          <a:lnRef idx="1">
+            <a:schemeClr val="accent1"/>
+          </a:lnRef>
+          <a:fillRef idx="3">
+            <a:schemeClr val="accent1"/>
+          </a:fillRef>
+          <a:effectRef idx="2">
+            <a:schemeClr val="accent1"/>
+          </a:effectRef>
+          <a:fontRef idx="minor">
+            <a:schemeClr val="lt1"/>
+          </a:fontRef>
+        </p:style>
+        <p:txBody>
+          <a:bodyPr rtlCol="0" anchor="ctr"/>
+          <a:lstStyle/>
+          <a:p>
+            <a:pPr algn="ctr"/>
+          </a:p>
+        </p:txBody>
+      </p:sp>
+      <p:sp>
+        <p:nvSpPr>
+          <p:cNvPr id="10" name="TextBox 9"/>
+          <p:cNvSpPr txBox="1"/>
+          <p:nvPr/>
+        </p:nvSpPr>
+        <p:spPr>
+          <a:xfrm>
+            <a:off x="868680" y="5596128"/>
+            <a:ext cx="10451592" cy="457200"/>
+          </a:xfrm>
+          <a:prstGeom prst="rect">
+            <a:avLst/>
+          </a:prstGeom>
+          <a:noFill/>
+        </p:spPr>
+        <p:txBody>
+          <a:bodyPr wrap="square">
+            <a:spAutoFit/>
+          </a:bodyPr>
+          <a:lstStyle/>
+          <a:p>
+            <a:pPr algn="l"/>
+            <a:r>
+              <a:rPr sz="1300" b="1" i="0">
+                <a:solidFill>
+                  <a:srgbClr val="FFFFFF"/>
+                </a:solidFill>
+                <a:latin typeface="Arial"/>
+              </a:rPr>
+              <a:t>→  Bearbeitung im Teilnehmer-Workbook (Arbeitsblatt mit Ausfüllfeldern)</a:t>
+            </a:r>
+          </a:p>
+        </p:txBody>
+      </p:sp>
+      <p:sp>
+        <p:nvSpPr>
+          <p:cNvPr id="11" name="Rectangle 10"/>
+          <p:cNvSpPr/>
+          <p:nvPr/>
+        </p:nvSpPr>
+        <p:spPr>
+          <a:xfrm>
+            <a:off x="0" y="6510528"/>
+            <a:ext cx="12188952" cy="347472"/>
+          </a:xfrm>
+          <a:prstGeom prst="rect">
+            <a:avLst/>
+          </a:prstGeom>
+          <a:solidFill>
+            <a:srgbClr val="0A1937"/>
+          </a:solidFill>
+          <a:ln>
+            <a:noFill/>
+          </a:ln>
+        </p:spPr>
+        <p:style>
+          <a:lnRef idx="1">
+            <a:schemeClr val="accent1"/>
+          </a:lnRef>
+          <a:fillRef idx="3">
+            <a:schemeClr val="accent1"/>
+          </a:fillRef>
+          <a:effectRef idx="2">
+            <a:schemeClr val="accent1"/>
+          </a:effectRef>
+          <a:fontRef idx="minor">
+            <a:schemeClr val="lt1"/>
+          </a:fontRef>
+        </p:style>
+        <p:txBody>
+          <a:bodyPr rtlCol="0" anchor="ctr"/>
+          <a:lstStyle/>
+          <a:p>
+            <a:pPr algn="ctr"/>
+          </a:p>
+        </p:txBody>
+      </p:sp>
+      <p:sp>
+        <p:nvSpPr>
+          <p:cNvPr id="12" name="TextBox 11"/>
+          <p:cNvSpPr txBox="1"/>
+          <p:nvPr/>
+        </p:nvSpPr>
+        <p:spPr>
+          <a:xfrm>
+            <a:off x="685800" y="6583680"/>
+            <a:ext cx="6490411" cy="256032"/>
+          </a:xfrm>
+          <a:prstGeom prst="rect">
+            <a:avLst/>
+          </a:prstGeom>
+          <a:noFill/>
+        </p:spPr>
+        <p:txBody>
+          <a:bodyPr wrap="none">
+            <a:spAutoFit/>
+          </a:bodyPr>
+          <a:lstStyle/>
+          <a:p>
+            <a:pPr algn="l"/>
+            <a:r>
+              <a:rPr sz="700">
+                <a:solidFill>
+                  <a:srgbClr val="A0B4D2"/>
+                </a:solidFill>
+                <a:latin typeface="JetBrains Mono"/>
+              </a:rPr>
+              <a:t>Benedikt Zoller Coaching  ·  FKB Campus  ·  M01</a:t>
+            </a:r>
+          </a:p>
+        </p:txBody>
+      </p:sp>
+    </p:spTree>
+  </p:cSld>
+  <p:clrMapOvr>
+    <a:masterClrMapping/>
+  </p:clrMapOvr>
+</p:sld>
+</file>
+
+<file path=ppt/slides/slide11.xml><?xml version="1.0" encoding="utf-8"?>
+<p:sld xmlns:a="http://schemas.openxmlformats.org/drawingml/2006/main" xmlns:p="http://schemas.openxmlformats.org/presentationml/2006/main" xmlns:r="http://schemas.openxmlformats.org/officeDocument/2006/relationships">
+  <p:cSld>
+    <p:spTree>
+      <p:nvGrpSpPr>
+        <p:cNvPr id="1" name=""/>
+        <p:cNvGrpSpPr/>
+        <p:nvPr/>
+      </p:nvGrpSpPr>
+      <p:grpSpPr/>
+      <p:sp>
+        <p:nvSpPr>
+          <p:cNvPr id="2" name="Rectangle 1"/>
+          <p:cNvSpPr/>
+          <p:nvPr/>
+        </p:nvSpPr>
+        <p:spPr>
+          <a:xfrm>
+            <a:off x="0" y="0"/>
+            <a:ext cx="12188952" cy="6858000"/>
+          </a:xfrm>
+          <a:prstGeom prst="rect">
+            <a:avLst/>
+          </a:prstGeom>
+          <a:solidFill>
+            <a:srgbClr val="FFFFFF"/>
+          </a:solidFill>
+          <a:ln>
+            <a:noFill/>
+          </a:ln>
+        </p:spPr>
+        <p:style>
+          <a:lnRef idx="1">
+            <a:schemeClr val="accent1"/>
+          </a:lnRef>
+          <a:fillRef idx="3">
+            <a:schemeClr val="accent1"/>
+          </a:fillRef>
+          <a:effectRef idx="2">
+            <a:schemeClr val="accent1"/>
+          </a:effectRef>
+          <a:fontRef idx="minor">
+            <a:schemeClr val="lt1"/>
+          </a:fontRef>
+        </p:style>
+        <p:txBody>
+          <a:bodyPr rtlCol="0" anchor="ctr"/>
+          <a:lstStyle/>
+          <a:p>
+            <a:pPr algn="ctr"/>
+          </a:p>
+        </p:txBody>
+      </p:sp>
+      <p:sp>
+        <p:nvSpPr>
+          <p:cNvPr id="3" name="Rectangle 2"/>
+          <p:cNvSpPr/>
+          <p:nvPr/>
+        </p:nvSpPr>
+        <p:spPr>
+          <a:xfrm>
+            <a:off x="0" y="0"/>
+            <a:ext cx="12188952" cy="50292"/>
+          </a:xfrm>
+          <a:prstGeom prst="rect">
+            <a:avLst/>
+          </a:prstGeom>
+          <a:solidFill>
+            <a:srgbClr val="1F2C56"/>
+          </a:solidFill>
+          <a:ln>
+            <a:noFill/>
+          </a:ln>
+        </p:spPr>
+        <p:style>
+          <a:lnRef idx="1">
+            <a:schemeClr val="accent1"/>
+          </a:lnRef>
+          <a:fillRef idx="3">
+            <a:schemeClr val="accent1"/>
+          </a:fillRef>
+          <a:effectRef idx="2">
+            <a:schemeClr val="accent1"/>
+          </a:effectRef>
+          <a:fontRef idx="minor">
+            <a:schemeClr val="lt1"/>
+          </a:fontRef>
+        </p:style>
+        <p:txBody>
+          <a:bodyPr rtlCol="0" anchor="ctr"/>
+          <a:lstStyle/>
+          <a:p>
+            <a:pPr algn="ctr"/>
+          </a:p>
+        </p:txBody>
+      </p:sp>
+      <p:sp>
+        <p:nvSpPr>
+          <p:cNvPr id="4" name="TextBox 3"/>
+          <p:cNvSpPr txBox="1"/>
+          <p:nvPr/>
+        </p:nvSpPr>
+        <p:spPr>
+          <a:xfrm>
+            <a:off x="685800" y="109728"/>
+            <a:ext cx="10817352" cy="228600"/>
+          </a:xfrm>
+          <a:prstGeom prst="rect">
+            <a:avLst/>
+          </a:prstGeom>
+          <a:noFill/>
+        </p:spPr>
+        <p:txBody>
+          <a:bodyPr wrap="none">
+            <a:spAutoFit/>
+          </a:bodyPr>
+          <a:lstStyle/>
+          <a:p>
+            <a:pPr algn="l"/>
+            <a:r>
+              <a:rPr sz="750">
+                <a:solidFill>
+                  <a:srgbClr val="78808C"/>
+                </a:solidFill>
+                <a:latin typeface="JetBrains Mono"/>
+              </a:rPr>
+              <a:t>M01  ·  SCHAUBILD</a:t>
+            </a:r>
+          </a:p>
+        </p:txBody>
+      </p:sp>
+      <p:sp>
+        <p:nvSpPr>
+          <p:cNvPr id="5" name="TextBox 4"/>
+          <p:cNvSpPr txBox="1"/>
+          <p:nvPr/>
+        </p:nvSpPr>
+        <p:spPr>
+          <a:xfrm>
+            <a:off x="685800" y="502920"/>
+            <a:ext cx="10817352" cy="594360"/>
+          </a:xfrm>
+          <a:prstGeom prst="rect">
+            <a:avLst/>
+          </a:prstGeom>
+          <a:noFill/>
+        </p:spPr>
+        <p:txBody>
+          <a:bodyPr wrap="square">
+            <a:spAutoFit/>
+          </a:bodyPr>
+          <a:lstStyle/>
+          <a:p>
+            <a:pPr algn="l"/>
+            <a:r>
+              <a:rPr sz="2000" b="1" i="0">
+                <a:solidFill>
+                  <a:srgbClr val="1F2C56"/>
+                </a:solidFill>
+                <a:latin typeface="Source Serif 4"/>
+              </a:rPr>
+              <a:t>Analyseprozess in vier Schritten</a:t>
+            </a:r>
+          </a:p>
+        </p:txBody>
+      </p:sp>
+      <p:sp>
+        <p:nvSpPr>
+          <p:cNvPr id="6" name="Rectangle 5"/>
+          <p:cNvSpPr/>
+          <p:nvPr/>
+        </p:nvSpPr>
+        <p:spPr>
+          <a:xfrm>
+            <a:off x="685800" y="1143000"/>
+            <a:ext cx="10817352" cy="25400"/>
+          </a:xfrm>
+          <a:prstGeom prst="rect">
+            <a:avLst/>
+          </a:prstGeom>
+          <a:solidFill>
+            <a:srgbClr val="D9C089"/>
+          </a:solidFill>
+          <a:ln>
+            <a:noFill/>
+          </a:ln>
+        </p:spPr>
+        <p:style>
+          <a:lnRef idx="1">
+            <a:schemeClr val="accent1"/>
+          </a:lnRef>
+          <a:fillRef idx="3">
+            <a:schemeClr val="accent1"/>
+          </a:fillRef>
+          <a:effectRef idx="2">
+            <a:schemeClr val="accent1"/>
+          </a:effectRef>
+          <a:fontRef idx="minor">
+            <a:schemeClr val="lt1"/>
+          </a:fontRef>
+        </p:style>
+        <p:txBody>
+          <a:bodyPr rtlCol="0" anchor="ctr"/>
+          <a:lstStyle/>
+          <a:p>
+            <a:pPr algn="ctr"/>
+          </a:p>
+        </p:txBody>
+      </p:sp>
+      <p:pic>
+        <p:nvPicPr>
+          <p:cNvPr id="7" name="Picture 6" descr="image.png"/>
+          <p:cNvPicPr>
+            <a:picLocks noChangeAspect="1"/>
+          </p:cNvPicPr>
+          <p:nvPr/>
+        </p:nvPicPr>
+        <p:blipFill>
+          <a:blip r:embed="rId2"/>
+          <a:stretch>
+            <a:fillRect/>
+          </a:stretch>
+        </p:blipFill>
+        <p:spPr>
+          <a:xfrm>
+            <a:off x="1670951" y="1325880"/>
+            <a:ext cx="8847050" cy="4937760"/>
+          </a:xfrm>
+          <a:prstGeom prst="rect">
+            <a:avLst/>
+          </a:prstGeom>
+        </p:spPr>
+      </p:pic>
+      <p:sp>
+        <p:nvSpPr>
+          <p:cNvPr id="8" name="Rectangle 7"/>
+          <p:cNvSpPr/>
+          <p:nvPr/>
+        </p:nvSpPr>
+        <p:spPr>
+          <a:xfrm>
+            <a:off x="0" y="6510528"/>
+            <a:ext cx="12188952" cy="347472"/>
+          </a:xfrm>
+          <a:prstGeom prst="rect">
+            <a:avLst/>
+          </a:prstGeom>
+          <a:solidFill>
+            <a:srgbClr val="0A1937"/>
+          </a:solidFill>
+          <a:ln>
+            <a:noFill/>
+          </a:ln>
+        </p:spPr>
+        <p:style>
+          <a:lnRef idx="1">
+            <a:schemeClr val="accent1"/>
+          </a:lnRef>
+          <a:fillRef idx="3">
+            <a:schemeClr val="accent1"/>
+          </a:fillRef>
+          <a:effectRef idx="2">
+            <a:schemeClr val="accent1"/>
+          </a:effectRef>
+          <a:fontRef idx="minor">
+            <a:schemeClr val="lt1"/>
+          </a:fontRef>
+        </p:style>
+        <p:txBody>
+          <a:bodyPr rtlCol="0" anchor="ctr"/>
+          <a:lstStyle/>
+          <a:p>
+            <a:pPr algn="ctr"/>
+          </a:p>
+        </p:txBody>
+      </p:sp>
+      <p:sp>
+        <p:nvSpPr>
+          <p:cNvPr id="9" name="TextBox 8"/>
+          <p:cNvSpPr txBox="1"/>
+          <p:nvPr/>
+        </p:nvSpPr>
+        <p:spPr>
+          <a:xfrm>
+            <a:off x="685800" y="6583680"/>
+            <a:ext cx="6490411" cy="256032"/>
+          </a:xfrm>
+          <a:prstGeom prst="rect">
+            <a:avLst/>
+          </a:prstGeom>
+          <a:noFill/>
+        </p:spPr>
+        <p:txBody>
+          <a:bodyPr wrap="none">
+            <a:spAutoFit/>
+          </a:bodyPr>
+          <a:lstStyle/>
+          <a:p>
+            <a:pPr algn="l"/>
+            <a:r>
+              <a:rPr sz="700">
+                <a:solidFill>
+                  <a:srgbClr val="A0B4D2"/>
+                </a:solidFill>
+                <a:latin typeface="JetBrains Mono"/>
+              </a:rPr>
+              <a:t>Benedikt Zoller Coaching  ·  FKB Campus  ·  M01</a:t>
+            </a:r>
+          </a:p>
+        </p:txBody>
+      </p:sp>
+      <p:sp>
+        <p:nvSpPr>
+          <p:cNvPr id="10" name="TextBox 9"/>
+          <p:cNvSpPr txBox="1"/>
+          <p:nvPr/>
+        </p:nvSpPr>
+        <p:spPr>
+          <a:xfrm>
+            <a:off x="7176211" y="6583680"/>
+            <a:ext cx="4326940" cy="256032"/>
+          </a:xfrm>
+          <a:prstGeom prst="rect">
+            <a:avLst/>
+          </a:prstGeom>
+          <a:noFill/>
+        </p:spPr>
+        <p:txBody>
+          <a:bodyPr wrap="none">
+            <a:spAutoFit/>
+          </a:bodyPr>
+          <a:lstStyle/>
+          <a:p>
+            <a:pPr algn="r"/>
+            <a:r>
+              <a:rPr sz="700">
+                <a:solidFill>
+                  <a:srgbClr val="A0B4D2"/>
+                </a:solidFill>
+                <a:latin typeface="JetBrains Mono"/>
+              </a:rPr>
+              <a:t>Schaubild</a:t>
+            </a:r>
+          </a:p>
+        </p:txBody>
+      </p:sp>
+    </p:spTree>
+  </p:cSld>
+  <p:clrMapOvr>
+    <a:masterClrMapping/>
+  </p:clrMapOvr>
+</p:sld>
+</file>
+
+<file path=ppt/slides/slide12.xml><?xml version="1.0" encoding="utf-8"?>
+<p:sld xmlns:a="http://schemas.openxmlformats.org/drawingml/2006/main" xmlns:p="http://schemas.openxmlformats.org/presentationml/2006/main" xmlns:r="http://schemas.openxmlformats.org/officeDocument/2006/relationships">
+  <p:cSld>
+    <p:spTree>
+      <p:nvGrpSpPr>
+        <p:cNvPr id="1" name=""/>
+        <p:cNvGrpSpPr/>
+        <p:nvPr/>
+      </p:nvGrpSpPr>
+      <p:grpSpPr/>
+      <p:sp>
+        <p:nvSpPr>
+          <p:cNvPr id="2" name="Rectangle 1"/>
+          <p:cNvSpPr/>
+          <p:nvPr/>
+        </p:nvSpPr>
+        <p:spPr>
+          <a:xfrm>
+            <a:off x="0" y="0"/>
+            <a:ext cx="12188952" cy="6858000"/>
+          </a:xfrm>
+          <a:prstGeom prst="rect">
+            <a:avLst/>
+          </a:prstGeom>
+          <a:solidFill>
+            <a:srgbClr val="FFFFFF"/>
+          </a:solidFill>
+          <a:ln>
+            <a:noFill/>
+          </a:ln>
+        </p:spPr>
+        <p:style>
+          <a:lnRef idx="1">
+            <a:schemeClr val="accent1"/>
+          </a:lnRef>
+          <a:fillRef idx="3">
+            <a:schemeClr val="accent1"/>
+          </a:fillRef>
+          <a:effectRef idx="2">
+            <a:schemeClr val="accent1"/>
+          </a:effectRef>
+          <a:fontRef idx="minor">
+            <a:schemeClr val="lt1"/>
+          </a:fontRef>
+        </p:style>
+        <p:txBody>
+          <a:bodyPr rtlCol="0" anchor="ctr"/>
+          <a:lstStyle/>
+          <a:p>
+            <a:pPr algn="ctr"/>
+          </a:p>
+        </p:txBody>
+      </p:sp>
+      <p:sp>
+        <p:nvSpPr>
+          <p:cNvPr id="3" name="Rectangle 2"/>
+          <p:cNvSpPr/>
+          <p:nvPr/>
+        </p:nvSpPr>
+        <p:spPr>
+          <a:xfrm>
+            <a:off x="0" y="0"/>
+            <a:ext cx="12188952" cy="50292"/>
+          </a:xfrm>
+          <a:prstGeom prst="rect">
+            <a:avLst/>
+          </a:prstGeom>
+          <a:solidFill>
+            <a:srgbClr val="1F2C56"/>
+          </a:solidFill>
+          <a:ln>
+            <a:noFill/>
+          </a:ln>
+        </p:spPr>
+        <p:style>
+          <a:lnRef idx="1">
+            <a:schemeClr val="accent1"/>
+          </a:lnRef>
+          <a:fillRef idx="3">
+            <a:schemeClr val="accent1"/>
+          </a:fillRef>
+          <a:effectRef idx="2">
+            <a:schemeClr val="accent1"/>
+          </a:effectRef>
+          <a:fontRef idx="minor">
+            <a:schemeClr val="lt1"/>
+          </a:fontRef>
+        </p:style>
+        <p:txBody>
+          <a:bodyPr rtlCol="0" anchor="ctr"/>
+          <a:lstStyle/>
+          <a:p>
+            <a:pPr algn="ctr"/>
+          </a:p>
+        </p:txBody>
+      </p:sp>
+      <p:sp>
+        <p:nvSpPr>
+          <p:cNvPr id="4" name="TextBox 3"/>
+          <p:cNvSpPr txBox="1"/>
+          <p:nvPr/>
+        </p:nvSpPr>
+        <p:spPr>
+          <a:xfrm>
+            <a:off x="685800" y="109728"/>
+            <a:ext cx="10817352" cy="228600"/>
+          </a:xfrm>
+          <a:prstGeom prst="rect">
+            <a:avLst/>
+          </a:prstGeom>
+          <a:noFill/>
+        </p:spPr>
+        <p:txBody>
+          <a:bodyPr wrap="none">
+            <a:spAutoFit/>
+          </a:bodyPr>
+          <a:lstStyle/>
+          <a:p>
+            <a:pPr algn="l"/>
+            <a:r>
+              <a:rPr sz="750">
+                <a:solidFill>
+                  <a:srgbClr val="78808C"/>
+                </a:solidFill>
+                <a:latin typeface="JetBrains Mono"/>
+              </a:rPr>
+              <a:t>M01  ·  SCHAUBILD</a:t>
+            </a:r>
+          </a:p>
+        </p:txBody>
+      </p:sp>
+      <p:sp>
+        <p:nvSpPr>
+          <p:cNvPr id="5" name="TextBox 4"/>
+          <p:cNvSpPr txBox="1"/>
+          <p:nvPr/>
+        </p:nvSpPr>
+        <p:spPr>
+          <a:xfrm>
+            <a:off x="685800" y="502920"/>
+            <a:ext cx="10817352" cy="594360"/>
+          </a:xfrm>
+          <a:prstGeom prst="rect">
+            <a:avLst/>
+          </a:prstGeom>
+          <a:noFill/>
+        </p:spPr>
+        <p:txBody>
+          <a:bodyPr wrap="square">
+            <a:spAutoFit/>
+          </a:bodyPr>
+          <a:lstStyle/>
+          <a:p>
+            <a:pPr algn="l"/>
+            <a:r>
+              <a:rPr sz="2000" b="1" i="0">
+                <a:solidFill>
+                  <a:srgbClr val="1F2C56"/>
+                </a:solidFill>
+                <a:latin typeface="Source Serif 4"/>
+              </a:rPr>
+              <a:t>Handlungsempfehlung</a:t>
+            </a:r>
+          </a:p>
+        </p:txBody>
+      </p:sp>
+      <p:sp>
+        <p:nvSpPr>
+          <p:cNvPr id="6" name="Rectangle 5"/>
+          <p:cNvSpPr/>
+          <p:nvPr/>
+        </p:nvSpPr>
+        <p:spPr>
+          <a:xfrm>
+            <a:off x="685800" y="1143000"/>
+            <a:ext cx="10817352" cy="25400"/>
+          </a:xfrm>
+          <a:prstGeom prst="rect">
+            <a:avLst/>
+          </a:prstGeom>
+          <a:solidFill>
+            <a:srgbClr val="D9C089"/>
+          </a:solidFill>
+          <a:ln>
+            <a:noFill/>
+          </a:ln>
+        </p:spPr>
+        <p:style>
+          <a:lnRef idx="1">
+            <a:schemeClr val="accent1"/>
+          </a:lnRef>
+          <a:fillRef idx="3">
+            <a:schemeClr val="accent1"/>
+          </a:fillRef>
+          <a:effectRef idx="2">
+            <a:schemeClr val="accent1"/>
+          </a:effectRef>
+          <a:fontRef idx="minor">
+            <a:schemeClr val="lt1"/>
+          </a:fontRef>
+        </p:style>
+        <p:txBody>
+          <a:bodyPr rtlCol="0" anchor="ctr"/>
+          <a:lstStyle/>
+          <a:p>
+            <a:pPr algn="ctr"/>
+          </a:p>
+        </p:txBody>
+      </p:sp>
+      <p:pic>
+        <p:nvPicPr>
+          <p:cNvPr id="7" name="Picture 6" descr="image.png"/>
+          <p:cNvPicPr>
+            <a:picLocks noChangeAspect="1"/>
+          </p:cNvPicPr>
+          <p:nvPr/>
+        </p:nvPicPr>
+        <p:blipFill>
+          <a:blip r:embed="rId2"/>
+          <a:stretch>
+            <a:fillRect/>
+          </a:stretch>
+        </p:blipFill>
+        <p:spPr>
+          <a:xfrm>
+            <a:off x="2303489" y="1325880"/>
+            <a:ext cx="7581973" cy="4937760"/>
+          </a:xfrm>
+          <a:prstGeom prst="rect">
+            <a:avLst/>
+          </a:prstGeom>
+        </p:spPr>
+      </p:pic>
+      <p:sp>
+        <p:nvSpPr>
+          <p:cNvPr id="8" name="Rectangle 7"/>
+          <p:cNvSpPr/>
+          <p:nvPr/>
+        </p:nvSpPr>
+        <p:spPr>
+          <a:xfrm>
+            <a:off x="0" y="6510528"/>
+            <a:ext cx="12188952" cy="347472"/>
+          </a:xfrm>
+          <a:prstGeom prst="rect">
+            <a:avLst/>
+          </a:prstGeom>
+          <a:solidFill>
+            <a:srgbClr val="0A1937"/>
+          </a:solidFill>
+          <a:ln>
+            <a:noFill/>
+          </a:ln>
+        </p:spPr>
+        <p:style>
+          <a:lnRef idx="1">
+            <a:schemeClr val="accent1"/>
+          </a:lnRef>
+          <a:fillRef idx="3">
+            <a:schemeClr val="accent1"/>
+          </a:fillRef>
+          <a:effectRef idx="2">
+            <a:schemeClr val="accent1"/>
+          </a:effectRef>
+          <a:fontRef idx="minor">
+            <a:schemeClr val="lt1"/>
+          </a:fontRef>
+        </p:style>
+        <p:txBody>
+          <a:bodyPr rtlCol="0" anchor="ctr"/>
+          <a:lstStyle/>
+          <a:p>
+            <a:pPr algn="ctr"/>
+          </a:p>
+        </p:txBody>
+      </p:sp>
+      <p:sp>
+        <p:nvSpPr>
+          <p:cNvPr id="9" name="TextBox 8"/>
+          <p:cNvSpPr txBox="1"/>
+          <p:nvPr/>
+        </p:nvSpPr>
+        <p:spPr>
+          <a:xfrm>
+            <a:off x="685800" y="6583680"/>
+            <a:ext cx="6490411" cy="256032"/>
+          </a:xfrm>
+          <a:prstGeom prst="rect">
+            <a:avLst/>
+          </a:prstGeom>
+          <a:noFill/>
+        </p:spPr>
+        <p:txBody>
+          <a:bodyPr wrap="none">
+            <a:spAutoFit/>
+          </a:bodyPr>
+          <a:lstStyle/>
+          <a:p>
+            <a:pPr algn="l"/>
+            <a:r>
+              <a:rPr sz="700">
+                <a:solidFill>
+                  <a:srgbClr val="A0B4D2"/>
+                </a:solidFill>
+                <a:latin typeface="JetBrains Mono"/>
+              </a:rPr>
+              <a:t>Benedikt Zoller Coaching  ·  FKB Campus  ·  M01</a:t>
+            </a:r>
+          </a:p>
+        </p:txBody>
+      </p:sp>
+      <p:sp>
+        <p:nvSpPr>
+          <p:cNvPr id="10" name="TextBox 9"/>
+          <p:cNvSpPr txBox="1"/>
+          <p:nvPr/>
+        </p:nvSpPr>
+        <p:spPr>
+          <a:xfrm>
+            <a:off x="7176211" y="6583680"/>
+            <a:ext cx="4326940" cy="256032"/>
+          </a:xfrm>
+          <a:prstGeom prst="rect">
+            <a:avLst/>
+          </a:prstGeom>
+          <a:noFill/>
+        </p:spPr>
+        <p:txBody>
+          <a:bodyPr wrap="none">
+            <a:spAutoFit/>
+          </a:bodyPr>
+          <a:lstStyle/>
+          <a:p>
+            <a:pPr algn="r"/>
+            <a:r>
+              <a:rPr sz="700">
+                <a:solidFill>
+                  <a:srgbClr val="A0B4D2"/>
+                </a:solidFill>
+                <a:latin typeface="JetBrains Mono"/>
+              </a:rPr>
+              <a:t>Schaubild</a:t>
+            </a:r>
+          </a:p>
+        </p:txBody>
+      </p:sp>
+    </p:spTree>
+  </p:cSld>
+  <p:clrMapOvr>
+    <a:masterClrMapping/>
+  </p:clrMapOvr>
+</p:sld>
+</file>
+
+<file path=ppt/slides/slide13.xml><?xml version="1.0" encoding="utf-8"?>
+<p:sld xmlns:a="http://schemas.openxmlformats.org/drawingml/2006/main" xmlns:p="http://schemas.openxmlformats.org/presentationml/2006/main" xmlns:r="http://schemas.openxmlformats.org/officeDocument/2006/relationships">
+  <p:cSld>
+    <p:spTree>
+      <p:nvGrpSpPr>
+        <p:cNvPr id="1" name=""/>
+        <p:cNvGrpSpPr/>
+        <p:nvPr/>
+      </p:nvGrpSpPr>
+      <p:grpSpPr/>
+      <p:sp>
+        <p:nvSpPr>
+          <p:cNvPr id="2" name="Rectangle 1"/>
+          <p:cNvSpPr/>
+          <p:nvPr/>
+        </p:nvSpPr>
+        <p:spPr>
+          <a:xfrm>
+            <a:off x="0" y="0"/>
+            <a:ext cx="12188952" cy="6858000"/>
+          </a:xfrm>
+          <a:prstGeom prst="rect">
+            <a:avLst/>
+          </a:prstGeom>
+          <a:solidFill>
+            <a:srgbClr val="EDEDF3"/>
+          </a:solidFill>
+          <a:ln>
+            <a:noFill/>
+          </a:ln>
+        </p:spPr>
+        <p:style>
+          <a:lnRef idx="1">
+            <a:schemeClr val="accent1"/>
+          </a:lnRef>
+          <a:fillRef idx="3">
+            <a:schemeClr val="accent1"/>
+          </a:fillRef>
+          <a:effectRef idx="2">
+            <a:schemeClr val="accent1"/>
+          </a:effectRef>
+          <a:fontRef idx="minor">
+            <a:schemeClr val="lt1"/>
+          </a:fontRef>
+        </p:style>
+        <p:txBody>
+          <a:bodyPr rtlCol="0" anchor="ctr"/>
+          <a:lstStyle/>
+          <a:p>
+            <a:pPr algn="ctr"/>
+          </a:p>
+        </p:txBody>
+      </p:sp>
+      <p:sp>
+        <p:nvSpPr>
+          <p:cNvPr id="3" name="Rectangle 2"/>
+          <p:cNvSpPr/>
+          <p:nvPr/>
+        </p:nvSpPr>
+        <p:spPr>
+          <a:xfrm>
+            <a:off x="0" y="0"/>
+            <a:ext cx="12188952" cy="50292"/>
+          </a:xfrm>
+          <a:prstGeom prst="rect">
+            <a:avLst/>
+          </a:prstGeom>
+          <a:solidFill>
+            <a:srgbClr val="1F2C56"/>
+          </a:solidFill>
+          <a:ln>
+            <a:noFill/>
+          </a:ln>
+        </p:spPr>
+        <p:style>
+          <a:lnRef idx="1">
+            <a:schemeClr val="accent1"/>
+          </a:lnRef>
+          <a:fillRef idx="3">
+            <a:schemeClr val="accent1"/>
+          </a:fillRef>
+          <a:effectRef idx="2">
+            <a:schemeClr val="accent1"/>
+          </a:effectRef>
+          <a:fontRef idx="minor">
+            <a:schemeClr val="lt1"/>
+          </a:fontRef>
+        </p:style>
+        <p:txBody>
+          <a:bodyPr rtlCol="0" anchor="ctr"/>
+          <a:lstStyle/>
+          <a:p>
+            <a:pPr algn="ctr"/>
+          </a:p>
+        </p:txBody>
+      </p:sp>
+      <p:sp>
+        <p:nvSpPr>
+          <p:cNvPr id="4" name="TextBox 3"/>
+          <p:cNvSpPr txBox="1"/>
+          <p:nvPr/>
+        </p:nvSpPr>
+        <p:spPr>
+          <a:xfrm>
+            <a:off x="685800" y="109728"/>
+            <a:ext cx="10817352" cy="228600"/>
+          </a:xfrm>
+          <a:prstGeom prst="rect">
+            <a:avLst/>
+          </a:prstGeom>
+          <a:noFill/>
+        </p:spPr>
+        <p:txBody>
+          <a:bodyPr wrap="none">
+            <a:spAutoFit/>
+          </a:bodyPr>
+          <a:lstStyle/>
+          <a:p>
+            <a:pPr algn="l"/>
+            <a:r>
+              <a:rPr sz="750">
+                <a:solidFill>
+                  <a:srgbClr val="78808C"/>
+                </a:solidFill>
+                <a:latin typeface="JetBrains Mono"/>
+              </a:rPr>
+              <a:t>M01  ·  INHALT</a:t>
+            </a:r>
+          </a:p>
+        </p:txBody>
+      </p:sp>
+      <p:sp>
+        <p:nvSpPr>
+          <p:cNvPr id="5" name="Rectangle 4"/>
+          <p:cNvSpPr/>
+          <p:nvPr/>
+        </p:nvSpPr>
+        <p:spPr>
+          <a:xfrm>
+            <a:off x="0" y="1234440"/>
+            <a:ext cx="12188952" cy="12700"/>
+          </a:xfrm>
+          <a:prstGeom prst="rect">
+            <a:avLst/>
+          </a:prstGeom>
+          <a:solidFill>
+            <a:srgbClr val="D8DFE4"/>
+          </a:solidFill>
+          <a:ln>
+            <a:noFill/>
+          </a:ln>
+        </p:spPr>
+        <p:style>
+          <a:lnRef idx="1">
+            <a:schemeClr val="accent1"/>
+          </a:lnRef>
+          <a:fillRef idx="3">
+            <a:schemeClr val="accent1"/>
+          </a:fillRef>
+          <a:effectRef idx="2">
+            <a:schemeClr val="accent1"/>
+          </a:effectRef>
+          <a:fontRef idx="minor">
+            <a:schemeClr val="lt1"/>
+          </a:fontRef>
+        </p:style>
+        <p:txBody>
+          <a:bodyPr rtlCol="0" anchor="ctr"/>
+          <a:lstStyle/>
+          <a:p>
+            <a:pPr algn="ctr"/>
+          </a:p>
+        </p:txBody>
+      </p:sp>
+      <p:sp>
+        <p:nvSpPr>
+          <p:cNvPr id="6" name="Rectangle 5"/>
+          <p:cNvSpPr/>
+          <p:nvPr/>
+        </p:nvSpPr>
+        <p:spPr>
+          <a:xfrm>
+            <a:off x="685800" y="502920"/>
+            <a:ext cx="36576" cy="658368"/>
+          </a:xfrm>
+          <a:prstGeom prst="rect">
+            <a:avLst/>
+          </a:prstGeom>
+          <a:solidFill>
+            <a:srgbClr val="D9C089"/>
+          </a:solidFill>
+          <a:ln>
+            <a:noFill/>
+          </a:ln>
+        </p:spPr>
+        <p:style>
+          <a:lnRef idx="1">
+            <a:schemeClr val="accent1"/>
+          </a:lnRef>
+          <a:fillRef idx="3">
+            <a:schemeClr val="accent1"/>
+          </a:fillRef>
+          <a:effectRef idx="2">
+            <a:schemeClr val="accent1"/>
+          </a:effectRef>
+          <a:fontRef idx="minor">
+            <a:schemeClr val="lt1"/>
+          </a:fontRef>
+        </p:style>
+        <p:txBody>
+          <a:bodyPr rtlCol="0" anchor="ctr"/>
+          <a:lstStyle/>
+          <a:p>
+            <a:pPr algn="ctr"/>
+          </a:p>
+        </p:txBody>
+      </p:sp>
+      <p:sp>
+        <p:nvSpPr>
+          <p:cNvPr id="7" name="TextBox 6"/>
+          <p:cNvSpPr txBox="1"/>
+          <p:nvPr/>
+        </p:nvSpPr>
+        <p:spPr>
+          <a:xfrm>
+            <a:off x="813816" y="502920"/>
+            <a:ext cx="10634472" cy="685800"/>
+          </a:xfrm>
+          <a:prstGeom prst="rect">
+            <a:avLst/>
+          </a:prstGeom>
+          <a:noFill/>
+        </p:spPr>
+        <p:txBody>
+          <a:bodyPr wrap="square">
+            <a:spAutoFit/>
+          </a:bodyPr>
+          <a:lstStyle/>
+          <a:p>
+            <a:pPr algn="l"/>
+            <a:r>
+              <a:rPr sz="2400" b="1" i="0">
+                <a:solidFill>
+                  <a:srgbClr val="1F2C56"/>
+                </a:solidFill>
+                <a:latin typeface="Source Serif 4"/>
+              </a:rPr>
+              <a:t>Reflexionsfragen</a:t>
+            </a:r>
+          </a:p>
+        </p:txBody>
+      </p:sp>
+      <p:sp>
+        <p:nvSpPr>
+          <p:cNvPr id="8" name="TextBox 7"/>
+          <p:cNvSpPr txBox="1"/>
+          <p:nvPr/>
+        </p:nvSpPr>
+        <p:spPr>
+          <a:xfrm>
+            <a:off x="685800" y="1417320"/>
+            <a:ext cx="10817352" cy="5029200"/>
+          </a:xfrm>
+          <a:prstGeom prst="rect">
+            <a:avLst/>
+          </a:prstGeom>
+          <a:noFill/>
+        </p:spPr>
+        <p:txBody>
+          <a:bodyPr wrap="square">
+            <a:spAutoFit/>
+          </a:bodyPr>
+          <a:lstStyle/>
+          <a:p>
+            <a:pPr>
+              <a:spcBef>
+                <a:spcPts val="400"/>
+              </a:spcBef>
+              <a:spcAft>
+                <a:spcPts val="200"/>
+              </a:spcAft>
+            </a:pPr>
+            <a:r>
+              <a:rPr sz="1300">
+                <a:solidFill>
+                  <a:srgbClr val="3D5466"/>
+                </a:solidFill>
+                <a:latin typeface="Arial"/>
+              </a:rPr>
+              <a:t>▸  Beantworten Sie diese Fragen am Ende des Moduls schriftlich (5 Minuten):</a:t>
             </a:r>
           </a:p>
           <a:p>
@@ -5569,7 +6884,7 @@
                 </a:solidFill>
                 <a:latin typeface="JetBrains Mono"/>
               </a:rPr>
-              <a:t>M01  ·  INHALT</a:t>
+              <a:t>AGENDA  ·  M01</a:t>
             </a:r>
           </a:p>
         </p:txBody>
@@ -5619,57 +6934,14 @@
       </p:sp>
       <p:sp>
         <p:nvSpPr>
-          <p:cNvPr id="6" name="Rectangle 5"/>
-          <p:cNvSpPr/>
+          <p:cNvPr id="6" name="TextBox 5"/>
+          <p:cNvSpPr txBox="1"/>
           <p:nvPr/>
         </p:nvSpPr>
         <p:spPr>
           <a:xfrm>
             <a:off x="685800" y="502920"/>
-            <a:ext cx="36576" cy="658368"/>
-          </a:xfrm>
-          <a:prstGeom prst="rect">
-            <a:avLst/>
-          </a:prstGeom>
-          <a:solidFill>
-            <a:srgbClr val="D9C089"/>
-          </a:solidFill>
-          <a:ln>
-            <a:noFill/>
-          </a:ln>
-        </p:spPr>
-        <p:style>
-          <a:lnRef idx="1">
-            <a:schemeClr val="accent1"/>
-          </a:lnRef>
-          <a:fillRef idx="3">
-            <a:schemeClr val="accent1"/>
-          </a:fillRef>
-          <a:effectRef idx="2">
-            <a:schemeClr val="accent1"/>
-          </a:effectRef>
-          <a:fontRef idx="minor">
-            <a:schemeClr val="lt1"/>
-          </a:fontRef>
-        </p:style>
-        <p:txBody>
-          <a:bodyPr rtlCol="0" anchor="ctr"/>
-          <a:lstStyle/>
-          <a:p>
-            <a:pPr algn="ctr"/>
-          </a:p>
-        </p:txBody>
-      </p:sp>
-      <p:sp>
-        <p:nvSpPr>
-          <p:cNvPr id="7" name="TextBox 6"/>
-          <p:cNvSpPr txBox="1"/>
-          <p:nvPr/>
-        </p:nvSpPr>
-        <p:spPr>
-          <a:xfrm>
-            <a:off x="813816" y="502920"/>
-            <a:ext cx="10634472" cy="685800"/>
+            <a:ext cx="10817352" cy="658368"/>
           </a:xfrm>
           <a:prstGeom prst="rect">
             <a:avLst/>
@@ -5684,27 +6956,27 @@
           <a:p>
             <a:pPr algn="l"/>
             <a:r>
-              <a:rPr sz="2400" b="1" i="0">
+              <a:rPr sz="2600" b="1" i="0">
                 <a:solidFill>
                   <a:srgbClr val="1F2C56"/>
                 </a:solidFill>
                 <a:latin typeface="Source Serif 4"/>
               </a:rPr>
-              <a:t>Theorie-Input: Aufbau des HGB-Jahresabschlusses</a:t>
-            </a:r>
-          </a:p>
-        </p:txBody>
-      </p:sp>
-      <p:sp>
-        <p:nvSpPr>
-          <p:cNvPr id="8" name="TextBox 7"/>
+              <a:t>So läuft das Modul</a:t>
+            </a:r>
+          </a:p>
+        </p:txBody>
+      </p:sp>
+      <p:sp>
+        <p:nvSpPr>
+          <p:cNvPr id="7" name="TextBox 6"/>
           <p:cNvSpPr txBox="1"/>
           <p:nvPr/>
         </p:nvSpPr>
         <p:spPr>
           <a:xfrm>
-            <a:off x="685800" y="1417320"/>
-            <a:ext cx="10817352" cy="5029200"/>
+            <a:off x="685800" y="1463040"/>
+            <a:ext cx="10817352" cy="4937760"/>
           </a:xfrm>
           <a:prstGeom prst="rect">
             <a:avLst/>
@@ -5719,217 +6991,304 @@
           <a:p>
             <a:pPr>
               <a:spcBef>
-                <a:spcPts val="1000"/>
+                <a:spcPts val="700"/>
               </a:spcBef>
               <a:spcAft>
-                <a:spcPts val="200"/>
+                <a:spcPts val="100"/>
               </a:spcAft>
             </a:pPr>
             <a:r>
-              <a:rPr sz="800" b="1">
+              <a:rPr sz="1200">
                 <a:solidFill>
                   <a:srgbClr val="78808C"/>
                 </a:solidFill>
-                <a:latin typeface="JetBrains Mono"/>
+                <a:latin typeface="Consolas"/>
               </a:rPr>
-              <a:t>WAS IST EIN JAHRESABSCHLUSS?</a:t>
+              <a:t>00–05       </a:t>
+            </a:r>
+            <a:r>
+              <a:rPr sz="1500" b="1">
+                <a:solidFill>
+                  <a:srgbClr val="3D5466"/>
+                </a:solidFill>
+                <a:latin typeface="Arial"/>
+              </a:rPr>
+              <a:t>  Einstieg</a:t>
+            </a:r>
+            <a:r>
+              <a:rPr sz="1200">
+                <a:solidFill>
+                  <a:srgbClr val="78808C"/>
+                </a:solidFill>
+                <a:latin typeface="Arial"/>
+              </a:rPr>
+              <a:t>  ·  Blitzrunde</a:t>
             </a:r>
           </a:p>
           <a:p>
             <a:pPr>
               <a:spcBef>
-                <a:spcPts val="400"/>
+                <a:spcPts val="700"/>
               </a:spcBef>
               <a:spcAft>
-                <a:spcPts val="200"/>
+                <a:spcPts val="100"/>
               </a:spcAft>
             </a:pPr>
             <a:r>
               <a:rPr sz="1200">
                 <a:solidFill>
+                  <a:srgbClr val="78808C"/>
+                </a:solidFill>
+                <a:latin typeface="Consolas"/>
+              </a:rPr>
+              <a:t>05–15       </a:t>
+            </a:r>
+            <a:r>
+              <a:rPr sz="1500" b="1">
+                <a:solidFill>
                   <a:srgbClr val="3D5466"/>
                 </a:solidFill>
                 <a:latin typeface="Arial"/>
               </a:rPr>
-              <a:t>Der Jahresabschluss ist die jährliche Zusammenfassung der wirtschaftlichen Lage eines Unternehmens. Für Kapitalgesellschaften (GmbH, AG) schreibt das HGB in §§ 264 ff. folgende Bestandteile vor:</a:t>
+              <a:t>  Aktivierung</a:t>
+            </a:r>
+            <a:r>
+              <a:rPr sz="1200">
+                <a:solidFill>
+                  <a:srgbClr val="78808C"/>
+                </a:solidFill>
+                <a:latin typeface="Arial"/>
+              </a:rPr>
+              <a:t>  ·  Einzelarbeit → Plenumsdiskussion</a:t>
             </a:r>
           </a:p>
           <a:p>
             <a:pPr>
               <a:spcBef>
-                <a:spcPts val="400"/>
+                <a:spcPts val="700"/>
               </a:spcBef>
               <a:spcAft>
-                <a:spcPts val="200"/>
+                <a:spcPts val="100"/>
               </a:spcAft>
             </a:pPr>
             <a:r>
               <a:rPr sz="1200">
                 <a:solidFill>
+                  <a:srgbClr val="78808C"/>
+                </a:solidFill>
+                <a:latin typeface="Consolas"/>
+              </a:rPr>
+              <a:t>15–35       </a:t>
+            </a:r>
+            <a:r>
+              <a:rPr sz="1500" b="1">
+                <a:solidFill>
                   <a:srgbClr val="3D5466"/>
                 </a:solidFill>
                 <a:latin typeface="Arial"/>
               </a:rPr>
-              <a:t>Bilanz (§ 266 HGB): Stichtagsbezogene Gegenüberstellung von Vermögen (Aktiva) und Kapital (Passiva). Die Bilanz zeigt, was ein Unternehmen besitzt und wie es finanziert ist.</a:t>
+              <a:t>  Input 1</a:t>
+            </a:r>
+            <a:r>
+              <a:rPr sz="1200">
+                <a:solidFill>
+                  <a:srgbClr val="78808C"/>
+                </a:solidFill>
+                <a:latin typeface="Arial"/>
+              </a:rPr>
+              <a:t>  ·  Interaktiver Vortrag (Folie + Tafelanschrieb)</a:t>
             </a:r>
           </a:p>
           <a:p>
             <a:pPr>
               <a:spcBef>
-                <a:spcPts val="400"/>
+                <a:spcPts val="700"/>
               </a:spcBef>
               <a:spcAft>
-                <a:spcPts val="200"/>
+                <a:spcPts val="100"/>
               </a:spcAft>
             </a:pPr>
             <a:r>
               <a:rPr sz="1200">
                 <a:solidFill>
+                  <a:srgbClr val="78808C"/>
+                </a:solidFill>
+                <a:latin typeface="Consolas"/>
+              </a:rPr>
+              <a:t>35–45       </a:t>
+            </a:r>
+            <a:r>
+              <a:rPr sz="1500" b="1">
+                <a:solidFill>
                   <a:srgbClr val="3D5466"/>
                 </a:solidFill>
                 <a:latin typeface="Arial"/>
               </a:rPr>
-              <a:t>Gewinn- und Verlustrechnung (§ 275 HGB): Zeitraumbezogene Darstellung von Erträgen und Aufwendungen eines Geschäftsjahres. Sie zeigt, wie ein Unternehmen Geld verdient (oder verliert).</a:t>
+              <a:t>  Übung 1</a:t>
+            </a:r>
+            <a:r>
+              <a:rPr sz="1200">
+                <a:solidFill>
+                  <a:srgbClr val="78808C"/>
+                </a:solidFill>
+                <a:latin typeface="Arial"/>
+              </a:rPr>
+              <a:t>  ·  Partnerarbeit</a:t>
             </a:r>
           </a:p>
           <a:p>
             <a:pPr>
               <a:spcBef>
-                <a:spcPts val="400"/>
+                <a:spcPts val="700"/>
               </a:spcBef>
               <a:spcAft>
-                <a:spcPts val="200"/>
+                <a:spcPts val="100"/>
               </a:spcAft>
             </a:pPr>
             <a:r>
               <a:rPr sz="1200">
                 <a:solidFill>
+                  <a:srgbClr val="78808C"/>
+                </a:solidFill>
+                <a:latin typeface="Consolas"/>
+              </a:rPr>
+              <a:t>45–65       </a:t>
+            </a:r>
+            <a:r>
+              <a:rPr sz="1500" b="1">
+                <a:solidFill>
                   <a:srgbClr val="3D5466"/>
                 </a:solidFill>
                 <a:latin typeface="Arial"/>
               </a:rPr>
-              <a:t>Anhang (§ 284 HGB): Erläuterungen und Ergänzungen zu Bilanz und GuV (z.B. Bilanzierungsmethoden, Haftungsverhältnisse). Für den Kreditgeber oft wertvoller als die nackten Zahlen.</a:t>
+              <a:t>  Input 2</a:t>
+            </a:r>
+            <a:r>
+              <a:rPr sz="1200">
+                <a:solidFill>
+                  <a:srgbClr val="78808C"/>
+                </a:solidFill>
+                <a:latin typeface="Arial"/>
+              </a:rPr>
+              <a:t>  ·  Interaktiver Vortrag mit direkter Anwendung</a:t>
             </a:r>
           </a:p>
           <a:p>
             <a:pPr>
               <a:spcBef>
-                <a:spcPts val="400"/>
+                <a:spcPts val="700"/>
               </a:spcBef>
               <a:spcAft>
-                <a:spcPts val="200"/>
+                <a:spcPts val="100"/>
               </a:spcAft>
             </a:pPr>
             <a:r>
               <a:rPr sz="1200">
                 <a:solidFill>
+                  <a:srgbClr val="78808C"/>
+                </a:solidFill>
+                <a:latin typeface="Consolas"/>
+              </a:rPr>
+              <a:t>65–80       </a:t>
+            </a:r>
+            <a:r>
+              <a:rPr sz="1500" b="1">
+                <a:solidFill>
                   <a:srgbClr val="3D5466"/>
                 </a:solidFill>
                 <a:latin typeface="Arial"/>
               </a:rPr>
-              <a:t>Lagebericht (§ 289 HGB): Lageeinschätzung des Managements, Risikobericht, Ausblick. Nur für mittelgroße und große Unternehmen verpflichtend.</a:t>
+              <a:t>  Übung 2</a:t>
+            </a:r>
+            <a:r>
+              <a:rPr sz="1200">
+                <a:solidFill>
+                  <a:srgbClr val="78808C"/>
+                </a:solidFill>
+                <a:latin typeface="Arial"/>
+              </a:rPr>
+              <a:t>  ·  Einzelarbeit → Vergleich Partnerarbeit</a:t>
             </a:r>
           </a:p>
           <a:p>
             <a:pPr>
               <a:spcBef>
-                <a:spcPts val="1000"/>
+                <a:spcPts val="700"/>
               </a:spcBef>
               <a:spcAft>
-                <a:spcPts val="200"/>
+                <a:spcPts val="100"/>
               </a:spcAft>
             </a:pPr>
             <a:r>
-              <a:rPr sz="800" b="1">
+              <a:rPr sz="1200">
                 <a:solidFill>
                   <a:srgbClr val="78808C"/>
                 </a:solidFill>
-                <a:latin typeface="JetBrains Mono"/>
+                <a:latin typeface="Consolas"/>
               </a:rPr>
-              <a:t>OFFENLEGUNGSPFLICHTEN UND GRÖSSENKLASSEN (§ 267 HGB)</a:t>
+              <a:t>80–90       </a:t>
+            </a:r>
+            <a:r>
+              <a:rPr sz="1500" b="1">
+                <a:solidFill>
+                  <a:srgbClr val="3D5466"/>
+                </a:solidFill>
+                <a:latin typeface="Arial"/>
+              </a:rPr>
+              <a:t>  Auswertung</a:t>
+            </a:r>
+            <a:r>
+              <a:rPr sz="1200">
+                <a:solidFill>
+                  <a:srgbClr val="78808C"/>
+                </a:solidFill>
+                <a:latin typeface="Arial"/>
+              </a:rPr>
+              <a:t>  ·  Plenumsgespräch</a:t>
             </a:r>
           </a:p>
           <a:p>
             <a:pPr>
               <a:spcBef>
-                <a:spcPts val="1000"/>
+                <a:spcPts val="700"/>
               </a:spcBef>
               <a:spcAft>
-                <a:spcPts val="200"/>
+                <a:spcPts val="100"/>
               </a:spcAft>
             </a:pPr>
             <a:r>
-              <a:rPr sz="800" b="1">
+              <a:rPr sz="1200">
                 <a:solidFill>
                   <a:srgbClr val="78808C"/>
                 </a:solidFill>
-                <a:latin typeface="JetBrains Mono"/>
+                <a:latin typeface="Consolas"/>
               </a:rPr>
-              <a:t>BILANZSTRUKTUR: MITTELHERKUNFT UND -VERWENDUNG</a:t>
-            </a:r>
-          </a:p>
-          <a:p>
-            <a:pPr>
-              <a:spcBef>
-                <a:spcPts val="1000"/>
-              </a:spcBef>
-              <a:spcAft>
-                <a:spcPts val="200"/>
-              </a:spcAft>
-            </a:pPr>
-            <a:r>
-              <a:rPr sz="800" b="1">
-                <a:solidFill>
-                  <a:srgbClr val="78808C"/>
-                </a:solidFill>
-                <a:latin typeface="JetBrains Mono"/>
-              </a:rPr>
-              <a:t>BILANZIERUNGSWAHLRECHTE UND IHRE WIRKUNG</a:t>
-            </a:r>
-          </a:p>
-          <a:p>
-            <a:pPr>
-              <a:spcBef>
-                <a:spcPts val="1000"/>
-              </a:spcBef>
-              <a:spcAft>
-                <a:spcPts val="200"/>
-              </a:spcAft>
-            </a:pPr>
-            <a:r>
-              <a:rPr sz="800" b="1">
-                <a:solidFill>
-                  <a:srgbClr val="78808C"/>
-                </a:solidFill>
-                <a:latin typeface="JetBrains Mono"/>
-              </a:rPr>
-              <a:t>BILANZKENNZAHLEN IM ÜBERBLICK</a:t>
-            </a:r>
-          </a:p>
-          <a:p>
-            <a:pPr>
-              <a:spcBef>
-                <a:spcPts val="400"/>
-              </a:spcBef>
-              <a:spcAft>
-                <a:spcPts val="200"/>
-              </a:spcAft>
-            </a:pPr>
-            <a:r>
-              <a:rPr sz="1200">
+              <a:t>90–95       </a:t>
+            </a:r>
+            <a:r>
+              <a:rPr sz="1500" b="1">
                 <a:solidFill>
                   <a:srgbClr val="3D5466"/>
                 </a:solidFill>
                 <a:latin typeface="Arial"/>
               </a:rPr>
-              <a:t>Die sechs zentralen Kennzahlen mit Formel, Benchmark und Bewertungsampel:</a:t>
-            </a:r>
-          </a:p>
-        </p:txBody>
-      </p:sp>
-      <p:sp>
-        <p:nvSpPr>
-          <p:cNvPr id="9" name="Rectangle 8"/>
+              <a:t>  Abschluss</a:t>
+            </a:r>
+            <a:r>
+              <a:rPr sz="1200">
+                <a:solidFill>
+                  <a:srgbClr val="78808C"/>
+                </a:solidFill>
+                <a:latin typeface="Arial"/>
+              </a:rPr>
+              <a:t>  ·  Plenum</a:t>
+            </a:r>
+          </a:p>
+        </p:txBody>
+      </p:sp>
+      <p:sp>
+        <p:nvSpPr>
+          <p:cNvPr id="8" name="Rectangle 7"/>
           <p:cNvSpPr/>
           <p:nvPr/>
         </p:nvSpPr>
@@ -5972,7 +7331,7 @@
       </p:sp>
       <p:sp>
         <p:nvSpPr>
-          <p:cNvPr id="10" name="TextBox 9"/>
+          <p:cNvPr id="9" name="TextBox 8"/>
           <p:cNvSpPr txBox="1"/>
           <p:nvPr/>
         </p:nvSpPr>
@@ -6038,7 +7397,7 @@
             <a:avLst/>
           </a:prstGeom>
           <a:solidFill>
-            <a:srgbClr val="FFFFFF"/>
+            <a:srgbClr val="EDEDF3"/>
           </a:solidFill>
           <a:ln>
             <a:noFill/>
@@ -6139,43 +7498,51 @@
                 </a:solidFill>
                 <a:latin typeface="JetBrains Mono"/>
               </a:rPr>
-              <a:t>M01  ·  SCHAUBILD</a:t>
-            </a:r>
-          </a:p>
-        </p:txBody>
-      </p:sp>
-      <p:sp>
-        <p:nvSpPr>
-          <p:cNvPr id="5" name="TextBox 4"/>
-          <p:cNvSpPr txBox="1"/>
-          <p:nvPr/>
-        </p:nvSpPr>
-        <p:spPr>
-          <a:xfrm>
-            <a:off x="685800" y="502920"/>
-            <a:ext cx="10817352" cy="594360"/>
-          </a:xfrm>
-          <a:prstGeom prst="rect">
-            <a:avLst/>
-          </a:prstGeom>
-          <a:noFill/>
-        </p:spPr>
-        <p:txBody>
-          <a:bodyPr wrap="square">
-            <a:spAutoFit/>
-          </a:bodyPr>
-          <a:lstStyle/>
-          <a:p>
-            <a:pPr algn="l"/>
-            <a:r>
-              <a:rPr sz="2000" b="1" i="0">
-                <a:solidFill>
-                  <a:srgbClr val="1F2C56"/>
-                </a:solidFill>
-                <a:latin typeface="Source Serif 4"/>
-              </a:rPr>
-              <a:t>Bilanzstruktur T-Konto</a:t>
-            </a:r>
+              <a:t>M01  ·  INHALT</a:t>
+            </a:r>
+          </a:p>
+        </p:txBody>
+      </p:sp>
+      <p:sp>
+        <p:nvSpPr>
+          <p:cNvPr id="5" name="Rectangle 4"/>
+          <p:cNvSpPr/>
+          <p:nvPr/>
+        </p:nvSpPr>
+        <p:spPr>
+          <a:xfrm>
+            <a:off x="0" y="1234440"/>
+            <a:ext cx="12188952" cy="12700"/>
+          </a:xfrm>
+          <a:prstGeom prst="rect">
+            <a:avLst/>
+          </a:prstGeom>
+          <a:solidFill>
+            <a:srgbClr val="D8DFE4"/>
+          </a:solidFill>
+          <a:ln>
+            <a:noFill/>
+          </a:ln>
+        </p:spPr>
+        <p:style>
+          <a:lnRef idx="1">
+            <a:schemeClr val="accent1"/>
+          </a:lnRef>
+          <a:fillRef idx="3">
+            <a:schemeClr val="accent1"/>
+          </a:fillRef>
+          <a:effectRef idx="2">
+            <a:schemeClr val="accent1"/>
+          </a:effectRef>
+          <a:fontRef idx="minor">
+            <a:schemeClr val="lt1"/>
+          </a:fontRef>
+        </p:style>
+        <p:txBody>
+          <a:bodyPr rtlCol="0" anchor="ctr"/>
+          <a:lstStyle/>
+          <a:p>
+            <a:pPr algn="ctr"/>
           </a:p>
         </p:txBody>
       </p:sp>
@@ -6187,8 +7554,8 @@
         </p:nvSpPr>
         <p:spPr>
           <a:xfrm>
-            <a:off x="685800" y="1143000"/>
-            <a:ext cx="10817352" cy="25400"/>
+            <a:off x="685800" y="502920"/>
+            <a:ext cx="36576" cy="658368"/>
           </a:xfrm>
           <a:prstGeom prst="rect">
             <a:avLst/>
@@ -6222,33 +7589,276 @@
           </a:p>
         </p:txBody>
       </p:sp>
-      <p:pic>
-        <p:nvPicPr>
-          <p:cNvPr id="7" name="Picture 6" descr="image.png"/>
-          <p:cNvPicPr>
-            <a:picLocks noChangeAspect="1"/>
-          </p:cNvPicPr>
-          <p:nvPr/>
-        </p:nvPicPr>
-        <p:blipFill>
-          <a:blip r:embed="rId2"/>
-          <a:stretch>
-            <a:fillRect/>
-          </a:stretch>
-        </p:blipFill>
-        <p:spPr>
-          <a:xfrm>
-            <a:off x="1931981" y="1325880"/>
-            <a:ext cx="8324990" cy="4937760"/>
-          </a:xfrm>
-          <a:prstGeom prst="rect">
-            <a:avLst/>
-          </a:prstGeom>
-        </p:spPr>
-      </p:pic>
-      <p:sp>
-        <p:nvSpPr>
-          <p:cNvPr id="8" name="Rectangle 7"/>
+      <p:sp>
+        <p:nvSpPr>
+          <p:cNvPr id="7" name="TextBox 6"/>
+          <p:cNvSpPr txBox="1"/>
+          <p:nvPr/>
+        </p:nvSpPr>
+        <p:spPr>
+          <a:xfrm>
+            <a:off x="813816" y="502920"/>
+            <a:ext cx="10634472" cy="685800"/>
+          </a:xfrm>
+          <a:prstGeom prst="rect">
+            <a:avLst/>
+          </a:prstGeom>
+          <a:noFill/>
+        </p:spPr>
+        <p:txBody>
+          <a:bodyPr wrap="square">
+            <a:spAutoFit/>
+          </a:bodyPr>
+          <a:lstStyle/>
+          <a:p>
+            <a:pPr algn="l"/>
+            <a:r>
+              <a:rPr sz="2400" b="1" i="0">
+                <a:solidFill>
+                  <a:srgbClr val="1F2C56"/>
+                </a:solidFill>
+                <a:latin typeface="Source Serif 4"/>
+              </a:rPr>
+              <a:t>Theorie-Input: Aufbau des HGB-Jahresabschlusses</a:t>
+            </a:r>
+          </a:p>
+        </p:txBody>
+      </p:sp>
+      <p:sp>
+        <p:nvSpPr>
+          <p:cNvPr id="8" name="TextBox 7"/>
+          <p:cNvSpPr txBox="1"/>
+          <p:nvPr/>
+        </p:nvSpPr>
+        <p:spPr>
+          <a:xfrm>
+            <a:off x="685800" y="1417320"/>
+            <a:ext cx="10817352" cy="5029200"/>
+          </a:xfrm>
+          <a:prstGeom prst="rect">
+            <a:avLst/>
+          </a:prstGeom>
+          <a:noFill/>
+        </p:spPr>
+        <p:txBody>
+          <a:bodyPr wrap="square">
+            <a:spAutoFit/>
+          </a:bodyPr>
+          <a:lstStyle/>
+          <a:p>
+            <a:pPr>
+              <a:spcBef>
+                <a:spcPts val="1000"/>
+              </a:spcBef>
+              <a:spcAft>
+                <a:spcPts val="200"/>
+              </a:spcAft>
+            </a:pPr>
+            <a:r>
+              <a:rPr sz="800" b="1">
+                <a:solidFill>
+                  <a:srgbClr val="78808C"/>
+                </a:solidFill>
+                <a:latin typeface="JetBrains Mono"/>
+              </a:rPr>
+              <a:t>WAS IST EIN JAHRESABSCHLUSS?</a:t>
+            </a:r>
+          </a:p>
+          <a:p>
+            <a:pPr>
+              <a:spcBef>
+                <a:spcPts val="400"/>
+              </a:spcBef>
+              <a:spcAft>
+                <a:spcPts val="200"/>
+              </a:spcAft>
+            </a:pPr>
+            <a:r>
+              <a:rPr sz="1300">
+                <a:solidFill>
+                  <a:srgbClr val="3D5466"/>
+                </a:solidFill>
+                <a:latin typeface="Arial"/>
+              </a:rPr>
+              <a:t>▸  Der Jahresabschluss ist die jährliche Zusammenfassung der wirtschaftlichen Lage eines Unternehmens. Für Kapitalgesellschaften (GmbH, AG) schreibt das HGB in §§ 264 ff. folgende Bestandteile vor:</a:t>
+            </a:r>
+          </a:p>
+          <a:p>
+            <a:pPr>
+              <a:spcBef>
+                <a:spcPts val="400"/>
+              </a:spcBef>
+              <a:spcAft>
+                <a:spcPts val="200"/>
+              </a:spcAft>
+            </a:pPr>
+            <a:r>
+              <a:rPr sz="1300">
+                <a:solidFill>
+                  <a:srgbClr val="3D5466"/>
+                </a:solidFill>
+                <a:latin typeface="Arial"/>
+              </a:rPr>
+              <a:t>▸  Bilanz (§ 266 HGB): Stichtagsbezogene Gegenüberstellung von Vermögen (Aktiva) und Kapital (Passiva). Die Bilanz zeigt, was ein Unternehmen besitzt und wie es finanziert ist.</a:t>
+            </a:r>
+          </a:p>
+          <a:p>
+            <a:pPr>
+              <a:spcBef>
+                <a:spcPts val="400"/>
+              </a:spcBef>
+              <a:spcAft>
+                <a:spcPts val="200"/>
+              </a:spcAft>
+            </a:pPr>
+            <a:r>
+              <a:rPr sz="1300">
+                <a:solidFill>
+                  <a:srgbClr val="3D5466"/>
+                </a:solidFill>
+                <a:latin typeface="Arial"/>
+              </a:rPr>
+              <a:t>▸  Gewinn- und Verlustrechnung (§ 275 HGB): Zeitraumbezogene Darstellung von Erträgen und Aufwendungen eines Geschäftsjahres. Sie zeigt, wie ein Unternehmen Geld verdient (oder verliert).</a:t>
+            </a:r>
+          </a:p>
+          <a:p>
+            <a:pPr>
+              <a:spcBef>
+                <a:spcPts val="400"/>
+              </a:spcBef>
+              <a:spcAft>
+                <a:spcPts val="200"/>
+              </a:spcAft>
+            </a:pPr>
+            <a:r>
+              <a:rPr sz="1300">
+                <a:solidFill>
+                  <a:srgbClr val="3D5466"/>
+                </a:solidFill>
+                <a:latin typeface="Arial"/>
+              </a:rPr>
+              <a:t>▸  Anhang (§ 284 HGB): Erläuterungen und Ergänzungen zu Bilanz und GuV (z.B. Bilanzierungsmethoden, Haftungsverhältnisse). Für den Kreditgeber oft wertvoller als die nackten Zahlen.</a:t>
+            </a:r>
+          </a:p>
+          <a:p>
+            <a:pPr>
+              <a:spcBef>
+                <a:spcPts val="400"/>
+              </a:spcBef>
+              <a:spcAft>
+                <a:spcPts val="200"/>
+              </a:spcAft>
+            </a:pPr>
+            <a:r>
+              <a:rPr sz="1300">
+                <a:solidFill>
+                  <a:srgbClr val="3D5466"/>
+                </a:solidFill>
+                <a:latin typeface="Arial"/>
+              </a:rPr>
+              <a:t>▸  Lagebericht (§ 289 HGB): Lageeinschätzung des Managements, Risikobericht, Ausblick. Nur für mittelgroße und große Unternehmen verpflichtend.</a:t>
+            </a:r>
+          </a:p>
+          <a:p>
+            <a:pPr>
+              <a:spcBef>
+                <a:spcPts val="1000"/>
+              </a:spcBef>
+              <a:spcAft>
+                <a:spcPts val="200"/>
+              </a:spcAft>
+            </a:pPr>
+            <a:r>
+              <a:rPr sz="800" b="1">
+                <a:solidFill>
+                  <a:srgbClr val="78808C"/>
+                </a:solidFill>
+                <a:latin typeface="JetBrains Mono"/>
+              </a:rPr>
+              <a:t>OFFENLEGUNGSPFLICHTEN UND GRÖSSENKLASSEN (§ 267 HGB)</a:t>
+            </a:r>
+          </a:p>
+          <a:p>
+            <a:pPr>
+              <a:spcBef>
+                <a:spcPts val="1000"/>
+              </a:spcBef>
+              <a:spcAft>
+                <a:spcPts val="200"/>
+              </a:spcAft>
+            </a:pPr>
+            <a:r>
+              <a:rPr sz="800" b="1">
+                <a:solidFill>
+                  <a:srgbClr val="78808C"/>
+                </a:solidFill>
+                <a:latin typeface="JetBrains Mono"/>
+              </a:rPr>
+              <a:t>BILANZSTRUKTUR: MITTELHERKUNFT UND -VERWENDUNG</a:t>
+            </a:r>
+          </a:p>
+          <a:p>
+            <a:pPr>
+              <a:spcBef>
+                <a:spcPts val="1000"/>
+              </a:spcBef>
+              <a:spcAft>
+                <a:spcPts val="200"/>
+              </a:spcAft>
+            </a:pPr>
+            <a:r>
+              <a:rPr sz="800" b="1">
+                <a:solidFill>
+                  <a:srgbClr val="78808C"/>
+                </a:solidFill>
+                <a:latin typeface="JetBrains Mono"/>
+              </a:rPr>
+              <a:t>BILANZIERUNGSWAHLRECHTE UND IHRE WIRKUNG</a:t>
+            </a:r>
+          </a:p>
+          <a:p>
+            <a:pPr>
+              <a:spcBef>
+                <a:spcPts val="1000"/>
+              </a:spcBef>
+              <a:spcAft>
+                <a:spcPts val="200"/>
+              </a:spcAft>
+            </a:pPr>
+            <a:r>
+              <a:rPr sz="800" b="1">
+                <a:solidFill>
+                  <a:srgbClr val="78808C"/>
+                </a:solidFill>
+                <a:latin typeface="JetBrains Mono"/>
+              </a:rPr>
+              <a:t>BILANZKENNZAHLEN IM ÜBERBLICK</a:t>
+            </a:r>
+          </a:p>
+          <a:p>
+            <a:pPr>
+              <a:spcBef>
+                <a:spcPts val="400"/>
+              </a:spcBef>
+              <a:spcAft>
+                <a:spcPts val="200"/>
+              </a:spcAft>
+            </a:pPr>
+            <a:r>
+              <a:rPr sz="1300">
+                <a:solidFill>
+                  <a:srgbClr val="3D5466"/>
+                </a:solidFill>
+                <a:latin typeface="Arial"/>
+              </a:rPr>
+              <a:t>▸  Die sechs zentralen Kennzahlen mit Formel, Benchmark und Bewertungsampel:</a:t>
+            </a:r>
+          </a:p>
+        </p:txBody>
+      </p:sp>
+      <p:sp>
+        <p:nvSpPr>
+          <p:cNvPr id="9" name="Rectangle 8"/>
           <p:cNvSpPr/>
           <p:nvPr/>
         </p:nvSpPr>
@@ -6291,7 +7901,7 @@
       </p:sp>
       <p:sp>
         <p:nvSpPr>
-          <p:cNvPr id="9" name="TextBox 8"/>
+          <p:cNvPr id="10" name="TextBox 9"/>
           <p:cNvSpPr txBox="1"/>
           <p:nvPr/>
         </p:nvSpPr>
@@ -6320,41 +7930,6 @@
                 <a:latin typeface="JetBrains Mono"/>
               </a:rPr>
               <a:t>Benedikt Zoller Coaching  ·  FKB Campus  ·  M01</a:t>
-            </a:r>
-          </a:p>
-        </p:txBody>
-      </p:sp>
-      <p:sp>
-        <p:nvSpPr>
-          <p:cNvPr id="10" name="TextBox 9"/>
-          <p:cNvSpPr txBox="1"/>
-          <p:nvPr/>
-        </p:nvSpPr>
-        <p:spPr>
-          <a:xfrm>
-            <a:off x="7176211" y="6583680"/>
-            <a:ext cx="4326940" cy="256032"/>
-          </a:xfrm>
-          <a:prstGeom prst="rect">
-            <a:avLst/>
-          </a:prstGeom>
-          <a:noFill/>
-        </p:spPr>
-        <p:txBody>
-          <a:bodyPr wrap="none">
-            <a:spAutoFit/>
-          </a:bodyPr>
-          <a:lstStyle/>
-          <a:p>
-            <a:pPr algn="r"/>
-            <a:r>
-              <a:rPr sz="700">
-                <a:solidFill>
-                  <a:srgbClr val="A0B4D2"/>
-                </a:solidFill>
-                <a:latin typeface="JetBrains Mono"/>
-              </a:rPr>
-              <a:t>Schaubild</a:t>
             </a:r>
           </a:p>
         </p:txBody>
@@ -6528,7 +8103,7 @@
                 </a:solidFill>
                 <a:latin typeface="Source Serif 4"/>
               </a:rPr>
-              <a:t>Bilanzkennzahlen-Karte mit Bewertungsampel</a:t>
+              <a:t>Bilanzstruktur T-Konto</a:t>
             </a:r>
           </a:p>
         </p:txBody>
@@ -6592,8 +8167,8 @@
         </p:blipFill>
         <p:spPr>
           <a:xfrm>
-            <a:off x="2163921" y="1325880"/>
-            <a:ext cx="7861110" cy="4937760"/>
+            <a:off x="1931981" y="1325880"/>
+            <a:ext cx="8324990" cy="4937760"/>
           </a:xfrm>
           <a:prstGeom prst="rect">
             <a:avLst/>
@@ -6746,7 +8321,7 @@
             <a:avLst/>
           </a:prstGeom>
           <a:solidFill>
-            <a:srgbClr val="EDEDF3"/>
+            <a:srgbClr val="FFFFFF"/>
           </a:solidFill>
           <a:ln>
             <a:noFill/>
@@ -6847,51 +8422,43 @@
                 </a:solidFill>
                 <a:latin typeface="JetBrains Mono"/>
               </a:rPr>
-              <a:t>M01  ·  ARBEITSBLATT</a:t>
-            </a:r>
-          </a:p>
-        </p:txBody>
-      </p:sp>
-      <p:sp>
-        <p:nvSpPr>
-          <p:cNvPr id="5" name="Rectangle 4"/>
-          <p:cNvSpPr/>
-          <p:nvPr/>
-        </p:nvSpPr>
-        <p:spPr>
-          <a:xfrm>
-            <a:off x="0" y="1234440"/>
-            <a:ext cx="12188952" cy="12700"/>
-          </a:xfrm>
-          <a:prstGeom prst="rect">
-            <a:avLst/>
-          </a:prstGeom>
-          <a:solidFill>
-            <a:srgbClr val="D8DFE4"/>
-          </a:solidFill>
-          <a:ln>
-            <a:noFill/>
-          </a:ln>
-        </p:spPr>
-        <p:style>
-          <a:lnRef idx="1">
-            <a:schemeClr val="accent1"/>
-          </a:lnRef>
-          <a:fillRef idx="3">
-            <a:schemeClr val="accent1"/>
-          </a:fillRef>
-          <a:effectRef idx="2">
-            <a:schemeClr val="accent1"/>
-          </a:effectRef>
-          <a:fontRef idx="minor">
-            <a:schemeClr val="lt1"/>
-          </a:fontRef>
-        </p:style>
-        <p:txBody>
-          <a:bodyPr rtlCol="0" anchor="ctr"/>
-          <a:lstStyle/>
-          <a:p>
-            <a:pPr algn="ctr"/>
+              <a:t>M01  ·  SCHAUBILD</a:t>
+            </a:r>
+          </a:p>
+        </p:txBody>
+      </p:sp>
+      <p:sp>
+        <p:nvSpPr>
+          <p:cNvPr id="5" name="TextBox 4"/>
+          <p:cNvSpPr txBox="1"/>
+          <p:nvPr/>
+        </p:nvSpPr>
+        <p:spPr>
+          <a:xfrm>
+            <a:off x="685800" y="502920"/>
+            <a:ext cx="10817352" cy="594360"/>
+          </a:xfrm>
+          <a:prstGeom prst="rect">
+            <a:avLst/>
+          </a:prstGeom>
+          <a:noFill/>
+        </p:spPr>
+        <p:txBody>
+          <a:bodyPr wrap="square">
+            <a:spAutoFit/>
+          </a:bodyPr>
+          <a:lstStyle/>
+          <a:p>
+            <a:pPr algn="l"/>
+            <a:r>
+              <a:rPr sz="2000" b="1" i="0">
+                <a:solidFill>
+                  <a:srgbClr val="1F2C56"/>
+                </a:solidFill>
+                <a:latin typeface="Source Serif 4"/>
+              </a:rPr>
+              <a:t>Bilanzkennzahlen-Karte mit Bewertungsampel</a:t>
+            </a:r>
           </a:p>
         </p:txBody>
       </p:sp>
@@ -6903,8 +8470,8 @@
         </p:nvSpPr>
         <p:spPr>
           <a:xfrm>
-            <a:off x="685800" y="502920"/>
-            <a:ext cx="36576" cy="658368"/>
+            <a:off x="685800" y="1143000"/>
+            <a:ext cx="10817352" cy="25400"/>
           </a:xfrm>
           <a:prstGeom prst="rect">
             <a:avLst/>
@@ -6938,240 +8505,33 @@
           </a:p>
         </p:txBody>
       </p:sp>
-      <p:sp>
-        <p:nvSpPr>
-          <p:cNvPr id="7" name="TextBox 6"/>
-          <p:cNvSpPr txBox="1"/>
-          <p:nvPr/>
-        </p:nvSpPr>
-        <p:spPr>
-          <a:xfrm>
-            <a:off x="813816" y="502920"/>
-            <a:ext cx="10634472" cy="685800"/>
-          </a:xfrm>
-          <a:prstGeom prst="rect">
-            <a:avLst/>
-          </a:prstGeom>
-          <a:noFill/>
-        </p:spPr>
-        <p:txBody>
-          <a:bodyPr wrap="square">
-            <a:spAutoFit/>
-          </a:bodyPr>
-          <a:lstStyle/>
-          <a:p>
-            <a:pPr algn="l"/>
-            <a:r>
-              <a:rPr sz="2400" b="1" i="0">
-                <a:solidFill>
-                  <a:srgbClr val="1F2C56"/>
-                </a:solidFill>
-                <a:latin typeface="Source Serif 4"/>
-              </a:rPr>
-              <a:t>Praxisfall: Musterbilanz „Bauer GmbH"</a:t>
-            </a:r>
-          </a:p>
-        </p:txBody>
-      </p:sp>
-      <p:sp>
-        <p:nvSpPr>
-          <p:cNvPr id="8" name="TextBox 7"/>
-          <p:cNvSpPr txBox="1"/>
-          <p:nvPr/>
-        </p:nvSpPr>
-        <p:spPr>
-          <a:xfrm>
-            <a:off x="685800" y="1554480"/>
-            <a:ext cx="10817352" cy="3840480"/>
-          </a:xfrm>
-          <a:prstGeom prst="rect">
-            <a:avLst/>
-          </a:prstGeom>
-          <a:noFill/>
-        </p:spPr>
-        <p:txBody>
-          <a:bodyPr wrap="square">
-            <a:spAutoFit/>
-          </a:bodyPr>
-          <a:lstStyle/>
-          <a:p>
-            <a:pPr>
-              <a:spcBef>
-                <a:spcPts val="400"/>
-              </a:spcBef>
-              <a:spcAft>
-                <a:spcPts val="200"/>
-              </a:spcAft>
-            </a:pPr>
-            <a:r>
-              <a:rPr sz="1400">
-                <a:solidFill>
-                  <a:srgbClr val="3D5466"/>
-                </a:solidFill>
-                <a:latin typeface="Arial"/>
-              </a:rPr>
-              <a:t>▸  Unternehmensportrait (anonymisiert, branchentypisch)</a:t>
-            </a:r>
-          </a:p>
-          <a:p>
-            <a:pPr>
-              <a:spcBef>
-                <a:spcPts val="400"/>
-              </a:spcBef>
-              <a:spcAft>
-                <a:spcPts val="200"/>
-              </a:spcAft>
-            </a:pPr>
-            <a:r>
-              <a:rPr sz="1400">
-                <a:solidFill>
-                  <a:srgbClr val="3D5466"/>
-                </a:solidFill>
-                <a:latin typeface="Arial"/>
-              </a:rPr>
-              <a:t>▸  Situation: Der Kunde beantragt ein neues Investitionsdarlehen über 650.000 EUR für eine neue CNC-Fräsmaschine. Sie bereiten die Kreditvorlage vor und lesen den Jahresabschluss 2023.</a:t>
-            </a:r>
-          </a:p>
-          <a:p>
-            <a:pPr>
-              <a:spcBef>
-                <a:spcPts val="400"/>
-              </a:spcBef>
-              <a:spcAft>
-                <a:spcPts val="200"/>
-              </a:spcAft>
-            </a:pPr>
-            <a:r>
-              <a:rPr sz="1400">
-                <a:solidFill>
-                  <a:srgbClr val="3D5466"/>
-                </a:solidFill>
-                <a:latin typeface="Arial"/>
-              </a:rPr>
-              <a:t>▸  Die folgende Handlungsempfehlung verknüpft typische Bilanzsignale mit der passenden Reaktion im Kreditgespräch – nutzen Sie sie als Orientierung bei der Auswertung des Praxisfalls.</a:t>
-            </a:r>
-          </a:p>
-          <a:p>
-            <a:pPr>
-              <a:spcBef>
-                <a:spcPts val="400"/>
-              </a:spcBef>
-              <a:spcAft>
-                <a:spcPts val="200"/>
-              </a:spcAft>
-            </a:pPr>
-            <a:r>
-              <a:rPr sz="1400">
-                <a:solidFill>
-                  <a:srgbClr val="3D5466"/>
-                </a:solidFill>
-                <a:latin typeface="Arial"/>
-              </a:rPr>
-              <a:t>▸  Musterbilanz Bauer GmbH (31.12.2023)</a:t>
-            </a:r>
-          </a:p>
-          <a:p>
-            <a:pPr>
-              <a:spcBef>
-                <a:spcPts val="400"/>
-              </a:spcBef>
-              <a:spcAft>
-                <a:spcPts val="200"/>
-              </a:spcAft>
-            </a:pPr>
-            <a:r>
-              <a:rPr sz="1400">
-                <a:solidFill>
-                  <a:srgbClr val="3D5466"/>
-                </a:solidFill>
-                <a:latin typeface="Arial"/>
-              </a:rPr>
-              <a:t>▸  BILANZ – Aktivseite</a:t>
-            </a:r>
-          </a:p>
-        </p:txBody>
-      </p:sp>
-      <p:sp>
-        <p:nvSpPr>
-          <p:cNvPr id="9" name="Rectangle 8"/>
-          <p:cNvSpPr/>
-          <p:nvPr/>
-        </p:nvSpPr>
-        <p:spPr>
-          <a:xfrm>
-            <a:off x="685800" y="5486400"/>
-            <a:ext cx="10817352" cy="640080"/>
-          </a:xfrm>
-          <a:prstGeom prst="rect">
-            <a:avLst/>
-          </a:prstGeom>
-          <a:solidFill>
-            <a:srgbClr val="1F2C56"/>
-          </a:solidFill>
-          <a:ln>
-            <a:noFill/>
-          </a:ln>
-        </p:spPr>
-        <p:style>
-          <a:lnRef idx="1">
-            <a:schemeClr val="accent1"/>
-          </a:lnRef>
-          <a:fillRef idx="3">
-            <a:schemeClr val="accent1"/>
-          </a:fillRef>
-          <a:effectRef idx="2">
-            <a:schemeClr val="accent1"/>
-          </a:effectRef>
-          <a:fontRef idx="minor">
-            <a:schemeClr val="lt1"/>
-          </a:fontRef>
-        </p:style>
-        <p:txBody>
-          <a:bodyPr rtlCol="0" anchor="ctr"/>
-          <a:lstStyle/>
-          <a:p>
-            <a:pPr algn="ctr"/>
-          </a:p>
-        </p:txBody>
-      </p:sp>
-      <p:sp>
-        <p:nvSpPr>
-          <p:cNvPr id="10" name="TextBox 9"/>
-          <p:cNvSpPr txBox="1"/>
-          <p:nvPr/>
-        </p:nvSpPr>
-        <p:spPr>
-          <a:xfrm>
-            <a:off x="868680" y="5596128"/>
-            <a:ext cx="10451592" cy="457200"/>
-          </a:xfrm>
-          <a:prstGeom prst="rect">
-            <a:avLst/>
-          </a:prstGeom>
-          <a:noFill/>
-        </p:spPr>
-        <p:txBody>
-          <a:bodyPr wrap="square">
-            <a:spAutoFit/>
-          </a:bodyPr>
-          <a:lstStyle/>
-          <a:p>
-            <a:pPr algn="l"/>
-            <a:r>
-              <a:rPr sz="1300" b="1" i="0">
-                <a:solidFill>
-                  <a:srgbClr val="FFFFFF"/>
-                </a:solidFill>
-                <a:latin typeface="Arial"/>
-              </a:rPr>
-              <a:t>→  Bearbeitung im Teilnehmer-Workbook (Arbeitsblatt mit Ausfüllfeldern)</a:t>
-            </a:r>
-          </a:p>
-        </p:txBody>
-      </p:sp>
-      <p:sp>
-        <p:nvSpPr>
-          <p:cNvPr id="11" name="Rectangle 10"/>
+      <p:pic>
+        <p:nvPicPr>
+          <p:cNvPr id="7" name="Picture 6" descr="image.png"/>
+          <p:cNvPicPr>
+            <a:picLocks noChangeAspect="1"/>
+          </p:cNvPicPr>
+          <p:nvPr/>
+        </p:nvPicPr>
+        <p:blipFill>
+          <a:blip r:embed="rId2"/>
+          <a:stretch>
+            <a:fillRect/>
+          </a:stretch>
+        </p:blipFill>
+        <p:spPr>
+          <a:xfrm>
+            <a:off x="2163921" y="1325880"/>
+            <a:ext cx="7861110" cy="4937760"/>
+          </a:xfrm>
+          <a:prstGeom prst="rect">
+            <a:avLst/>
+          </a:prstGeom>
+        </p:spPr>
+      </p:pic>
+      <p:sp>
+        <p:nvSpPr>
+          <p:cNvPr id="8" name="Rectangle 7"/>
           <p:cNvSpPr/>
           <p:nvPr/>
         </p:nvSpPr>
@@ -7214,7 +8574,7 @@
       </p:sp>
       <p:sp>
         <p:nvSpPr>
-          <p:cNvPr id="12" name="TextBox 11"/>
+          <p:cNvPr id="9" name="TextBox 8"/>
           <p:cNvSpPr txBox="1"/>
           <p:nvPr/>
         </p:nvSpPr>
@@ -7243,6 +8603,41 @@
                 <a:latin typeface="JetBrains Mono"/>
               </a:rPr>
               <a:t>Benedikt Zoller Coaching  ·  FKB Campus  ·  M01</a:t>
+            </a:r>
+          </a:p>
+        </p:txBody>
+      </p:sp>
+      <p:sp>
+        <p:nvSpPr>
+          <p:cNvPr id="10" name="TextBox 9"/>
+          <p:cNvSpPr txBox="1"/>
+          <p:nvPr/>
+        </p:nvSpPr>
+        <p:spPr>
+          <a:xfrm>
+            <a:off x="7176211" y="6583680"/>
+            <a:ext cx="4326940" cy="256032"/>
+          </a:xfrm>
+          <a:prstGeom prst="rect">
+            <a:avLst/>
+          </a:prstGeom>
+          <a:noFill/>
+        </p:spPr>
+        <p:txBody>
+          <a:bodyPr wrap="none">
+            <a:spAutoFit/>
+          </a:bodyPr>
+          <a:lstStyle/>
+          <a:p>
+            <a:pPr algn="r"/>
+            <a:r>
+              <a:rPr sz="700">
+                <a:solidFill>
+                  <a:srgbClr val="A0B4D2"/>
+                </a:solidFill>
+                <a:latin typeface="JetBrains Mono"/>
+              </a:rPr>
+              <a:t>Schaubild</a:t>
             </a:r>
           </a:p>
         </p:txBody>
@@ -7381,7 +8776,7 @@
                 </a:solidFill>
                 <a:latin typeface="JetBrains Mono"/>
               </a:rPr>
-              <a:t>M01  ·  SCHAUBILD</a:t>
+              <a:t>M01  ·  ÜBERSICHT</a:t>
             </a:r>
           </a:p>
         </p:txBody>
@@ -7416,7 +8811,7 @@
                 </a:solidFill>
                 <a:latin typeface="Source Serif 4"/>
               </a:rPr>
-              <a:t>Analyseprozess in vier Schritten</a:t>
+              <a:t>Theorie-Input: Aufbau des HGB-Jahresabschlusses</a:t>
             </a:r>
           </a:p>
         </p:txBody>
@@ -7464,30 +8859,423 @@
           </a:p>
         </p:txBody>
       </p:sp>
-      <p:pic>
-        <p:nvPicPr>
-          <p:cNvPr id="7" name="Picture 6" descr="image.png"/>
-          <p:cNvPicPr>
-            <a:picLocks noChangeAspect="1"/>
-          </p:cNvPicPr>
-          <p:nvPr/>
-        </p:nvPicPr>
-        <p:blipFill>
-          <a:blip r:embed="rId2"/>
-          <a:stretch>
-            <a:fillRect/>
-          </a:stretch>
-        </p:blipFill>
-        <p:spPr>
-          <a:xfrm>
-            <a:off x="1670951" y="1325880"/>
-            <a:ext cx="8847050" cy="4937760"/>
-          </a:xfrm>
-          <a:prstGeom prst="rect">
-            <a:avLst/>
-          </a:prstGeom>
-        </p:spPr>
-      </p:pic>
+      <p:graphicFrame>
+        <p:nvGraphicFramePr>
+          <p:cNvPr id="7" name="Table 6"/>
+          <p:cNvGraphicFramePr>
+            <a:graphicFrameLocks noGrp="1"/>
+          </p:cNvGraphicFramePr>
+          <p:nvPr/>
+        </p:nvGraphicFramePr>
+        <p:xfrm>
+          <a:off x="685800" y="1417320"/>
+          <a:ext cx="10817352" cy="1536192"/>
+        </p:xfrm>
+        <a:graphic>
+          <a:graphicData uri="http://schemas.openxmlformats.org/drawingml/2006/table">
+            <a:tbl>
+              <a:tblPr firstRow="1" bandRow="1">
+                <a:tableStyleId>{5C22544A-7EE6-4342-B048-85BDC9FD1C3A}</a:tableStyleId>
+              </a:tblPr>
+              <a:tblGrid>
+                <a:gridCol w="2163470"/>
+                <a:gridCol w="2163470"/>
+                <a:gridCol w="2163470"/>
+                <a:gridCol w="2163470"/>
+                <a:gridCol w="2163472"/>
+              </a:tblGrid>
+              <a:tr h="384048">
+                <a:tc>
+                  <a:txBody>
+                    <a:bodyPr/>
+                    <a:lstStyle/>
+                    <a:p>
+                      <a:r>
+                        <a:rPr sz="1100" b="1">
+                          <a:solidFill>
+                            <a:srgbClr val="FFFFFF"/>
+                          </a:solidFill>
+                          <a:latin typeface="Arial"/>
+                        </a:rPr>
+                        <a:t>Größenklasse</a:t>
+                      </a:r>
+                    </a:p>
+                  </a:txBody>
+                  <a:tcPr>
+                    <a:solidFill>
+                      <a:srgbClr val="1F2C56"/>
+                    </a:solidFill>
+                  </a:tcPr>
+                </a:tc>
+                <a:tc>
+                  <a:txBody>
+                    <a:bodyPr/>
+                    <a:lstStyle/>
+                    <a:p>
+                      <a:r>
+                        <a:rPr sz="1100" b="1">
+                          <a:solidFill>
+                            <a:srgbClr val="FFFFFF"/>
+                          </a:solidFill>
+                          <a:latin typeface="Arial"/>
+                        </a:rPr>
+                        <a:t>Bilanzsumme</a:t>
+                      </a:r>
+                    </a:p>
+                  </a:txBody>
+                  <a:tcPr>
+                    <a:solidFill>
+                      <a:srgbClr val="1F2C56"/>
+                    </a:solidFill>
+                  </a:tcPr>
+                </a:tc>
+                <a:tc>
+                  <a:txBody>
+                    <a:bodyPr/>
+                    <a:lstStyle/>
+                    <a:p>
+                      <a:r>
+                        <a:rPr sz="1100" b="1">
+                          <a:solidFill>
+                            <a:srgbClr val="FFFFFF"/>
+                          </a:solidFill>
+                          <a:latin typeface="Arial"/>
+                        </a:rPr>
+                        <a:t>Umsatz</a:t>
+                      </a:r>
+                    </a:p>
+                  </a:txBody>
+                  <a:tcPr>
+                    <a:solidFill>
+                      <a:srgbClr val="1F2C56"/>
+                    </a:solidFill>
+                  </a:tcPr>
+                </a:tc>
+                <a:tc>
+                  <a:txBody>
+                    <a:bodyPr/>
+                    <a:lstStyle/>
+                    <a:p>
+                      <a:r>
+                        <a:rPr sz="1100" b="1">
+                          <a:solidFill>
+                            <a:srgbClr val="FFFFFF"/>
+                          </a:solidFill>
+                          <a:latin typeface="Arial"/>
+                        </a:rPr>
+                        <a:t>Mitarbeiter</a:t>
+                      </a:r>
+                    </a:p>
+                  </a:txBody>
+                  <a:tcPr>
+                    <a:solidFill>
+                      <a:srgbClr val="1F2C56"/>
+                    </a:solidFill>
+                  </a:tcPr>
+                </a:tc>
+                <a:tc>
+                  <a:txBody>
+                    <a:bodyPr/>
+                    <a:lstStyle/>
+                    <a:p>
+                      <a:r>
+                        <a:rPr sz="1100" b="1">
+                          <a:solidFill>
+                            <a:srgbClr val="FFFFFF"/>
+                          </a:solidFill>
+                          <a:latin typeface="Arial"/>
+                        </a:rPr>
+                        <a:t>Offenlegungspflicht</a:t>
+                      </a:r>
+                    </a:p>
+                  </a:txBody>
+                  <a:tcPr>
+                    <a:solidFill>
+                      <a:srgbClr val="1F2C56"/>
+                    </a:solidFill>
+                  </a:tcPr>
+                </a:tc>
+              </a:tr>
+              <a:tr h="384048">
+                <a:tc>
+                  <a:txBody>
+                    <a:bodyPr/>
+                    <a:lstStyle/>
+                    <a:p>
+                      <a:r>
+                        <a:rPr sz="1050">
+                          <a:solidFill>
+                            <a:srgbClr val="3D5466"/>
+                          </a:solidFill>
+                          <a:latin typeface="Arial"/>
+                        </a:rPr>
+                        <a:t>Klein</a:t>
+                      </a:r>
+                    </a:p>
+                  </a:txBody>
+                  <a:tcPr/>
+                </a:tc>
+                <a:tc>
+                  <a:txBody>
+                    <a:bodyPr/>
+                    <a:lstStyle/>
+                    <a:p>
+                      <a:r>
+                        <a:rPr sz="1050">
+                          <a:solidFill>
+                            <a:srgbClr val="3D5466"/>
+                          </a:solidFill>
+                          <a:latin typeface="Arial"/>
+                        </a:rPr>
+                        <a:t>≤ 6 Mio. EUR</a:t>
+                      </a:r>
+                    </a:p>
+                  </a:txBody>
+                  <a:tcPr/>
+                </a:tc>
+                <a:tc>
+                  <a:txBody>
+                    <a:bodyPr/>
+                    <a:lstStyle/>
+                    <a:p>
+                      <a:r>
+                        <a:rPr sz="1050">
+                          <a:solidFill>
+                            <a:srgbClr val="3D5466"/>
+                          </a:solidFill>
+                          <a:latin typeface="Arial"/>
+                        </a:rPr>
+                        <a:t>≤ 12 Mio. EUR</a:t>
+                      </a:r>
+                    </a:p>
+                  </a:txBody>
+                  <a:tcPr/>
+                </a:tc>
+                <a:tc>
+                  <a:txBody>
+                    <a:bodyPr/>
+                    <a:lstStyle/>
+                    <a:p>
+                      <a:r>
+                        <a:rPr sz="1050">
+                          <a:solidFill>
+                            <a:srgbClr val="3D5466"/>
+                          </a:solidFill>
+                          <a:latin typeface="Arial"/>
+                        </a:rPr>
+                        <a:t>≤ 50</a:t>
+                      </a:r>
+                    </a:p>
+                  </a:txBody>
+                  <a:tcPr/>
+                </a:tc>
+                <a:tc>
+                  <a:txBody>
+                    <a:bodyPr/>
+                    <a:lstStyle/>
+                    <a:p>
+                      <a:r>
+                        <a:rPr sz="1050">
+                          <a:solidFill>
+                            <a:srgbClr val="3D5466"/>
+                          </a:solidFill>
+                          <a:latin typeface="Arial"/>
+                        </a:rPr>
+                        <a:t>Verkürzte Bilanz, keine GuV</a:t>
+                      </a:r>
+                    </a:p>
+                  </a:txBody>
+                  <a:tcPr/>
+                </a:tc>
+              </a:tr>
+              <a:tr h="384048">
+                <a:tc>
+                  <a:txBody>
+                    <a:bodyPr/>
+                    <a:lstStyle/>
+                    <a:p>
+                      <a:r>
+                        <a:rPr sz="1050">
+                          <a:solidFill>
+                            <a:srgbClr val="3D5466"/>
+                          </a:solidFill>
+                          <a:latin typeface="Arial"/>
+                        </a:rPr>
+                        <a:t>Mittel</a:t>
+                      </a:r>
+                    </a:p>
+                  </a:txBody>
+                  <a:tcPr/>
+                </a:tc>
+                <a:tc>
+                  <a:txBody>
+                    <a:bodyPr/>
+                    <a:lstStyle/>
+                    <a:p>
+                      <a:r>
+                        <a:rPr sz="1050">
+                          <a:solidFill>
+                            <a:srgbClr val="3D5466"/>
+                          </a:solidFill>
+                          <a:latin typeface="Arial"/>
+                        </a:rPr>
+                        <a:t>≤ 20 Mio. EUR</a:t>
+                      </a:r>
+                    </a:p>
+                  </a:txBody>
+                  <a:tcPr/>
+                </a:tc>
+                <a:tc>
+                  <a:txBody>
+                    <a:bodyPr/>
+                    <a:lstStyle/>
+                    <a:p>
+                      <a:r>
+                        <a:rPr sz="1050">
+                          <a:solidFill>
+                            <a:srgbClr val="3D5466"/>
+                          </a:solidFill>
+                          <a:latin typeface="Arial"/>
+                        </a:rPr>
+                        <a:t>≤ 40 Mio. EUR</a:t>
+                      </a:r>
+                    </a:p>
+                  </a:txBody>
+                  <a:tcPr/>
+                </a:tc>
+                <a:tc>
+                  <a:txBody>
+                    <a:bodyPr/>
+                    <a:lstStyle/>
+                    <a:p>
+                      <a:r>
+                        <a:rPr sz="1050">
+                          <a:solidFill>
+                            <a:srgbClr val="3D5466"/>
+                          </a:solidFill>
+                          <a:latin typeface="Arial"/>
+                        </a:rPr>
+                        <a:t>≤ 250</a:t>
+                      </a:r>
+                    </a:p>
+                  </a:txBody>
+                  <a:tcPr/>
+                </a:tc>
+                <a:tc>
+                  <a:txBody>
+                    <a:bodyPr/>
+                    <a:lstStyle/>
+                    <a:p>
+                      <a:r>
+                        <a:rPr sz="1050">
+                          <a:solidFill>
+                            <a:srgbClr val="3D5466"/>
+                          </a:solidFill>
+                          <a:latin typeface="Arial"/>
+                        </a:rPr>
+                        <a:t>Bilanz + GuV + Anhang</a:t>
+                      </a:r>
+                    </a:p>
+                  </a:txBody>
+                  <a:tcPr/>
+                </a:tc>
+              </a:tr>
+              <a:tr h="384048">
+                <a:tc>
+                  <a:txBody>
+                    <a:bodyPr/>
+                    <a:lstStyle/>
+                    <a:p>
+                      <a:r>
+                        <a:rPr sz="1050">
+                          <a:solidFill>
+                            <a:srgbClr val="3D5466"/>
+                          </a:solidFill>
+                          <a:latin typeface="Arial"/>
+                        </a:rPr>
+                        <a:t>Groß</a:t>
+                      </a:r>
+                    </a:p>
+                  </a:txBody>
+                  <a:tcPr/>
+                </a:tc>
+                <a:tc>
+                  <a:txBody>
+                    <a:bodyPr/>
+                    <a:lstStyle/>
+                    <a:p>
+                      <a:r>
+                        <a:rPr sz="1050">
+                          <a:solidFill>
+                            <a:srgbClr val="3D5466"/>
+                          </a:solidFill>
+                          <a:latin typeface="Arial"/>
+                        </a:rPr>
+                        <a:t>&gt; 20 Mio. EUR</a:t>
+                      </a:r>
+                    </a:p>
+                  </a:txBody>
+                  <a:tcPr/>
+                </a:tc>
+                <a:tc>
+                  <a:txBody>
+                    <a:bodyPr/>
+                    <a:lstStyle/>
+                    <a:p>
+                      <a:r>
+                        <a:rPr sz="1050">
+                          <a:solidFill>
+                            <a:srgbClr val="3D5466"/>
+                          </a:solidFill>
+                          <a:latin typeface="Arial"/>
+                        </a:rPr>
+                        <a:t>&gt; 40 Mio. EUR</a:t>
+                      </a:r>
+                    </a:p>
+                  </a:txBody>
+                  <a:tcPr/>
+                </a:tc>
+                <a:tc>
+                  <a:txBody>
+                    <a:bodyPr/>
+                    <a:lstStyle/>
+                    <a:p>
+                      <a:r>
+                        <a:rPr sz="1050">
+                          <a:solidFill>
+                            <a:srgbClr val="3D5466"/>
+                          </a:solidFill>
+                          <a:latin typeface="Arial"/>
+                        </a:rPr>
+                        <a:t>&gt; 250</a:t>
+                      </a:r>
+                    </a:p>
+                  </a:txBody>
+                  <a:tcPr/>
+                </a:tc>
+                <a:tc>
+                  <a:txBody>
+                    <a:bodyPr/>
+                    <a:lstStyle/>
+                    <a:p>
+                      <a:r>
+                        <a:rPr sz="1050">
+                          <a:solidFill>
+                            <a:srgbClr val="3D5466"/>
+                          </a:solidFill>
+                          <a:latin typeface="Arial"/>
+                        </a:rPr>
+                        <a:t>Vollständig + Lagebericht</a:t>
+                      </a:r>
+                    </a:p>
+                  </a:txBody>
+                  <a:tcPr/>
+                </a:tc>
+              </a:tr>
+            </a:tbl>
+          </a:graphicData>
+        </a:graphic>
+      </p:graphicFrame>
       <p:sp>
         <p:nvSpPr>
           <p:cNvPr id="8" name="Rectangle 7"/>
@@ -7596,7 +9384,7 @@
                 </a:solidFill>
                 <a:latin typeface="JetBrains Mono"/>
               </a:rPr>
-              <a:t>Schaubild</a:t>
+              <a:t>Übersicht</a:t>
             </a:r>
           </a:p>
         </p:txBody>
@@ -7735,7 +9523,7 @@
                 </a:solidFill>
                 <a:latin typeface="JetBrains Mono"/>
               </a:rPr>
-              <a:t>M01  ·  SCHAUBILD</a:t>
+              <a:t>M01  ·  ÜBERSICHT</a:t>
             </a:r>
           </a:p>
         </p:txBody>
@@ -7770,7 +9558,7 @@
                 </a:solidFill>
                 <a:latin typeface="Source Serif 4"/>
               </a:rPr>
-              <a:t>Handlungsempfehlung</a:t>
+              <a:t>Theorie-Input: Aufbau des HGB-Jahresabschlusses</a:t>
             </a:r>
           </a:p>
         </p:txBody>
@@ -7818,30 +9606,325 @@
           </a:p>
         </p:txBody>
       </p:sp>
-      <p:pic>
-        <p:nvPicPr>
-          <p:cNvPr id="7" name="Picture 6" descr="image.png"/>
-          <p:cNvPicPr>
-            <a:picLocks noChangeAspect="1"/>
-          </p:cNvPicPr>
-          <p:nvPr/>
-        </p:nvPicPr>
-        <p:blipFill>
-          <a:blip r:embed="rId2"/>
-          <a:stretch>
-            <a:fillRect/>
-          </a:stretch>
-        </p:blipFill>
-        <p:spPr>
-          <a:xfrm>
-            <a:off x="2303489" y="1325880"/>
-            <a:ext cx="7581973" cy="4937760"/>
-          </a:xfrm>
-          <a:prstGeom prst="rect">
-            <a:avLst/>
-          </a:prstGeom>
-        </p:spPr>
-      </p:pic>
+      <p:graphicFrame>
+        <p:nvGraphicFramePr>
+          <p:cNvPr id="7" name="Table 6"/>
+          <p:cNvGraphicFramePr>
+            <a:graphicFrameLocks noGrp="1"/>
+          </p:cNvGraphicFramePr>
+          <p:nvPr/>
+        </p:nvGraphicFramePr>
+        <p:xfrm>
+          <a:off x="685800" y="1417320"/>
+          <a:ext cx="10817352" cy="1920240"/>
+        </p:xfrm>
+        <a:graphic>
+          <a:graphicData uri="http://schemas.openxmlformats.org/drawingml/2006/table">
+            <a:tbl>
+              <a:tblPr firstRow="1" bandRow="1">
+                <a:tableStyleId>{5C22544A-7EE6-4342-B048-85BDC9FD1C3A}</a:tableStyleId>
+              </a:tblPr>
+              <a:tblGrid>
+                <a:gridCol w="3605784"/>
+                <a:gridCol w="3605784"/>
+                <a:gridCol w="3605784"/>
+              </a:tblGrid>
+              <a:tr h="384048">
+                <a:tc>
+                  <a:txBody>
+                    <a:bodyPr/>
+                    <a:lstStyle/>
+                    <a:p>
+                      <a:r>
+                        <a:rPr sz="1100" b="1">
+                          <a:solidFill>
+                            <a:srgbClr val="FFFFFF"/>
+                          </a:solidFill>
+                          <a:latin typeface="Arial"/>
+                        </a:rPr>
+                        <a:t>Wahlrecht</a:t>
+                      </a:r>
+                    </a:p>
+                  </a:txBody>
+                  <a:tcPr>
+                    <a:solidFill>
+                      <a:srgbClr val="1F2C56"/>
+                    </a:solidFill>
+                  </a:tcPr>
+                </a:tc>
+                <a:tc>
+                  <a:txBody>
+                    <a:bodyPr/>
+                    <a:lstStyle/>
+                    <a:p>
+                      <a:r>
+                        <a:rPr sz="1100" b="1">
+                          <a:solidFill>
+                            <a:srgbClr val="FFFFFF"/>
+                          </a:solidFill>
+                          <a:latin typeface="Arial"/>
+                        </a:rPr>
+                        <a:t>Wirkung defensiv</a:t>
+                      </a:r>
+                    </a:p>
+                  </a:txBody>
+                  <a:tcPr>
+                    <a:solidFill>
+                      <a:srgbClr val="1F2C56"/>
+                    </a:solidFill>
+                  </a:tcPr>
+                </a:tc>
+                <a:tc>
+                  <a:txBody>
+                    <a:bodyPr/>
+                    <a:lstStyle/>
+                    <a:p>
+                      <a:r>
+                        <a:rPr sz="1100" b="1">
+                          <a:solidFill>
+                            <a:srgbClr val="FFFFFF"/>
+                          </a:solidFill>
+                          <a:latin typeface="Arial"/>
+                        </a:rPr>
+                        <a:t>Wirkung aggressiv</a:t>
+                      </a:r>
+                    </a:p>
+                  </a:txBody>
+                  <a:tcPr>
+                    <a:solidFill>
+                      <a:srgbClr val="1F2C56"/>
+                    </a:solidFill>
+                  </a:tcPr>
+                </a:tc>
+              </a:tr>
+              <a:tr h="384048">
+                <a:tc>
+                  <a:txBody>
+                    <a:bodyPr/>
+                    <a:lstStyle/>
+                    <a:p>
+                      <a:r>
+                        <a:rPr sz="1050">
+                          <a:solidFill>
+                            <a:srgbClr val="3D5466"/>
+                          </a:solidFill>
+                          <a:latin typeface="Arial"/>
+                        </a:rPr>
+                        <a:t>Herstellungskosten (§ 255 HGB)</a:t>
+                      </a:r>
+                    </a:p>
+                  </a:txBody>
+                  <a:tcPr/>
+                </a:tc>
+                <a:tc>
+                  <a:txBody>
+                    <a:bodyPr/>
+                    <a:lstStyle/>
+                    <a:p>
+                      <a:r>
+                        <a:rPr sz="1050">
+                          <a:solidFill>
+                            <a:srgbClr val="3D5466"/>
+                          </a:solidFill>
+                          <a:latin typeface="Arial"/>
+                        </a:rPr>
+                        <a:t>Niedrige Vorräte, niedrige Gewinne</a:t>
+                      </a:r>
+                    </a:p>
+                  </a:txBody>
+                  <a:tcPr/>
+                </a:tc>
+                <a:tc>
+                  <a:txBody>
+                    <a:bodyPr/>
+                    <a:lstStyle/>
+                    <a:p>
+                      <a:r>
+                        <a:rPr sz="1050">
+                          <a:solidFill>
+                            <a:srgbClr val="3D5466"/>
+                          </a:solidFill>
+                          <a:latin typeface="Arial"/>
+                        </a:rPr>
+                        <a:t>Hohe Vorräte, hohe Gewinne</a:t>
+                      </a:r>
+                    </a:p>
+                  </a:txBody>
+                  <a:tcPr/>
+                </a:tc>
+              </a:tr>
+              <a:tr h="384048">
+                <a:tc>
+                  <a:txBody>
+                    <a:bodyPr/>
+                    <a:lstStyle/>
+                    <a:p>
+                      <a:r>
+                        <a:rPr sz="1050">
+                          <a:solidFill>
+                            <a:srgbClr val="3D5466"/>
+                          </a:solidFill>
+                          <a:latin typeface="Arial"/>
+                        </a:rPr>
+                        <a:t>GWG-Sofortabschreibung (§ 6 Abs. 2 EStG)</a:t>
+                      </a:r>
+                    </a:p>
+                  </a:txBody>
+                  <a:tcPr/>
+                </a:tc>
+                <a:tc>
+                  <a:txBody>
+                    <a:bodyPr/>
+                    <a:lstStyle/>
+                    <a:p>
+                      <a:r>
+                        <a:rPr sz="1050">
+                          <a:solidFill>
+                            <a:srgbClr val="3D5466"/>
+                          </a:solidFill>
+                          <a:latin typeface="Arial"/>
+                        </a:rPr>
+                        <a:t>Höhere AfA, niedrigerer Gewinn</a:t>
+                      </a:r>
+                    </a:p>
+                  </a:txBody>
+                  <a:tcPr/>
+                </a:tc>
+                <a:tc>
+                  <a:txBody>
+                    <a:bodyPr/>
+                    <a:lstStyle/>
+                    <a:p>
+                      <a:r>
+                        <a:rPr sz="1050">
+                          <a:solidFill>
+                            <a:srgbClr val="3D5466"/>
+                          </a:solidFill>
+                          <a:latin typeface="Arial"/>
+                        </a:rPr>
+                        <a:t>Geringere AfA, höherer Gewinn</a:t>
+                      </a:r>
+                    </a:p>
+                  </a:txBody>
+                  <a:tcPr/>
+                </a:tc>
+              </a:tr>
+              <a:tr h="384048">
+                <a:tc>
+                  <a:txBody>
+                    <a:bodyPr/>
+                    <a:lstStyle/>
+                    <a:p>
+                      <a:r>
+                        <a:rPr sz="1050">
+                          <a:solidFill>
+                            <a:srgbClr val="3D5466"/>
+                          </a:solidFill>
+                          <a:latin typeface="Arial"/>
+                        </a:rPr>
+                        <a:t>Rückstellungen (§ 249 HGB)</a:t>
+                      </a:r>
+                    </a:p>
+                  </a:txBody>
+                  <a:tcPr/>
+                </a:tc>
+                <a:tc>
+                  <a:txBody>
+                    <a:bodyPr/>
+                    <a:lstStyle/>
+                    <a:p>
+                      <a:r>
+                        <a:rPr sz="1050">
+                          <a:solidFill>
+                            <a:srgbClr val="3D5466"/>
+                          </a:solidFill>
+                          <a:latin typeface="Arial"/>
+                        </a:rPr>
+                        <a:t>Höhere Rückstellungen, niedrigerer Gewinn</a:t>
+                      </a:r>
+                    </a:p>
+                  </a:txBody>
+                  <a:tcPr/>
+                </a:tc>
+                <a:tc>
+                  <a:txBody>
+                    <a:bodyPr/>
+                    <a:lstStyle/>
+                    <a:p>
+                      <a:r>
+                        <a:rPr sz="1050">
+                          <a:solidFill>
+                            <a:srgbClr val="3D5466"/>
+                          </a:solidFill>
+                          <a:latin typeface="Arial"/>
+                        </a:rPr>
+                        <a:t>Niedrigere Rückstellungen, höherer Gewinn</a:t>
+                      </a:r>
+                    </a:p>
+                  </a:txBody>
+                  <a:tcPr/>
+                </a:tc>
+              </a:tr>
+              <a:tr h="384048">
+                <a:tc>
+                  <a:txBody>
+                    <a:bodyPr/>
+                    <a:lstStyle/>
+                    <a:p>
+                      <a:r>
+                        <a:rPr sz="1050">
+                          <a:solidFill>
+                            <a:srgbClr val="3D5466"/>
+                          </a:solidFill>
+                          <a:latin typeface="Arial"/>
+                        </a:rPr>
+                        <a:t>Forderungsbewertung (§ 253 HGB)</a:t>
+                      </a:r>
+                    </a:p>
+                  </a:txBody>
+                  <a:tcPr/>
+                </a:tc>
+                <a:tc>
+                  <a:txBody>
+                    <a:bodyPr/>
+                    <a:lstStyle/>
+                    <a:p>
+                      <a:r>
+                        <a:rPr sz="1050">
+                          <a:solidFill>
+                            <a:srgbClr val="3D5466"/>
+                          </a:solidFill>
+                          <a:latin typeface="Arial"/>
+                        </a:rPr>
+                        <a:t>Strenge Abwertung bei Zweifeln</a:t>
+                      </a:r>
+                    </a:p>
+                  </a:txBody>
+                  <a:tcPr/>
+                </a:tc>
+                <a:tc>
+                  <a:txBody>
+                    <a:bodyPr/>
+                    <a:lstStyle/>
+                    <a:p>
+                      <a:r>
+                        <a:rPr sz="1050">
+                          <a:solidFill>
+                            <a:srgbClr val="3D5466"/>
+                          </a:solidFill>
+                          <a:latin typeface="Arial"/>
+                        </a:rPr>
+                        <a:t>Beibehaltung zweifelhafter Forderungen</a:t>
+                      </a:r>
+                    </a:p>
+                  </a:txBody>
+                  <a:tcPr/>
+                </a:tc>
+              </a:tr>
+            </a:tbl>
+          </a:graphicData>
+        </a:graphic>
+      </p:graphicFrame>
       <p:sp>
         <p:nvSpPr>
           <p:cNvPr id="8" name="Rectangle 7"/>
@@ -7950,7 +10033,7 @@
                 </a:solidFill>
                 <a:latin typeface="JetBrains Mono"/>
               </a:rPr>
-              <a:t>Schaubild</a:t>
+              <a:t>Übersicht</a:t>
             </a:r>
           </a:p>
         </p:txBody>

</xml_diff>

<commit_message>
Rebrand FKB Campus: Content, Zertifikat, Impressum, alle PDF/PPTX-Artefakte; Beobachtungsbogen-Leak gefixt (public→protected)
Co-Authored-By: Claude Fable 5 <noreply@anthropic.com>
</commit_message>
<xml_diff>
--- a/protected-downloads/praesentation/M01.pptx
+++ b/protected-downloads/praesentation/M01.pptx
@@ -4252,7 +4252,7 @@
                 </a:solidFill>
                 <a:latin typeface="JetBrains Mono"/>
               </a:rPr>
-              <a:t>Benedikt Zoller Coaching  ·  FKB Campus  ·  2026</a:t>
+              <a:t>FKB Campus  ·  2026</a:t>
             </a:r>
           </a:p>
         </p:txBody>
@@ -4821,7 +4821,7 @@
                 </a:solidFill>
                 <a:latin typeface="JetBrains Mono"/>
               </a:rPr>
-              <a:t>Benedikt Zoller Coaching  ·  FKB Campus  ·  M01</a:t>
+              <a:t>FKB Campus  ·  M01</a:t>
             </a:r>
           </a:p>
         </p:txBody>
@@ -5140,7 +5140,7 @@
                 </a:solidFill>
                 <a:latin typeface="JetBrains Mono"/>
               </a:rPr>
-              <a:t>Benedikt Zoller Coaching  ·  FKB Campus  ·  M01</a:t>
+              <a:t>FKB Campus  ·  M01</a:t>
             </a:r>
           </a:p>
         </p:txBody>
@@ -5494,7 +5494,7 @@
                 </a:solidFill>
                 <a:latin typeface="JetBrains Mono"/>
               </a:rPr>
-              <a:t>Benedikt Zoller Coaching  ·  FKB Campus  ·  M01</a:t>
+              <a:t>FKB Campus  ·  M01</a:t>
             </a:r>
           </a:p>
         </p:txBody>
@@ -5985,7 +5985,7 @@
                 </a:solidFill>
                 <a:latin typeface="JetBrains Mono"/>
               </a:rPr>
-              <a:t>Benedikt Zoller Coaching  ·  FKB Campus  ·  M01</a:t>
+              <a:t>FKB Campus  ·  M01</a:t>
             </a:r>
           </a:p>
         </p:txBody>
@@ -6351,7 +6351,7 @@
                 </a:solidFill>
                 <a:latin typeface="JetBrains Mono"/>
               </a:rPr>
-              <a:t>Benedikt Zoller Coaching  ·  FKB Campus  ·  M01</a:t>
+              <a:t>FKB Campus  ·  M01</a:t>
             </a:r>
           </a:p>
         </p:txBody>
@@ -6745,7 +6745,7 @@
                 </a:solidFill>
                 <a:latin typeface="JetBrains Mono"/>
               </a:rPr>
-              <a:t>Benedikt Zoller Coaching  ·  FKB Campus  ·  M01</a:t>
+              <a:t>FKB Campus  ·  M01</a:t>
             </a:r>
           </a:p>
         </p:txBody>
@@ -7359,7 +7359,7 @@
                 </a:solidFill>
                 <a:latin typeface="JetBrains Mono"/>
               </a:rPr>
-              <a:t>Benedikt Zoller Coaching  ·  FKB Campus  ·  M01</a:t>
+              <a:t>FKB Campus  ·  M01</a:t>
             </a:r>
           </a:p>
         </p:txBody>
@@ -7929,7 +7929,7 @@
                 </a:solidFill>
                 <a:latin typeface="JetBrains Mono"/>
               </a:rPr>
-              <a:t>Benedikt Zoller Coaching  ·  FKB Campus  ·  M01</a:t>
+              <a:t>FKB Campus  ·  M01</a:t>
             </a:r>
           </a:p>
         </p:txBody>
@@ -8248,7 +8248,7 @@
                 </a:solidFill>
                 <a:latin typeface="JetBrains Mono"/>
               </a:rPr>
-              <a:t>Benedikt Zoller Coaching  ·  FKB Campus  ·  M01</a:t>
+              <a:t>FKB Campus  ·  M01</a:t>
             </a:r>
           </a:p>
         </p:txBody>
@@ -8602,7 +8602,7 @@
                 </a:solidFill>
                 <a:latin typeface="JetBrains Mono"/>
               </a:rPr>
-              <a:t>Benedikt Zoller Coaching  ·  FKB Campus  ·  M01</a:t>
+              <a:t>FKB Campus  ·  M01</a:t>
             </a:r>
           </a:p>
         </p:txBody>
@@ -9349,7 +9349,7 @@
                 </a:solidFill>
                 <a:latin typeface="JetBrains Mono"/>
               </a:rPr>
-              <a:t>Benedikt Zoller Coaching  ·  FKB Campus  ·  M01</a:t>
+              <a:t>FKB Campus  ·  M01</a:t>
             </a:r>
           </a:p>
         </p:txBody>
@@ -9998,7 +9998,7 @@
                 </a:solidFill>
                 <a:latin typeface="JetBrains Mono"/>
               </a:rPr>
-              <a:t>Benedikt Zoller Coaching  ·  FKB Campus  ·  M01</a:t>
+              <a:t>FKB Campus  ·  M01</a:t>
             </a:r>
           </a:p>
         </p:txBody>

</xml_diff>

<commit_message>
Sim-Review M01: 8 VPs umgesetzt + Artefakte neu + sim_review true
Co-Authored-By: Claude Fable 5 <noreply@anthropic.com>
</commit_message>
<xml_diff>
--- a/protected-downloads/praesentation/M01.pptx
+++ b/protected-downloads/praesentation/M01.pptx
@@ -6667,7 +6667,7 @@
                 </a:solidFill>
                 <a:latin typeface="Arial"/>
               </a:rPr>
-              <a:t>▸  Häufige Bilanzierungswahlrechte nach HGB identifizieren und deren Auswirkung auf Kennzahlen benennen</a:t>
+              <a:t>▸  Häufige Warnsignale in Bilanzen (stille Lasten, Forderungsüberbestand, rückläufige EK-Quote) identifizieren und erste Nachfragen für das Kundengespräch ableiten</a:t>
             </a:r>
           </a:p>
         </p:txBody>
@@ -7041,7 +7041,7 @@
                 </a:solidFill>
                 <a:latin typeface="Consolas"/>
               </a:rPr>
-              <a:t>05–15       </a:t>
+              <a:t>05–13       </a:t>
             </a:r>
             <a:r>
               <a:rPr sz="1500" b="1">
@@ -7059,7 +7059,7 @@
                 </a:solidFill>
                 <a:latin typeface="Arial"/>
               </a:rPr>
-              <a:t>  ·  Einzelarbeit → Plenumsdiskussion</a:t>
+              <a:t>  ·  Einzelarbeit → kurze Plenumsdiskussion</a:t>
             </a:r>
           </a:p>
           <a:p>
@@ -7078,7 +7078,7 @@
                 </a:solidFill>
                 <a:latin typeface="Consolas"/>
               </a:rPr>
-              <a:t>15–35       </a:t>
+              <a:t>13–33       </a:t>
             </a:r>
             <a:r>
               <a:rPr sz="1500" b="1">
@@ -7115,7 +7115,7 @@
                 </a:solidFill>
                 <a:latin typeface="Consolas"/>
               </a:rPr>
-              <a:t>35–45       </a:t>
+              <a:t>33–41       </a:t>
             </a:r>
             <a:r>
               <a:rPr sz="1500" b="1">
@@ -7152,7 +7152,7 @@
                 </a:solidFill>
                 <a:latin typeface="Consolas"/>
               </a:rPr>
-              <a:t>45–65       </a:t>
+              <a:t>41–56       </a:t>
             </a:r>
             <a:r>
               <a:rPr sz="1500" b="1">
@@ -7161,7 +7161,7 @@
                 </a:solidFill>
                 <a:latin typeface="Arial"/>
               </a:rPr>
-              <a:t>  Input 2</a:t>
+              <a:t>  Input 2a</a:t>
             </a:r>
             <a:r>
               <a:rPr sz="1200">
@@ -7189,7 +7189,7 @@
                 </a:solidFill>
                 <a:latin typeface="Consolas"/>
               </a:rPr>
-              <a:t>65–80       </a:t>
+              <a:t>56–66       </a:t>
             </a:r>
             <a:r>
               <a:rPr sz="1500" b="1">
@@ -7198,7 +7198,7 @@
                 </a:solidFill>
                 <a:latin typeface="Arial"/>
               </a:rPr>
-              <a:t>  Übung 2</a:t>
+              <a:t>  Input 2b</a:t>
             </a:r>
             <a:r>
               <a:rPr sz="1200">
@@ -7207,7 +7207,7 @@
                 </a:solidFill>
                 <a:latin typeface="Arial"/>
               </a:rPr>
-              <a:t>  ·  Einzelarbeit → Vergleich Partnerarbeit</a:t>
+              <a:t>  ·  Muster-Whiteboard-Rechnung</a:t>
             </a:r>
           </a:p>
           <a:p>
@@ -7226,7 +7226,7 @@
                 </a:solidFill>
                 <a:latin typeface="Consolas"/>
               </a:rPr>
-              <a:t>80–90       </a:t>
+              <a:t>66–81       </a:t>
             </a:r>
             <a:r>
               <a:rPr sz="1500" b="1">
@@ -7235,7 +7235,7 @@
                 </a:solidFill>
                 <a:latin typeface="Arial"/>
               </a:rPr>
-              <a:t>  Auswertung</a:t>
+              <a:t>  Übung 2</a:t>
             </a:r>
             <a:r>
               <a:rPr sz="1200">
@@ -7244,7 +7244,7 @@
                 </a:solidFill>
                 <a:latin typeface="Arial"/>
               </a:rPr>
-              <a:t>  ·  Plenumsgespräch</a:t>
+              <a:t>  ·  Einzelarbeit → Vergleich Partnerarbeit</a:t>
             </a:r>
           </a:p>
           <a:p>
@@ -7263,7 +7263,44 @@
                 </a:solidFill>
                 <a:latin typeface="Consolas"/>
               </a:rPr>
-              <a:t>90–95       </a:t>
+              <a:t>81–96       </a:t>
+            </a:r>
+            <a:r>
+              <a:rPr sz="1500" b="1">
+                <a:solidFill>
+                  <a:srgbClr val="3D5466"/>
+                </a:solidFill>
+                <a:latin typeface="Arial"/>
+              </a:rPr>
+              <a:t>  Auswertung</a:t>
+            </a:r>
+            <a:r>
+              <a:rPr sz="1200">
+                <a:solidFill>
+                  <a:srgbClr val="78808C"/>
+                </a:solidFill>
+                <a:latin typeface="Arial"/>
+              </a:rPr>
+              <a:t>  ·  Plenumsgespräch</a:t>
+            </a:r>
+          </a:p>
+          <a:p>
+            <a:pPr>
+              <a:spcBef>
+                <a:spcPts val="700"/>
+              </a:spcBef>
+              <a:spcAft>
+                <a:spcPts val="100"/>
+              </a:spcAft>
+            </a:pPr>
+            <a:r>
+              <a:rPr sz="1200">
+                <a:solidFill>
+                  <a:srgbClr val="78808C"/>
+                </a:solidFill>
+                <a:latin typeface="Consolas"/>
+              </a:rPr>
+              <a:t>96–100      </a:t>
             </a:r>
             <a:r>
               <a:rPr sz="1500" b="1">

</xml_diff>

<commit_message>
Welle 1: alle 36 Trainer-Decks neu (Arial-Fonts, Layout-Haertung nach PPTX-Audit)
Co-Authored-By: Claude Fable 5 <noreply@anthropic.com>
</commit_message>
<xml_diff>
--- a/protected-downloads/praesentation/M01.pptx
+++ b/protected-downloads/praesentation/M01.pptx
@@ -3849,7 +3849,7 @@
                 <a:solidFill>
                   <a:srgbClr val="C8D2E6"/>
                 </a:solidFill>
-                <a:latin typeface="JetBrains Mono"/>
+                <a:latin typeface="Consolas"/>
               </a:rPr>
               <a:t>FKB CAMPUS  ·  FIRMENKUNDENAKADEMIE  ·  M01</a:t>
             </a:r>
@@ -3884,7 +3884,7 @@
                 <a:solidFill>
                   <a:srgbClr val="FFFFFF"/>
                 </a:solidFill>
-                <a:latin typeface="Source Serif 4"/>
+                <a:latin typeface="Arial"/>
               </a:rPr>
               <a:t>Bilanzlesen für Praktiker</a:t>
             </a:r>
@@ -3919,7 +3919,7 @@
                 <a:solidFill>
                   <a:srgbClr val="BECDE6"/>
                 </a:solidFill>
-                <a:latin typeface="Source Serif 4"/>
+                <a:latin typeface="Arial"/>
               </a:rPr>
               <a:t>Jahresabschlüsse sicher lesen, verstehen und interpretieren</a:t>
             </a:r>
@@ -3997,7 +3997,7 @@
                 <a:solidFill>
                   <a:srgbClr val="A0B4D2"/>
                 </a:solidFill>
-                <a:latin typeface="JetBrains Mono"/>
+                <a:latin typeface="Consolas"/>
               </a:rPr>
               <a:t>KOMPETENZFELD</a:t>
             </a:r>
@@ -4067,7 +4067,7 @@
                 <a:solidFill>
                   <a:srgbClr val="A0B4D2"/>
                 </a:solidFill>
-                <a:latin typeface="JetBrains Mono"/>
+                <a:latin typeface="Consolas"/>
               </a:rPr>
               <a:t>KOMPETENZSTUFE</a:t>
             </a:r>
@@ -4137,7 +4137,7 @@
                 <a:solidFill>
                   <a:srgbClr val="A0B4D2"/>
                 </a:solidFill>
-                <a:latin typeface="JetBrains Mono"/>
+                <a:latin typeface="Consolas"/>
               </a:rPr>
               <a:t>VERSION</a:t>
             </a:r>
@@ -4250,7 +4250,7 @@
                 <a:solidFill>
                   <a:srgbClr val="96A5BE"/>
                 </a:solidFill>
-                <a:latin typeface="JetBrains Mono"/>
+                <a:latin typeface="Consolas"/>
               </a:rPr>
               <a:t>FKB Campus  ·  2026</a:t>
             </a:r>
@@ -4285,7 +4285,7 @@
                 <a:solidFill>
                   <a:srgbClr val="96A5BE"/>
                 </a:solidFill>
-                <a:latin typeface="JetBrains Mono"/>
+                <a:latin typeface="Consolas"/>
               </a:rPr>
               <a:t>Trainer-Präsentation</a:t>
             </a:r>
@@ -4424,7 +4424,7 @@
                 <a:solidFill>
                   <a:srgbClr val="78808C"/>
                 </a:solidFill>
-                <a:latin typeface="JetBrains Mono"/>
+                <a:latin typeface="Consolas"/>
               </a:rPr>
               <a:t>M01  ·  ARBEITSBLATT</a:t>
             </a:r>
@@ -4545,7 +4545,7 @@
                 <a:solidFill>
                   <a:srgbClr val="1F2C56"/>
                 </a:solidFill>
-                <a:latin typeface="Source Serif 4"/>
+                <a:latin typeface="Arial"/>
               </a:rPr>
               <a:t>Praxisfall: Musterbilanz „Bauer GmbH"</a:t>
             </a:r>
@@ -4574,7 +4574,7 @@
           </a:bodyPr>
           <a:lstStyle/>
           <a:p>
-            <a:pPr>
+            <a:pPr marL="190500" indent="-190500">
               <a:spcBef>
                 <a:spcPts val="400"/>
               </a:spcBef>
@@ -4593,7 +4593,7 @@
             </a:r>
           </a:p>
           <a:p>
-            <a:pPr>
+            <a:pPr marL="190500" indent="-190500">
               <a:spcBef>
                 <a:spcPts val="400"/>
               </a:spcBef>
@@ -4612,7 +4612,7 @@
             </a:r>
           </a:p>
           <a:p>
-            <a:pPr>
+            <a:pPr marL="190500" indent="-190500">
               <a:spcBef>
                 <a:spcPts val="400"/>
               </a:spcBef>
@@ -4631,7 +4631,7 @@
             </a:r>
           </a:p>
           <a:p>
-            <a:pPr>
+            <a:pPr marL="190500" indent="-190500">
               <a:spcBef>
                 <a:spcPts val="400"/>
               </a:spcBef>
@@ -4650,7 +4650,7 @@
             </a:r>
           </a:p>
           <a:p>
-            <a:pPr>
+            <a:pPr marL="190500" indent="-190500">
               <a:spcBef>
                 <a:spcPts val="400"/>
               </a:spcBef>
@@ -4819,7 +4819,7 @@
                 <a:solidFill>
                   <a:srgbClr val="A0B4D2"/>
                 </a:solidFill>
-                <a:latin typeface="JetBrains Mono"/>
+                <a:latin typeface="Consolas"/>
               </a:rPr>
               <a:t>FKB Campus  ·  M01</a:t>
             </a:r>
@@ -4958,7 +4958,7 @@
                 <a:solidFill>
                   <a:srgbClr val="78808C"/>
                 </a:solidFill>
-                <a:latin typeface="JetBrains Mono"/>
+                <a:latin typeface="Consolas"/>
               </a:rPr>
               <a:t>M01  ·  SCHAUBILD</a:t>
             </a:r>
@@ -4993,7 +4993,7 @@
                 <a:solidFill>
                   <a:srgbClr val="1F2C56"/>
                 </a:solidFill>
-                <a:latin typeface="Source Serif 4"/>
+                <a:latin typeface="Arial"/>
               </a:rPr>
               <a:t>Analyseprozess in vier Schritten</a:t>
             </a:r>
@@ -5138,7 +5138,7 @@
                 <a:solidFill>
                   <a:srgbClr val="A0B4D2"/>
                 </a:solidFill>
-                <a:latin typeface="JetBrains Mono"/>
+                <a:latin typeface="Consolas"/>
               </a:rPr>
               <a:t>FKB Campus  ·  M01</a:t>
             </a:r>
@@ -5173,7 +5173,7 @@
                 <a:solidFill>
                   <a:srgbClr val="A0B4D2"/>
                 </a:solidFill>
-                <a:latin typeface="JetBrains Mono"/>
+                <a:latin typeface="Consolas"/>
               </a:rPr>
               <a:t>Schaubild</a:t>
             </a:r>
@@ -5312,7 +5312,7 @@
                 <a:solidFill>
                   <a:srgbClr val="78808C"/>
                 </a:solidFill>
-                <a:latin typeface="JetBrains Mono"/>
+                <a:latin typeface="Consolas"/>
               </a:rPr>
               <a:t>M01  ·  SCHAUBILD</a:t>
             </a:r>
@@ -5347,7 +5347,7 @@
                 <a:solidFill>
                   <a:srgbClr val="1F2C56"/>
                 </a:solidFill>
-                <a:latin typeface="Source Serif 4"/>
+                <a:latin typeface="Arial"/>
               </a:rPr>
               <a:t>Handlungsempfehlung</a:t>
             </a:r>
@@ -5492,7 +5492,7 @@
                 <a:solidFill>
                   <a:srgbClr val="A0B4D2"/>
                 </a:solidFill>
-                <a:latin typeface="JetBrains Mono"/>
+                <a:latin typeface="Consolas"/>
               </a:rPr>
               <a:t>FKB Campus  ·  M01</a:t>
             </a:r>
@@ -5527,7 +5527,7 @@
                 <a:solidFill>
                   <a:srgbClr val="A0B4D2"/>
                 </a:solidFill>
-                <a:latin typeface="JetBrains Mono"/>
+                <a:latin typeface="Consolas"/>
               </a:rPr>
               <a:t>Schaubild</a:t>
             </a:r>
@@ -5666,7 +5666,7 @@
                 <a:solidFill>
                   <a:srgbClr val="78808C"/>
                 </a:solidFill>
-                <a:latin typeface="JetBrains Mono"/>
+                <a:latin typeface="Consolas"/>
               </a:rPr>
               <a:t>M01  ·  INHALT</a:t>
             </a:r>
@@ -5787,7 +5787,7 @@
                 <a:solidFill>
                   <a:srgbClr val="1F2C56"/>
                 </a:solidFill>
-                <a:latin typeface="Source Serif 4"/>
+                <a:latin typeface="Arial"/>
               </a:rPr>
               <a:t>Reflexionsfragen</a:t>
             </a:r>
@@ -5803,7 +5803,7 @@
         <p:spPr>
           <a:xfrm>
             <a:off x="685800" y="1417320"/>
-            <a:ext cx="10817352" cy="5029200"/>
+            <a:ext cx="10817352" cy="4892040"/>
           </a:xfrm>
           <a:prstGeom prst="rect">
             <a:avLst/>
@@ -5811,12 +5811,12 @@
           <a:noFill/>
         </p:spPr>
         <p:txBody>
-          <a:bodyPr wrap="square">
+          <a:bodyPr wrap="square" anchor="ctr">
             <a:spAutoFit/>
           </a:bodyPr>
           <a:lstStyle/>
           <a:p>
-            <a:pPr>
+            <a:pPr marL="190500" indent="-190500">
               <a:spcBef>
                 <a:spcPts val="400"/>
               </a:spcBef>
@@ -5835,7 +5835,7 @@
             </a:r>
           </a:p>
           <a:p>
-            <a:pPr>
+            <a:pPr marL="190500" indent="-190500">
               <a:spcBef>
                 <a:spcPts val="400"/>
               </a:spcBef>
@@ -5854,7 +5854,7 @@
             </a:r>
           </a:p>
           <a:p>
-            <a:pPr>
+            <a:pPr marL="190500" indent="-190500">
               <a:spcBef>
                 <a:spcPts val="400"/>
               </a:spcBef>
@@ -5873,7 +5873,7 @@
             </a:r>
           </a:p>
           <a:p>
-            <a:pPr>
+            <a:pPr marL="190500" indent="-190500">
               <a:spcBef>
                 <a:spcPts val="400"/>
               </a:spcBef>
@@ -5892,7 +5892,7 @@
             </a:r>
           </a:p>
           <a:p>
-            <a:pPr>
+            <a:pPr marL="190500" indent="-190500">
               <a:spcBef>
                 <a:spcPts val="400"/>
               </a:spcBef>
@@ -5983,7 +5983,7 @@
                 <a:solidFill>
                   <a:srgbClr val="A0B4D2"/>
                 </a:solidFill>
-                <a:latin typeface="JetBrains Mono"/>
+                <a:latin typeface="Consolas"/>
               </a:rPr>
               <a:t>FKB Campus  ·  M01</a:t>
             </a:r>
@@ -6122,7 +6122,7 @@
                 <a:solidFill>
                   <a:srgbClr val="78808C"/>
                 </a:solidFill>
-                <a:latin typeface="JetBrains Mono"/>
+                <a:latin typeface="Consolas"/>
               </a:rPr>
               <a:t>ÜBERBLICK  ·  M01</a:t>
             </a:r>
@@ -6200,7 +6200,7 @@
                 <a:solidFill>
                   <a:srgbClr val="1F2C56"/>
                 </a:solidFill>
-                <a:latin typeface="Source Serif 4"/>
+                <a:latin typeface="Arial"/>
               </a:rPr>
               <a:t>Worum geht es heute</a:t>
             </a:r>
@@ -6349,7 +6349,7 @@
                 <a:solidFill>
                   <a:srgbClr val="A0B4D2"/>
                 </a:solidFill>
-                <a:latin typeface="JetBrains Mono"/>
+                <a:latin typeface="Consolas"/>
               </a:rPr>
               <a:t>FKB Campus  ·  M01</a:t>
             </a:r>
@@ -6488,7 +6488,7 @@
                 <a:solidFill>
                   <a:srgbClr val="78808C"/>
                 </a:solidFill>
-                <a:latin typeface="JetBrains Mono"/>
+                <a:latin typeface="Consolas"/>
               </a:rPr>
               <a:t>LERNZIELE  ·  M01</a:t>
             </a:r>
@@ -6566,7 +6566,7 @@
                 <a:solidFill>
                   <a:srgbClr val="1F2C56"/>
                 </a:solidFill>
-                <a:latin typeface="Source Serif 4"/>
+                <a:latin typeface="Arial"/>
               </a:rPr>
               <a:t>Was Sie heute mitnehmen</a:t>
             </a:r>
@@ -6743,7 +6743,7 @@
                 <a:solidFill>
                   <a:srgbClr val="A0B4D2"/>
                 </a:solidFill>
-                <a:latin typeface="JetBrains Mono"/>
+                <a:latin typeface="Consolas"/>
               </a:rPr>
               <a:t>FKB Campus  ·  M01</a:t>
             </a:r>
@@ -6882,7 +6882,7 @@
                 <a:solidFill>
                   <a:srgbClr val="78808C"/>
                 </a:solidFill>
-                <a:latin typeface="JetBrains Mono"/>
+                <a:latin typeface="Consolas"/>
               </a:rPr>
               <a:t>AGENDA  ·  M01</a:t>
             </a:r>
@@ -6960,7 +6960,7 @@
                 <a:solidFill>
                   <a:srgbClr val="1F2C56"/>
                 </a:solidFill>
-                <a:latin typeface="Source Serif 4"/>
+                <a:latin typeface="Arial"/>
               </a:rPr>
               <a:t>So läuft das Modul</a:t>
             </a:r>
@@ -7394,7 +7394,7 @@
                 <a:solidFill>
                   <a:srgbClr val="A0B4D2"/>
                 </a:solidFill>
-                <a:latin typeface="JetBrains Mono"/>
+                <a:latin typeface="Consolas"/>
               </a:rPr>
               <a:t>FKB Campus  ·  M01</a:t>
             </a:r>
@@ -7533,7 +7533,7 @@
                 <a:solidFill>
                   <a:srgbClr val="78808C"/>
                 </a:solidFill>
-                <a:latin typeface="JetBrains Mono"/>
+                <a:latin typeface="Consolas"/>
               </a:rPr>
               <a:t>M01  ·  INHALT</a:t>
             </a:r>
@@ -7654,7 +7654,7 @@
                 <a:solidFill>
                   <a:srgbClr val="1F2C56"/>
                 </a:solidFill>
-                <a:latin typeface="Source Serif 4"/>
+                <a:latin typeface="Arial"/>
               </a:rPr>
               <a:t>Theorie-Input: Aufbau des HGB-Jahresabschlusses</a:t>
             </a:r>
@@ -7670,7 +7670,7 @@
         <p:spPr>
           <a:xfrm>
             <a:off x="685800" y="1417320"/>
-            <a:ext cx="10817352" cy="5029200"/>
+            <a:ext cx="10817352" cy="4892040"/>
           </a:xfrm>
           <a:prstGeom prst="rect">
             <a:avLst/>
@@ -7696,13 +7696,13 @@
                 <a:solidFill>
                   <a:srgbClr val="78808C"/>
                 </a:solidFill>
-                <a:latin typeface="JetBrains Mono"/>
+                <a:latin typeface="Consolas"/>
               </a:rPr>
               <a:t>WAS IST EIN JAHRESABSCHLUSS?</a:t>
             </a:r>
           </a:p>
           <a:p>
-            <a:pPr>
+            <a:pPr marL="190500" indent="-190500">
               <a:spcBef>
                 <a:spcPts val="400"/>
               </a:spcBef>
@@ -7721,7 +7721,7 @@
             </a:r>
           </a:p>
           <a:p>
-            <a:pPr>
+            <a:pPr marL="190500" indent="-190500">
               <a:spcBef>
                 <a:spcPts val="400"/>
               </a:spcBef>
@@ -7740,7 +7740,7 @@
             </a:r>
           </a:p>
           <a:p>
-            <a:pPr>
+            <a:pPr marL="190500" indent="-190500">
               <a:spcBef>
                 <a:spcPts val="400"/>
               </a:spcBef>
@@ -7759,7 +7759,7 @@
             </a:r>
           </a:p>
           <a:p>
-            <a:pPr>
+            <a:pPr marL="190500" indent="-190500">
               <a:spcBef>
                 <a:spcPts val="400"/>
               </a:spcBef>
@@ -7778,7 +7778,7 @@
             </a:r>
           </a:p>
           <a:p>
-            <a:pPr>
+            <a:pPr marL="190500" indent="-190500">
               <a:spcBef>
                 <a:spcPts val="400"/>
               </a:spcBef>
@@ -7810,70 +7810,13 @@
                 <a:solidFill>
                   <a:srgbClr val="78808C"/>
                 </a:solidFill>
-                <a:latin typeface="JetBrains Mono"/>
-              </a:rPr>
-              <a:t>OFFENLEGUNGSPFLICHTEN UND GRÖSSENKLASSEN (§ 267 HGB)</a:t>
-            </a:r>
-          </a:p>
-          <a:p>
-            <a:pPr>
-              <a:spcBef>
-                <a:spcPts val="1000"/>
-              </a:spcBef>
-              <a:spcAft>
-                <a:spcPts val="200"/>
-              </a:spcAft>
-            </a:pPr>
-            <a:r>
-              <a:rPr sz="800" b="1">
-                <a:solidFill>
-                  <a:srgbClr val="78808C"/>
-                </a:solidFill>
-                <a:latin typeface="JetBrains Mono"/>
-              </a:rPr>
-              <a:t>BILANZSTRUKTUR: MITTELHERKUNFT UND -VERWENDUNG</a:t>
-            </a:r>
-          </a:p>
-          <a:p>
-            <a:pPr>
-              <a:spcBef>
-                <a:spcPts val="1000"/>
-              </a:spcBef>
-              <a:spcAft>
-                <a:spcPts val="200"/>
-              </a:spcAft>
-            </a:pPr>
-            <a:r>
-              <a:rPr sz="800" b="1">
-                <a:solidFill>
-                  <a:srgbClr val="78808C"/>
-                </a:solidFill>
-                <a:latin typeface="JetBrains Mono"/>
-              </a:rPr>
-              <a:t>BILANZIERUNGSWAHLRECHTE UND IHRE WIRKUNG</a:t>
-            </a:r>
-          </a:p>
-          <a:p>
-            <a:pPr>
-              <a:spcBef>
-                <a:spcPts val="1000"/>
-              </a:spcBef>
-              <a:spcAft>
-                <a:spcPts val="200"/>
-              </a:spcAft>
-            </a:pPr>
-            <a:r>
-              <a:rPr sz="800" b="1">
-                <a:solidFill>
-                  <a:srgbClr val="78808C"/>
-                </a:solidFill>
-                <a:latin typeface="JetBrains Mono"/>
+                <a:latin typeface="Consolas"/>
               </a:rPr>
               <a:t>BILANZKENNZAHLEN IM ÜBERBLICK</a:t>
             </a:r>
           </a:p>
           <a:p>
-            <a:pPr>
+            <a:pPr marL="190500" indent="-190500">
               <a:spcBef>
                 <a:spcPts val="400"/>
               </a:spcBef>
@@ -7964,7 +7907,7 @@
                 <a:solidFill>
                   <a:srgbClr val="A0B4D2"/>
                 </a:solidFill>
-                <a:latin typeface="JetBrains Mono"/>
+                <a:latin typeface="Consolas"/>
               </a:rPr>
               <a:t>FKB Campus  ·  M01</a:t>
             </a:r>
@@ -8103,7 +8046,7 @@
                 <a:solidFill>
                   <a:srgbClr val="78808C"/>
                 </a:solidFill>
-                <a:latin typeface="JetBrains Mono"/>
+                <a:latin typeface="Consolas"/>
               </a:rPr>
               <a:t>M01  ·  SCHAUBILD</a:t>
             </a:r>
@@ -8138,7 +8081,7 @@
                 <a:solidFill>
                   <a:srgbClr val="1F2C56"/>
                 </a:solidFill>
-                <a:latin typeface="Source Serif 4"/>
+                <a:latin typeface="Arial"/>
               </a:rPr>
               <a:t>Bilanzstruktur T-Konto</a:t>
             </a:r>
@@ -8283,7 +8226,7 @@
                 <a:solidFill>
                   <a:srgbClr val="A0B4D2"/>
                 </a:solidFill>
-                <a:latin typeface="JetBrains Mono"/>
+                <a:latin typeface="Consolas"/>
               </a:rPr>
               <a:t>FKB Campus  ·  M01</a:t>
             </a:r>
@@ -8318,7 +8261,7 @@
                 <a:solidFill>
                   <a:srgbClr val="A0B4D2"/>
                 </a:solidFill>
-                <a:latin typeface="JetBrains Mono"/>
+                <a:latin typeface="Consolas"/>
               </a:rPr>
               <a:t>Schaubild</a:t>
             </a:r>
@@ -8457,7 +8400,7 @@
                 <a:solidFill>
                   <a:srgbClr val="78808C"/>
                 </a:solidFill>
-                <a:latin typeface="JetBrains Mono"/>
+                <a:latin typeface="Consolas"/>
               </a:rPr>
               <a:t>M01  ·  SCHAUBILD</a:t>
             </a:r>
@@ -8492,7 +8435,7 @@
                 <a:solidFill>
                   <a:srgbClr val="1F2C56"/>
                 </a:solidFill>
-                <a:latin typeface="Source Serif 4"/>
+                <a:latin typeface="Arial"/>
               </a:rPr>
               <a:t>Bilanzkennzahlen-Karte mit Bewertungsampel</a:t>
             </a:r>
@@ -8637,7 +8580,7 @@
                 <a:solidFill>
                   <a:srgbClr val="A0B4D2"/>
                 </a:solidFill>
-                <a:latin typeface="JetBrains Mono"/>
+                <a:latin typeface="Consolas"/>
               </a:rPr>
               <a:t>FKB Campus  ·  M01</a:t>
             </a:r>
@@ -8672,7 +8615,7 @@
                 <a:solidFill>
                   <a:srgbClr val="A0B4D2"/>
                 </a:solidFill>
-                <a:latin typeface="JetBrains Mono"/>
+                <a:latin typeface="Consolas"/>
               </a:rPr>
               <a:t>Schaubild</a:t>
             </a:r>
@@ -8811,7 +8754,7 @@
                 <a:solidFill>
                   <a:srgbClr val="78808C"/>
                 </a:solidFill>
-                <a:latin typeface="JetBrains Mono"/>
+                <a:latin typeface="Consolas"/>
               </a:rPr>
               <a:t>M01  ·  ÜBERSICHT</a:t>
             </a:r>
@@ -8846,7 +8789,7 @@
                 <a:solidFill>
                   <a:srgbClr val="1F2C56"/>
                 </a:solidFill>
-                <a:latin typeface="Source Serif 4"/>
+                <a:latin typeface="Arial"/>
               </a:rPr>
               <a:t>Theorie-Input: Aufbau des HGB-Jahresabschlusses</a:t>
             </a:r>
@@ -9064,7 +9007,7 @@
                           </a:solidFill>
                           <a:latin typeface="Arial"/>
                         </a:rPr>
-                        <a:t>≤ 6 Mio. EUR</a:t>
+                        <a:t>≤ 7,5 Mio. EUR</a:t>
                       </a:r>
                     </a:p>
                   </a:txBody>
@@ -9082,7 +9025,7 @@
                           </a:solidFill>
                           <a:latin typeface="Arial"/>
                         </a:rPr>
-                        <a:t>≤ 12 Mio. EUR</a:t>
+                        <a:t>≤ 15 Mio. EUR</a:t>
                       </a:r>
                     </a:p>
                   </a:txBody>
@@ -9156,7 +9099,7 @@
                           </a:solidFill>
                           <a:latin typeface="Arial"/>
                         </a:rPr>
-                        <a:t>≤ 20 Mio. EUR</a:t>
+                        <a:t>≤ 25 Mio. EUR</a:t>
                       </a:r>
                     </a:p>
                   </a:txBody>
@@ -9174,7 +9117,7 @@
                           </a:solidFill>
                           <a:latin typeface="Arial"/>
                         </a:rPr>
-                        <a:t>≤ 40 Mio. EUR</a:t>
+                        <a:t>≤ 50 Mio. EUR</a:t>
                       </a:r>
                     </a:p>
                   </a:txBody>
@@ -9248,7 +9191,7 @@
                           </a:solidFill>
                           <a:latin typeface="Arial"/>
                         </a:rPr>
-                        <a:t>&gt; 20 Mio. EUR</a:t>
+                        <a:t>&gt; 25 Mio. EUR</a:t>
                       </a:r>
                     </a:p>
                   </a:txBody>
@@ -9266,7 +9209,7 @@
                           </a:solidFill>
                           <a:latin typeface="Arial"/>
                         </a:rPr>
-                        <a:t>&gt; 40 Mio. EUR</a:t>
+                        <a:t>&gt; 50 Mio. EUR</a:t>
                       </a:r>
                     </a:p>
                   </a:txBody>
@@ -9384,7 +9327,7 @@
                 <a:solidFill>
                   <a:srgbClr val="A0B4D2"/>
                 </a:solidFill>
-                <a:latin typeface="JetBrains Mono"/>
+                <a:latin typeface="Consolas"/>
               </a:rPr>
               <a:t>FKB Campus  ·  M01</a:t>
             </a:r>
@@ -9419,7 +9362,7 @@
                 <a:solidFill>
                   <a:srgbClr val="A0B4D2"/>
                 </a:solidFill>
-                <a:latin typeface="JetBrains Mono"/>
+                <a:latin typeface="Consolas"/>
               </a:rPr>
               <a:t>Übersicht</a:t>
             </a:r>
@@ -9558,7 +9501,7 @@
                 <a:solidFill>
                   <a:srgbClr val="78808C"/>
                 </a:solidFill>
-                <a:latin typeface="JetBrains Mono"/>
+                <a:latin typeface="Consolas"/>
               </a:rPr>
               <a:t>M01  ·  ÜBERSICHT</a:t>
             </a:r>
@@ -9593,7 +9536,7 @@
                 <a:solidFill>
                   <a:srgbClr val="1F2C56"/>
                 </a:solidFill>
-                <a:latin typeface="Source Serif 4"/>
+                <a:latin typeface="Arial"/>
               </a:rPr>
               <a:t>Theorie-Input: Aufbau des HGB-Jahresabschlusses</a:t>
             </a:r>
@@ -10033,7 +9976,7 @@
                 <a:solidFill>
                   <a:srgbClr val="A0B4D2"/>
                 </a:solidFill>
-                <a:latin typeface="JetBrains Mono"/>
+                <a:latin typeface="Consolas"/>
               </a:rPr>
               <a:t>FKB Campus  ·  M01</a:t>
             </a:r>
@@ -10068,7 +10011,7 @@
                 <a:solidFill>
                   <a:srgbClr val="A0B4D2"/>
                 </a:solidFill>
-                <a:latin typeface="JetBrains Mono"/>
+                <a:latin typeface="Consolas"/>
               </a:rPr>
               <a:t>Übersicht</a:t>
             </a:r>

</xml_diff>